<commit_message>
Clarify completed pilot and proposed interview plan
</commit_message>
<xml_diff>
--- a/deliverables/Quanova_Photonic_QML_Interview_Case_Study_20260911.pptx
+++ b/deliverables/Quanova_Photonic_QML_Interview_Case_Study_20260911.pptx
@@ -535,7 +535,7 @@
             <a:pPr/>
             <a:r>
               <a:rPr lang="en-US" dirty="0"/>
-              <a:t>The architecture is deliberately hybrid and small. A frozen OpenCLIP encoder produces image embeddings; PCA is fitted on training data only and reduces each embedding to five values scaled into the phase range from minus pi to pi. Those phases enter a fixed six-mode, two-photon circuit, and postselection converts twenty-one possible outcomes into fifteen conditional probabilities for a linear readout. The trainable part remains classical, so the experiment isolates the contribution of the photonic map without requiring a costly variational loop. Perceval provides the Quandela simulation layer, and its probabilities agree with an independent MerLin implementation to machine precision. That simulator check is complete. A remote QPU subset is the proposed final validation gate and has not yet been executed, so the current evidence must not be described as a hardware result.</a:t>
+              <a:t>The architecture is deliberately hybrid and small. A frozen OpenCLIP encoder produces image embeddings; PCA is fitted on training data only and reduces each embedding to five values scaled into the phase range from minus pi to pi. Those phases enter a fixed six-mode, two-photon circuit, and postselection converts twenty-one possible outcomes into fifteen conditional probabilities for a linear readout. The trainable part remains classical, so the experiment isolates the contribution of the photonic map without requiring a costly variational loop. Perceval provides the primary Quandela simulation layer, and a second implementation path in MerLin reproduces its probabilities to machine precision. Here, independent means a separate code path, not an independent organization or external replication. Both simulator checks are complete. A remote QPU subset is the proposed final validation gate and has not yet been executed, so the current evidence must not be described as a hardware result.</a:t>
             </a:r>
           </a:p>
         </p:txBody>
@@ -595,7 +595,7 @@
             <a:pPr/>
             <a:r>
               <a:rPr lang="en-US" dirty="0"/>
-              <a:t>The feasibility question is narrower than asking whether quantum machine learning is generally better. At the same five-dimensional compressed input and fifteen-dimensional output, can Q1 beat a matched random Fourier feature map and close the gap to stronger nonlinear controls such as ELM and RBF-SVM? Alternatively, can it demonstrate an accuracy, sampling, or resource trade-off with practical value? The benchmark uses paired label budgets of twelve, twenty-four, and forty-eight examples per class, three nested subset seeds, and the same locked outer test fold. Seven model families separate the effects of full embeddings, PCA compression, nonlinear mapping, and output dimension. Hyperparameters are selected using validation macro-F1 only, while map seeds are averaged rather than selected. The continue gate is evidence against strong controls across outer folds or a useful resource trade-off. If Q1 only beats RFF, the stop conclusion is feasibility without utility.</a:t>
+              <a:t>The feasibility question is narrower than asking whether quantum machine learning is generally better. At the same five-dimensional compressed input and fifteen-dimensional output, can Q1 beat a matched random Fourier feature map and close the gap to stronger nonlinear controls such as ELM and RBF-SVM? Alternatively, can it demonstrate an accuracy, sampling, or resource trade-off with practical value? The benchmark uses paired label budgets of twelve, twenty-four, and forty-eight examples per class, three nested subset seeds, and the same locked outer test fold. Seven model families separate the effects of full embeddings, PCA compression, nonlinear mapping, and output dimension. Hyperparameters are selected using validation macro-F1 only, while map seeds are averaged rather than selected. Each selected train-fitted pipeline is evaluated on test once, which produces multiple R1 test evaluations across families, budgets, subsets, and map seeds; those repetitions still share one outer test fold. The continue gate is evidence against strong controls across outer folds or a useful resource trade-off. If Q1 only beats RFF, the stop conclusion is feasibility without utility.</a:t>
             </a:r>
           </a:p>
         </p:txBody>
@@ -655,7 +655,7 @@
             <a:pPr/>
             <a:r>
               <a:rPr lang="en-US" dirty="0"/>
-              <a:t>The twelve-week plan removes uncertainty in stages and delays scarce hardware time until the earlier gates pass. Weeks one and two freeze the data audit, leakage-safe splits, metrics, classical baselines, and stopping criteria. Weeks three and four implement the Perceval circuit and require agreement with an independent simulator before benchmarking. Weeks five and six run the paired model matrix across five outer folds to test whether the ranking generalizes beyond the pilot. Weeks seven and eight introduce finite-shot sampling, photon loss, phase drift, distinguishability, detector effects, and noise-aware training where appropriate. Weeks nine and ten run a frozen remote subset with raw counts and calibration metadata, but only if the simulation and noise gates remain credible. Weeks eleven and twelve replicate on a harder dataset, document resource accounting, and issue a go-or-stop decision memo.</a:t>
+              <a:t>The pilot is pre-study evidence and does not consume the proposed twelve-week project. The dataset audit, frozen protocol, Perceval and MerLin code-path verification, finite-shot check, and fold-zero result are already complete. Weeks one and two therefore begin with replication across all five outer folds. Weeks three and four ablate PCA dimension, circuit design, and measurement choices to select a credible candidate. Weeks five and six test photon loss, phase drift, partial distinguishability, detector effects, and noise-aware training. Weeks seven and eight select and freeze the hardware candidate, preprocessing, shot definition, calibration fields, and evaluation subset. Weeks nine and ten run the remote QPU subset with raw counts and calibration metadata, but only if the prior gates pass. Weeks eleven and twelve replicate on harder data or through an independent evaluation, account for resources, and issue the go-or-stop decision memo. The completed pilot shows that I can execute the workflow; the proposed clock is reserved for evidence that can change the application decision.</a:t>
             </a:r>
           </a:p>
         </p:txBody>
@@ -6499,7 +6499,7 @@
           <p:spPr>
             <a:xfrm>
               <a:off x="4412742" y="4607242"/>
-              <a:ext cx="2140862" cy="264033"/>
+              <a:ext cx="2695331" cy="264033"/>
             </a:xfrm>
             <a:prstGeom prst="rect">
               <a:avLst/>
@@ -6525,7 +6525,7 @@
                   <a:ea typeface="+mn-ea"/>
                   <a:cs typeface="+mn-cs"/>
                 </a:rPr>
-                <a:t>2 · INDEPENDENT CHECK</a:t>
+                <a:t>2 · SECOND IMPLEMENTATION</a:t>
               </a:r>
             </a:p>
           </p:txBody>
@@ -6539,7 +6539,7 @@
           <p:spPr>
             <a:xfrm>
               <a:off x="4408170" y="4891088"/>
-              <a:ext cx="2758859" cy="440055"/>
+              <a:ext cx="3335274" cy="440055"/>
             </a:xfrm>
             <a:prstGeom prst="rect">
               <a:avLst/>
@@ -6565,7 +6565,7 @@
                   <a:ea typeface="+mj-ea"/>
                   <a:cs typeface="+mj-cs"/>
                 </a:rPr>
-                <a:t>MerLin complete</a:t>
+                <a:t>MerLin cross-check</a:t>
               </a:r>
             </a:p>
           </p:txBody>
@@ -7163,9 +7163,9 @@
         <p:grpSpPr>
           <a:xfrm>
             <a:off x="609600" y="2647950"/>
-            <a:ext cx="3511868" cy="2971800"/>
+            <a:ext cx="3352800" cy="2981706"/>
             <a:chOff x="609600" y="2647950"/>
-            <a:chExt cx="3511868" cy="2971800"/>
+            <a:chExt cx="3352800" cy="2981706"/>
           </a:xfrm>
         </p:grpSpPr>
         <p:sp>
@@ -7354,8 +7354,8 @@
           </p:nvSpPr>
           <p:spPr>
             <a:xfrm>
-              <a:off x="830580" y="4067175"/>
-              <a:ext cx="2491740" cy="1179195"/>
+              <a:off x="831342" y="4026218"/>
+              <a:ext cx="2148268" cy="1368933"/>
             </a:xfrm>
             <a:prstGeom prst="rect">
               <a:avLst/>
@@ -7373,11 +7373,11 @@
             <a:p>
               <a:pPr algn="l">
                 <a:lnSpc>
-                  <a:spcPts val="2325"/>
+                  <a:spcPts val="2175"/>
                 </a:lnSpc>
               </a:pPr>
               <a:r>
-                <a:rPr lang="en-US" sz="1500" dirty="0">
+                <a:rPr lang="en-US" sz="1350" dirty="0">
                   <a:solidFill>
                     <a:schemeClr val="dk1"/>
                   </a:solidFill>
@@ -7389,7 +7389,7 @@
               </a:r>
               <a:br/>
               <a:r>
-                <a:rPr lang="en-US" sz="1500" dirty="0">
+                <a:rPr lang="en-US" sz="1350" dirty="0">
                   <a:solidFill>
                     <a:schemeClr val="dk1"/>
                   </a:solidFill>
@@ -7401,7 +7401,7 @@
               </a:r>
               <a:br/>
               <a:r>
-                <a:rPr lang="en-US" sz="1500" dirty="0">
+                <a:rPr lang="en-US" sz="1350" dirty="0">
                   <a:solidFill>
                     <a:schemeClr val="dk1"/>
                   </a:solidFill>
@@ -7413,7 +7413,7 @@
               </a:r>
               <a:br/>
               <a:r>
-                <a:rPr lang="en-US" sz="1500" dirty="0">
+                <a:rPr lang="en-US" sz="1350" dirty="0">
                   <a:solidFill>
                     <a:schemeClr val="dk1"/>
                   </a:solidFill>
@@ -7421,7 +7421,19 @@
                   <a:ea typeface="+mn-ea"/>
                   <a:cs typeface="+mn-cs"/>
                 </a:rPr>
-                <a:t>One locked test evaluation</a:t>
+                <a:t>One test evaluation</a:t>
+              </a:r>
+              <a:br/>
+              <a:r>
+                <a:rPr lang="en-US" sz="1350" dirty="0">
+                  <a:solidFill>
+                    <a:schemeClr val="dk1"/>
+                  </a:solidFill>
+                  <a:latin typeface="+mn-lt"/>
+                  <a:ea typeface="+mn-ea"/>
+                  <a:cs typeface="+mn-cs"/>
+                </a:rPr>
+                <a:t>per selected pipeline</a:t>
               </a:r>
             </a:p>
           </p:txBody>
@@ -7434,8 +7446,8 @@
           </p:nvSpPr>
           <p:spPr>
             <a:xfrm>
-              <a:off x="831342" y="5283518"/>
-              <a:ext cx="3290126" cy="264033"/>
+              <a:off x="832104" y="5394960"/>
+              <a:ext cx="2924556" cy="234696"/>
             </a:xfrm>
             <a:prstGeom prst="rect">
               <a:avLst/>
@@ -7453,7 +7465,7 @@
             <a:p>
               <a:pPr algn="l"/>
               <a:r>
-                <a:rPr lang="en-US" sz="1350" b="1" dirty="0">
+                <a:rPr lang="en-US" sz="1200" b="1" dirty="0">
                   <a:solidFill>
                     <a:schemeClr val="accent3"/>
                   </a:solidFill>
@@ -8464,9 +8476,9 @@
         <p:grpSpPr>
           <a:xfrm>
             <a:off x="594360" y="482918"/>
-            <a:ext cx="11203323" cy="913447"/>
+            <a:ext cx="11851958" cy="913447"/>
             <a:chOff x="594360" y="482918"/>
-            <a:chExt cx="11203323" cy="913447"/>
+            <a:chExt cx="11851958" cy="913447"/>
           </a:xfrm>
         </p:grpSpPr>
         <p:sp>
@@ -8478,7 +8490,7 @@
           <p:spPr>
             <a:xfrm>
               <a:off x="602742" y="482918"/>
-              <a:ext cx="3763571" cy="264033"/>
+              <a:ext cx="5590520" cy="264033"/>
             </a:xfrm>
             <a:prstGeom prst="rect">
               <a:avLst/>
@@ -8504,7 +8516,7 @@
                   <a:ea typeface="+mn-ea"/>
                   <a:cs typeface="+mn-cs"/>
                 </a:rPr>
-                <a:t>APPROACH · TWO TO THREE MONTHS</a:t>
+                <a:t>APPROACH · COMPLETED PILOT → PROPOSED PROJECT</a:t>
               </a:r>
             </a:p>
           </p:txBody>
@@ -8518,7 +8530,7 @@
           <p:spPr>
             <a:xfrm>
               <a:off x="594360" y="809625"/>
-              <a:ext cx="11203323" cy="586740"/>
+              <a:ext cx="11851958" cy="586740"/>
             </a:xfrm>
             <a:prstGeom prst="rect">
               <a:avLst/>
@@ -8544,7 +8556,7 @@
                   <a:ea typeface="+mj-ea"/>
                   <a:cs typeface="+mj-cs"/>
                 </a:rPr>
-                <a:t>A 12-week plan moves from simulation to a decision</a:t>
+                <a:t>The 12-week project starts after the completed pilot</a:t>
               </a:r>
             </a:p>
           </p:txBody>
@@ -8552,27 +8564,144 @@
       </p:grpSp>
       <p:grpSp>
         <p:nvGrpSpPr>
-          <p:cNvPr id="61" name="Group 61"/>
+          <p:cNvPr id="9" name="Group 9"/>
           <p:cNvGrpSpPr/>
           <p:nvPr/>
         </p:nvGrpSpPr>
         <p:grpSpPr>
           <a:xfrm>
-            <a:off x="609600" y="1676400"/>
-            <a:ext cx="11346485" cy="3524250"/>
-            <a:chOff x="609600" y="1676400"/>
-            <a:chExt cx="11346485" cy="3524250"/>
+            <a:off x="609600" y="1390650"/>
+            <a:ext cx="10972800" cy="495300"/>
+            <a:chOff x="609600" y="1390650"/>
+            <a:chExt cx="10972800" cy="495300"/>
           </a:xfrm>
         </p:grpSpPr>
         <p:sp>
           <p:nvSpPr>
-            <p:cNvPr id="6" name="Line 6"/>
+            <p:cNvPr id="6" name="Rectangle 6"/>
             <p:cNvSpPr/>
             <p:nvPr/>
           </p:nvSpPr>
           <p:spPr>
             <a:xfrm>
-              <a:off x="1447800" y="1914525"/>
+              <a:off x="609600" y="1390650"/>
+              <a:ext cx="10972800" cy="495300"/>
+            </a:xfrm>
+            <a:prstGeom prst="rect">
+              <a:avLst/>
+            </a:prstGeom>
+            <a:solidFill>
+              <a:schemeClr val="accent3"/>
+            </a:solidFill>
+            <a:ln>
+              <a:noFill/>
+            </a:ln>
+          </p:spPr>
+        </p:sp>
+        <p:sp>
+          <p:nvSpPr>
+            <p:cNvPr id="7" name="TextBox 7"/>
+            <p:cNvSpPr txBox="1"/>
+            <p:nvPr/>
+          </p:nvSpPr>
+          <p:spPr>
+            <a:xfrm>
+              <a:off x="831342" y="1559242"/>
+              <a:ext cx="2927200" cy="264033"/>
+            </a:xfrm>
+            <a:prstGeom prst="rect">
+              <a:avLst/>
+            </a:prstGeom>
+            <a:noFill/>
+            <a:ln>
+              <a:noFill/>
+            </a:ln>
+          </p:spPr>
+          <p:txBody>
+            <a:bodyPr wrap="none" lIns="0" tIns="0" rIns="0" bIns="0" anchor="t" anchorCtr="0">
+              <a:spAutoFit/>
+            </a:bodyPr>
+            <a:lstStyle/>
+            <a:p>
+              <a:pPr algn="l"/>
+              <a:r>
+                <a:rPr lang="en-US" sz="1350" b="1" dirty="0">
+                  <a:solidFill>
+                    <a:srgbClr val="FFFFFF"/>
+                  </a:solidFill>
+                  <a:latin typeface="+mn-lt"/>
+                  <a:ea typeface="+mn-ea"/>
+                  <a:cs typeface="+mn-cs"/>
+                </a:rPr>
+                <a:t>PRE-STUDY · COMPLETED PILOT</a:t>
+              </a:r>
+            </a:p>
+          </p:txBody>
+        </p:sp>
+        <p:sp>
+          <p:nvSpPr>
+            <p:cNvPr id="8" name="TextBox 8"/>
+            <p:cNvSpPr txBox="1"/>
+            <p:nvPr/>
+          </p:nvSpPr>
+          <p:spPr>
+            <a:xfrm>
+              <a:off x="3726942" y="1559242"/>
+              <a:ext cx="6090095" cy="264033"/>
+            </a:xfrm>
+            <a:prstGeom prst="rect">
+              <a:avLst/>
+            </a:prstGeom>
+            <a:noFill/>
+            <a:ln>
+              <a:noFill/>
+            </a:ln>
+          </p:spPr>
+          <p:txBody>
+            <a:bodyPr wrap="none" lIns="0" tIns="0" rIns="0" bIns="0" anchor="t" anchorCtr="0">
+              <a:spAutoFit/>
+            </a:bodyPr>
+            <a:lstStyle/>
+            <a:p>
+              <a:pPr algn="l"/>
+              <a:r>
+                <a:rPr lang="en-US" sz="1350" dirty="0">
+                  <a:solidFill>
+                    <a:srgbClr val="FBF7EE"/>
+                  </a:solidFill>
+                  <a:latin typeface="+mn-lt"/>
+                  <a:ea typeface="+mn-ea"/>
+                  <a:cs typeface="+mn-cs"/>
+                </a:rPr>
+                <a:t>Data audit · frozen protocol · simulator verification · fold-0 result</a:t>
+              </a:r>
+            </a:p>
+          </p:txBody>
+        </p:sp>
+      </p:grpSp>
+      <p:grpSp>
+        <p:nvGrpSpPr>
+          <p:cNvPr id="66" name="Group 66"/>
+          <p:cNvGrpSpPr/>
+          <p:nvPr/>
+        </p:nvGrpSpPr>
+        <p:grpSpPr>
+          <a:xfrm>
+            <a:off x="609600" y="1924050"/>
+            <a:ext cx="10972800" cy="3467100"/>
+            <a:chOff x="609600" y="1924050"/>
+            <a:chExt cx="10972800" cy="3467100"/>
+          </a:xfrm>
+        </p:grpSpPr>
+        <p:sp>
+          <p:nvSpPr>
+            <p:cNvPr id="10" name="Line 10"/>
+            <p:cNvSpPr/>
+            <p:nvPr/>
+          </p:nvSpPr>
+          <p:spPr>
+            <a:xfrm>
+              <a:off x="1447800" y="2143125"/>
               <a:ext cx="9296400" cy="9525"/>
             </a:xfrm>
             <a:custGeom>
@@ -8602,14 +8731,14 @@
         </p:sp>
         <p:sp>
           <p:nvSpPr>
-            <p:cNvPr id="7" name="Ellipse 7"/>
+            <p:cNvPr id="11" name="Ellipse 11"/>
             <p:cNvSpPr/>
             <p:nvPr/>
           </p:nvSpPr>
           <p:spPr>
             <a:xfrm>
-              <a:off x="1209675" y="1676400"/>
-              <a:ext cx="476250" cy="476250"/>
+              <a:off x="1228725" y="1924050"/>
+              <a:ext cx="438150" cy="438150"/>
             </a:xfrm>
             <a:prstGeom prst="ellipse">
               <a:avLst/>
@@ -8624,13 +8753,13 @@
         </p:sp>
         <p:sp>
           <p:nvSpPr>
-            <p:cNvPr id="8" name="TextBox 8"/>
-            <p:cNvSpPr txBox="1"/>
-            <p:nvPr/>
-          </p:nvSpPr>
-          <p:spPr>
-            <a:xfrm>
-              <a:off x="1283512" y="1835468"/>
+            <p:cNvPr id="12" name="TextBox 12"/>
+            <p:cNvSpPr txBox="1"/>
+            <p:nvPr/>
+          </p:nvSpPr>
+          <p:spPr>
+            <a:xfrm>
+              <a:off x="1283512" y="2064068"/>
               <a:ext cx="328575" cy="264033"/>
             </a:xfrm>
             <a:prstGeom prst="rect">
@@ -8664,14 +8793,14 @@
         </p:sp>
         <p:sp>
           <p:nvSpPr>
-            <p:cNvPr id="9" name="Ellipse 9"/>
+            <p:cNvPr id="13" name="Ellipse 13"/>
             <p:cNvSpPr/>
             <p:nvPr/>
           </p:nvSpPr>
           <p:spPr>
             <a:xfrm>
-              <a:off x="3038475" y="1676400"/>
-              <a:ext cx="476250" cy="476250"/>
+              <a:off x="3057525" y="1924050"/>
+              <a:ext cx="438150" cy="438150"/>
             </a:xfrm>
             <a:prstGeom prst="ellipse">
               <a:avLst/>
@@ -8686,13 +8815,13 @@
         </p:sp>
         <p:sp>
           <p:nvSpPr>
-            <p:cNvPr id="10" name="TextBox 10"/>
-            <p:cNvSpPr txBox="1"/>
-            <p:nvPr/>
-          </p:nvSpPr>
-          <p:spPr>
-            <a:xfrm>
-              <a:off x="3112312" y="1835468"/>
+            <p:cNvPr id="14" name="TextBox 14"/>
+            <p:cNvSpPr txBox="1"/>
+            <p:nvPr/>
+          </p:nvSpPr>
+          <p:spPr>
+            <a:xfrm>
+              <a:off x="3112312" y="2064068"/>
               <a:ext cx="328575" cy="264033"/>
             </a:xfrm>
             <a:prstGeom prst="rect">
@@ -8726,14 +8855,14 @@
         </p:sp>
         <p:sp>
           <p:nvSpPr>
-            <p:cNvPr id="11" name="Ellipse 11"/>
+            <p:cNvPr id="15" name="Ellipse 15"/>
             <p:cNvSpPr/>
             <p:nvPr/>
           </p:nvSpPr>
           <p:spPr>
             <a:xfrm>
-              <a:off x="4867275" y="1676400"/>
-              <a:ext cx="476250" cy="476250"/>
+              <a:off x="4886325" y="1924050"/>
+              <a:ext cx="438150" cy="438150"/>
             </a:xfrm>
             <a:prstGeom prst="ellipse">
               <a:avLst/>
@@ -8748,13 +8877,13 @@
         </p:sp>
         <p:sp>
           <p:nvSpPr>
-            <p:cNvPr id="12" name="TextBox 12"/>
-            <p:cNvSpPr txBox="1"/>
-            <p:nvPr/>
-          </p:nvSpPr>
-          <p:spPr>
-            <a:xfrm>
-              <a:off x="4941112" y="1835468"/>
+            <p:cNvPr id="16" name="TextBox 16"/>
+            <p:cNvSpPr txBox="1"/>
+            <p:nvPr/>
+          </p:nvSpPr>
+          <p:spPr>
+            <a:xfrm>
+              <a:off x="4941112" y="2064068"/>
               <a:ext cx="328575" cy="264033"/>
             </a:xfrm>
             <a:prstGeom prst="rect">
@@ -8788,14 +8917,14 @@
         </p:sp>
         <p:sp>
           <p:nvSpPr>
-            <p:cNvPr id="13" name="Ellipse 13"/>
+            <p:cNvPr id="17" name="Ellipse 17"/>
             <p:cNvSpPr/>
             <p:nvPr/>
           </p:nvSpPr>
           <p:spPr>
             <a:xfrm>
-              <a:off x="6696075" y="1676400"/>
-              <a:ext cx="476250" cy="476250"/>
+              <a:off x="6715125" y="1924050"/>
+              <a:ext cx="438150" cy="438150"/>
             </a:xfrm>
             <a:prstGeom prst="ellipse">
               <a:avLst/>
@@ -8810,13 +8939,13 @@
         </p:sp>
         <p:sp>
           <p:nvSpPr>
-            <p:cNvPr id="14" name="TextBox 14"/>
-            <p:cNvSpPr txBox="1"/>
-            <p:nvPr/>
-          </p:nvSpPr>
-          <p:spPr>
-            <a:xfrm>
-              <a:off x="6769912" y="1835468"/>
+            <p:cNvPr id="18" name="TextBox 18"/>
+            <p:cNvSpPr txBox="1"/>
+            <p:nvPr/>
+          </p:nvSpPr>
+          <p:spPr>
+            <a:xfrm>
+              <a:off x="6769912" y="2064068"/>
               <a:ext cx="328575" cy="264033"/>
             </a:xfrm>
             <a:prstGeom prst="rect">
@@ -8850,14 +8979,14 @@
         </p:sp>
         <p:sp>
           <p:nvSpPr>
-            <p:cNvPr id="15" name="Ellipse 15"/>
+            <p:cNvPr id="19" name="Ellipse 19"/>
             <p:cNvSpPr/>
             <p:nvPr/>
           </p:nvSpPr>
           <p:spPr>
             <a:xfrm>
-              <a:off x="8524875" y="1676400"/>
-              <a:ext cx="476250" cy="476250"/>
+              <a:off x="8543925" y="1924050"/>
+              <a:ext cx="438150" cy="438150"/>
             </a:xfrm>
             <a:prstGeom prst="ellipse">
               <a:avLst/>
@@ -8872,13 +9001,13 @@
         </p:sp>
         <p:sp>
           <p:nvSpPr>
-            <p:cNvPr id="16" name="TextBox 16"/>
-            <p:cNvSpPr txBox="1"/>
-            <p:nvPr/>
-          </p:nvSpPr>
-          <p:spPr>
-            <a:xfrm>
-              <a:off x="8546236" y="1835468"/>
+            <p:cNvPr id="20" name="TextBox 20"/>
+            <p:cNvSpPr txBox="1"/>
+            <p:nvPr/>
+          </p:nvSpPr>
+          <p:spPr>
+            <a:xfrm>
+              <a:off x="8546236" y="2064068"/>
               <a:ext cx="433528" cy="264033"/>
             </a:xfrm>
             <a:prstGeom prst="rect">
@@ -8912,14 +9041,14 @@
         </p:sp>
         <p:sp>
           <p:nvSpPr>
-            <p:cNvPr id="17" name="Ellipse 17"/>
+            <p:cNvPr id="21" name="Ellipse 21"/>
             <p:cNvSpPr/>
             <p:nvPr/>
           </p:nvSpPr>
           <p:spPr>
             <a:xfrm>
-              <a:off x="10353675" y="1676400"/>
-              <a:ext cx="476250" cy="476250"/>
+              <a:off x="10372725" y="1924050"/>
+              <a:ext cx="438150" cy="438150"/>
             </a:xfrm>
             <a:prstGeom prst="ellipse">
               <a:avLst/>
@@ -8934,13 +9063,13 @@
         </p:sp>
         <p:sp>
           <p:nvSpPr>
-            <p:cNvPr id="18" name="TextBox 18"/>
-            <p:cNvSpPr txBox="1"/>
-            <p:nvPr/>
-          </p:nvSpPr>
-          <p:spPr>
-            <a:xfrm>
-              <a:off x="10352475" y="1851660"/>
+            <p:cNvPr id="22" name="TextBox 22"/>
+            <p:cNvSpPr txBox="1"/>
+            <p:nvPr/>
+          </p:nvSpPr>
+          <p:spPr>
+            <a:xfrm>
+              <a:off x="10352475" y="2080260"/>
               <a:ext cx="478650" cy="234696"/>
             </a:xfrm>
             <a:prstGeom prst="rect">
@@ -8974,14 +9103,14 @@
         </p:sp>
         <p:sp>
           <p:nvSpPr>
-            <p:cNvPr id="19" name="Rectangle 19"/>
+            <p:cNvPr id="23" name="Rectangle 23"/>
             <p:cNvSpPr/>
             <p:nvPr/>
           </p:nvSpPr>
           <p:spPr>
             <a:xfrm>
-              <a:off x="609600" y="2343150"/>
-              <a:ext cx="1676400" cy="2857500"/>
+              <a:off x="609600" y="2495550"/>
+              <a:ext cx="1676400" cy="2895600"/>
             </a:xfrm>
             <a:prstGeom prst="rect">
               <a:avLst/>
@@ -8996,14 +9125,14 @@
         </p:sp>
         <p:sp>
           <p:nvSpPr>
-            <p:cNvPr id="20" name="TextBox 20"/>
-            <p:cNvSpPr txBox="1"/>
-            <p:nvPr/>
-          </p:nvSpPr>
-          <p:spPr>
-            <a:xfrm>
-              <a:off x="755142" y="2511742"/>
-              <a:ext cx="628673" cy="264033"/>
+            <p:cNvPr id="24" name="TextBox 24"/>
+            <p:cNvSpPr txBox="1"/>
+            <p:nvPr/>
+          </p:nvSpPr>
+          <p:spPr>
+            <a:xfrm>
+              <a:off x="755142" y="2664142"/>
+              <a:ext cx="961354" cy="264033"/>
             </a:xfrm>
             <a:prstGeom prst="rect">
               <a:avLst/>
@@ -9029,21 +9158,21 @@
                   <a:ea typeface="+mn-ea"/>
                   <a:cs typeface="+mn-cs"/>
                 </a:rPr>
-                <a:t>DEFINE</a:t>
-              </a:r>
-            </a:p>
-          </p:txBody>
-        </p:sp>
-        <p:sp>
-          <p:nvSpPr>
-            <p:cNvPr id="21" name="TextBox 21"/>
-            <p:cNvSpPr txBox="1"/>
-            <p:nvPr/>
-          </p:nvSpPr>
-          <p:spPr>
-            <a:xfrm>
-              <a:off x="753237" y="2823686"/>
-              <a:ext cx="1863890" cy="613600"/>
+                <a:t>REPLICATE</a:t>
+              </a:r>
+            </a:p>
+          </p:txBody>
+        </p:sp>
+        <p:sp>
+          <p:nvSpPr>
+            <p:cNvPr id="25" name="TextBox 25"/>
+            <p:cNvSpPr txBox="1"/>
+            <p:nvPr/>
+          </p:nvSpPr>
+          <p:spPr>
+            <a:xfrm>
+              <a:off x="753237" y="2976086"/>
+              <a:ext cx="1233145" cy="613600"/>
             </a:xfrm>
             <a:prstGeom prst="rect">
               <a:avLst/>
@@ -9073,7 +9202,7 @@
                   <a:ea typeface="+mj-ea"/>
                   <a:cs typeface="+mj-cs"/>
                 </a:rPr>
-                <a:t>Data · protocol</a:t>
+                <a:t>Five-fold</a:t>
               </a:r>
               <a:br/>
               <a:r>
@@ -9085,20 +9214,20 @@
                   <a:ea typeface="+mj-ea"/>
                   <a:cs typeface="+mj-cs"/>
                 </a:rPr>
-                <a:t>strong baselines</a:t>
-              </a:r>
-            </a:p>
-          </p:txBody>
-        </p:sp>
-        <p:sp>
-          <p:nvSpPr>
-            <p:cNvPr id="22" name="TextBox 22"/>
-            <p:cNvSpPr txBox="1"/>
-            <p:nvPr/>
-          </p:nvSpPr>
-          <p:spPr>
-            <a:xfrm>
-              <a:off x="755904" y="3594735"/>
+                <a:t>replication</a:t>
+              </a:r>
+            </a:p>
+          </p:txBody>
+        </p:sp>
+        <p:sp>
+          <p:nvSpPr>
+            <p:cNvPr id="26" name="TextBox 26"/>
+            <p:cNvSpPr txBox="1"/>
+            <p:nvPr/>
+          </p:nvSpPr>
+          <p:spPr>
+            <a:xfrm>
+              <a:off x="755904" y="3747135"/>
               <a:ext cx="1051682" cy="234696"/>
             </a:xfrm>
             <a:prstGeom prst="rect">
@@ -9132,14 +9261,14 @@
         </p:sp>
         <p:sp>
           <p:nvSpPr>
-            <p:cNvPr id="23" name="TextBox 23"/>
-            <p:cNvSpPr txBox="1"/>
-            <p:nvPr/>
-          </p:nvSpPr>
-          <p:spPr>
-            <a:xfrm>
-              <a:off x="755523" y="3843814"/>
-              <a:ext cx="1353784" cy="249364"/>
+            <p:cNvPr id="27" name="TextBox 27"/>
+            <p:cNvSpPr txBox="1"/>
+            <p:nvPr/>
+          </p:nvSpPr>
+          <p:spPr>
+            <a:xfrm>
+              <a:off x="755523" y="3996214"/>
+              <a:ext cx="1319182" cy="249364"/>
             </a:xfrm>
             <a:prstGeom prst="rect">
               <a:avLst/>
@@ -9165,20 +9294,20 @@
                   <a:ea typeface="+mn-ea"/>
                   <a:cs typeface="+mn-cs"/>
                 </a:rPr>
-                <a:t>Frozen protocol</a:t>
-              </a:r>
-            </a:p>
-          </p:txBody>
-        </p:sp>
-        <p:sp>
-          <p:nvSpPr>
-            <p:cNvPr id="24" name="TextBox 24"/>
-            <p:cNvSpPr txBox="1"/>
-            <p:nvPr/>
-          </p:nvSpPr>
-          <p:spPr>
-            <a:xfrm>
-              <a:off x="755904" y="4299585"/>
+                <a:t>Fold-level table</a:t>
+              </a:r>
+            </a:p>
+          </p:txBody>
+        </p:sp>
+        <p:sp>
+          <p:nvSpPr>
+            <p:cNvPr id="28" name="TextBox 28"/>
+            <p:cNvSpPr txBox="1"/>
+            <p:nvPr/>
+          </p:nvSpPr>
+          <p:spPr>
+            <a:xfrm>
+              <a:off x="755904" y="4451985"/>
               <a:ext cx="361676" cy="234696"/>
             </a:xfrm>
             <a:prstGeom prst="rect">
@@ -9212,14 +9341,14 @@
         </p:sp>
         <p:sp>
           <p:nvSpPr>
-            <p:cNvPr id="25" name="TextBox 25"/>
-            <p:cNvSpPr txBox="1"/>
-            <p:nvPr/>
-          </p:nvSpPr>
-          <p:spPr>
-            <a:xfrm>
-              <a:off x="755523" y="4548664"/>
-              <a:ext cx="1711706" cy="487490"/>
+            <p:cNvPr id="29" name="TextBox 29"/>
+            <p:cNvSpPr txBox="1"/>
+            <p:nvPr/>
+          </p:nvSpPr>
+          <p:spPr>
+            <a:xfrm>
+              <a:off x="755523" y="4701064"/>
+              <a:ext cx="1142746" cy="487490"/>
             </a:xfrm>
             <a:prstGeom prst="rect">
               <a:avLst/>
@@ -9249,7 +9378,7 @@
                   <a:ea typeface="+mn-ea"/>
                   <a:cs typeface="+mn-cs"/>
                 </a:rPr>
-                <a:t>Leakage-safe splits</a:t>
+                <a:t>Ranking stable</a:t>
               </a:r>
               <a:br/>
               <a:r>
@@ -9261,21 +9390,21 @@
                   <a:ea typeface="+mn-ea"/>
                   <a:cs typeface="+mn-cs"/>
                 </a:rPr>
-                <a:t>and matched controls</a:t>
-              </a:r>
-            </a:p>
-          </p:txBody>
-        </p:sp>
-        <p:sp>
-          <p:nvSpPr>
-            <p:cNvPr id="26" name="Rectangle 26"/>
+                <a:t>across folds</a:t>
+              </a:r>
+            </a:p>
+          </p:txBody>
+        </p:sp>
+        <p:sp>
+          <p:nvSpPr>
+            <p:cNvPr id="30" name="Rectangle 30"/>
             <p:cNvSpPr/>
             <p:nvPr/>
           </p:nvSpPr>
           <p:spPr>
             <a:xfrm>
-              <a:off x="2438400" y="2343150"/>
-              <a:ext cx="1676400" cy="2857500"/>
+              <a:off x="2438400" y="2495550"/>
+              <a:ext cx="1676400" cy="2895600"/>
             </a:xfrm>
             <a:prstGeom prst="rect">
               <a:avLst/>
@@ -9290,14 +9419,14 @@
         </p:sp>
         <p:sp>
           <p:nvSpPr>
-            <p:cNvPr id="27" name="TextBox 27"/>
-            <p:cNvSpPr txBox="1"/>
-            <p:nvPr/>
-          </p:nvSpPr>
-          <p:spPr>
-            <a:xfrm>
-              <a:off x="2583942" y="2511742"/>
-              <a:ext cx="628673" cy="264033"/>
+            <p:cNvPr id="31" name="TextBox 31"/>
+            <p:cNvSpPr txBox="1"/>
+            <p:nvPr/>
+          </p:nvSpPr>
+          <p:spPr>
+            <a:xfrm>
+              <a:off x="2583942" y="2664142"/>
+              <a:ext cx="679079" cy="264033"/>
             </a:xfrm>
             <a:prstGeom prst="rect">
               <a:avLst/>
@@ -9323,21 +9452,339 @@
                   <a:ea typeface="+mn-ea"/>
                   <a:cs typeface="+mn-cs"/>
                 </a:rPr>
-                <a:t>VERIFY</a:t>
-              </a:r>
-            </a:p>
-          </p:txBody>
-        </p:sp>
-        <p:sp>
-          <p:nvSpPr>
-            <p:cNvPr id="28" name="TextBox 28"/>
-            <p:cNvSpPr txBox="1"/>
-            <p:nvPr/>
-          </p:nvSpPr>
-          <p:spPr>
-            <a:xfrm>
-              <a:off x="2582037" y="2823686"/>
-              <a:ext cx="1405166" cy="613600"/>
+                <a:t>ABLATE</a:t>
+              </a:r>
+            </a:p>
+          </p:txBody>
+        </p:sp>
+        <p:sp>
+          <p:nvSpPr>
+            <p:cNvPr id="32" name="TextBox 32"/>
+            <p:cNvSpPr txBox="1"/>
+            <p:nvPr/>
+          </p:nvSpPr>
+          <p:spPr>
+            <a:xfrm>
+              <a:off x="2582418" y="2984182"/>
+              <a:ext cx="1629742" cy="322707"/>
+            </a:xfrm>
+            <a:prstGeom prst="rect">
+              <a:avLst/>
+            </a:prstGeom>
+            <a:noFill/>
+            <a:ln>
+              <a:noFill/>
+            </a:ln>
+          </p:spPr>
+          <p:txBody>
+            <a:bodyPr wrap="none" lIns="0" tIns="0" rIns="0" bIns="0" anchor="t" anchorCtr="0">
+              <a:spAutoFit/>
+            </a:bodyPr>
+            <a:lstStyle/>
+            <a:p>
+              <a:pPr algn="l"/>
+              <a:r>
+                <a:rPr lang="en-US" sz="1650" b="1" dirty="0">
+                  <a:solidFill>
+                    <a:srgbClr val="FFFFFF"/>
+                  </a:solidFill>
+                  <a:latin typeface="+mj-lt"/>
+                  <a:ea typeface="+mj-ea"/>
+                  <a:cs typeface="+mj-cs"/>
+                </a:rPr>
+                <a:t>PCA · circuit</a:t>
+              </a:r>
+            </a:p>
+          </p:txBody>
+        </p:sp>
+        <p:sp>
+          <p:nvSpPr>
+            <p:cNvPr id="33" name="TextBox 33"/>
+            <p:cNvSpPr txBox="1"/>
+            <p:nvPr/>
+          </p:nvSpPr>
+          <p:spPr>
+            <a:xfrm>
+              <a:off x="2583180" y="3276600"/>
+              <a:ext cx="1460221" cy="293370"/>
+            </a:xfrm>
+            <a:prstGeom prst="rect">
+              <a:avLst/>
+            </a:prstGeom>
+            <a:noFill/>
+            <a:ln>
+              <a:noFill/>
+            </a:ln>
+          </p:spPr>
+          <p:txBody>
+            <a:bodyPr wrap="none" lIns="0" tIns="0" rIns="0" bIns="0" anchor="t" anchorCtr="0">
+              <a:spAutoFit/>
+            </a:bodyPr>
+            <a:lstStyle/>
+            <a:p>
+              <a:pPr algn="l"/>
+              <a:r>
+                <a:rPr lang="en-US" sz="1500" b="1" dirty="0">
+                  <a:solidFill>
+                    <a:srgbClr val="FFFFFF"/>
+                  </a:solidFill>
+                  <a:latin typeface="+mj-lt"/>
+                  <a:ea typeface="+mj-ea"/>
+                  <a:cs typeface="+mj-cs"/>
+                </a:rPr>
+                <a:t>measurement</a:t>
+              </a:r>
+            </a:p>
+          </p:txBody>
+        </p:sp>
+        <p:sp>
+          <p:nvSpPr>
+            <p:cNvPr id="34" name="TextBox 34"/>
+            <p:cNvSpPr txBox="1"/>
+            <p:nvPr/>
+          </p:nvSpPr>
+          <p:spPr>
+            <a:xfrm>
+              <a:off x="2584704" y="3747135"/>
+              <a:ext cx="1051682" cy="234696"/>
+            </a:xfrm>
+            <a:prstGeom prst="rect">
+              <a:avLst/>
+            </a:prstGeom>
+            <a:noFill/>
+            <a:ln>
+              <a:noFill/>
+            </a:ln>
+          </p:spPr>
+          <p:txBody>
+            <a:bodyPr wrap="none" lIns="0" tIns="0" rIns="0" bIns="0" anchor="t" anchorCtr="0">
+              <a:spAutoFit/>
+            </a:bodyPr>
+            <a:lstStyle/>
+            <a:p>
+              <a:pPr algn="l"/>
+              <a:r>
+                <a:rPr lang="en-US" sz="1200" b="1" dirty="0">
+                  <a:solidFill>
+                    <a:srgbClr val="B9D0C7"/>
+                  </a:solidFill>
+                  <a:latin typeface="+mn-lt"/>
+                  <a:ea typeface="+mn-ea"/>
+                  <a:cs typeface="+mn-cs"/>
+                </a:rPr>
+                <a:t>DELIVERABLE</a:t>
+              </a:r>
+            </a:p>
+          </p:txBody>
+        </p:sp>
+        <p:sp>
+          <p:nvSpPr>
+            <p:cNvPr id="35" name="TextBox 35"/>
+            <p:cNvSpPr txBox="1"/>
+            <p:nvPr/>
+          </p:nvSpPr>
+          <p:spPr>
+            <a:xfrm>
+              <a:off x="2584323" y="3996214"/>
+              <a:ext cx="1301881" cy="249364"/>
+            </a:xfrm>
+            <a:prstGeom prst="rect">
+              <a:avLst/>
+            </a:prstGeom>
+            <a:noFill/>
+            <a:ln>
+              <a:noFill/>
+            </a:ln>
+          </p:spPr>
+          <p:txBody>
+            <a:bodyPr wrap="none" lIns="0" tIns="0" rIns="0" bIns="0" anchor="t" anchorCtr="0">
+              <a:spAutoFit/>
+            </a:bodyPr>
+            <a:lstStyle/>
+            <a:p>
+              <a:pPr algn="l"/>
+              <a:r>
+                <a:rPr lang="en-US" sz="1280" dirty="0">
+                  <a:solidFill>
+                    <a:srgbClr val="FBF7EE"/>
+                  </a:solidFill>
+                  <a:latin typeface="+mn-lt"/>
+                  <a:ea typeface="+mn-ea"/>
+                  <a:cs typeface="+mn-cs"/>
+                </a:rPr>
+                <a:t>Ablation matrix</a:t>
+              </a:r>
+            </a:p>
+          </p:txBody>
+        </p:sp>
+        <p:sp>
+          <p:nvSpPr>
+            <p:cNvPr id="36" name="TextBox 36"/>
+            <p:cNvSpPr txBox="1"/>
+            <p:nvPr/>
+          </p:nvSpPr>
+          <p:spPr>
+            <a:xfrm>
+              <a:off x="2584704" y="4451985"/>
+              <a:ext cx="361676" cy="234696"/>
+            </a:xfrm>
+            <a:prstGeom prst="rect">
+              <a:avLst/>
+            </a:prstGeom>
+            <a:noFill/>
+            <a:ln>
+              <a:noFill/>
+            </a:ln>
+          </p:spPr>
+          <p:txBody>
+            <a:bodyPr wrap="none" lIns="0" tIns="0" rIns="0" bIns="0" anchor="t" anchorCtr="0">
+              <a:spAutoFit/>
+            </a:bodyPr>
+            <a:lstStyle/>
+            <a:p>
+              <a:pPr algn="l"/>
+              <a:r>
+                <a:rPr lang="en-US" sz="1200" b="1" dirty="0">
+                  <a:solidFill>
+                    <a:srgbClr val="B9D0C7"/>
+                  </a:solidFill>
+                  <a:latin typeface="+mn-lt"/>
+                  <a:ea typeface="+mn-ea"/>
+                  <a:cs typeface="+mn-cs"/>
+                </a:rPr>
+                <a:t>EXIT</a:t>
+              </a:r>
+            </a:p>
+          </p:txBody>
+        </p:sp>
+        <p:sp>
+          <p:nvSpPr>
+            <p:cNvPr id="37" name="TextBox 37"/>
+            <p:cNvSpPr txBox="1"/>
+            <p:nvPr/>
+          </p:nvSpPr>
+          <p:spPr>
+            <a:xfrm>
+              <a:off x="2584323" y="4701064"/>
+              <a:ext cx="1394714" cy="487490"/>
+            </a:xfrm>
+            <a:prstGeom prst="rect">
+              <a:avLst/>
+            </a:prstGeom>
+            <a:noFill/>
+            <a:ln>
+              <a:noFill/>
+            </a:ln>
+          </p:spPr>
+          <p:txBody>
+            <a:bodyPr wrap="none" lIns="0" tIns="0" rIns="0" bIns="0" anchor="t" anchorCtr="0">
+              <a:spAutoFit/>
+            </a:bodyPr>
+            <a:lstStyle/>
+            <a:p>
+              <a:pPr algn="l">
+                <a:lnSpc>
+                  <a:spcPts val="1875"/>
+                </a:lnSpc>
+              </a:pPr>
+              <a:r>
+                <a:rPr lang="en-US" sz="1280" dirty="0">
+                  <a:solidFill>
+                    <a:srgbClr val="FBF7EE"/>
+                  </a:solidFill>
+                  <a:latin typeface="+mn-lt"/>
+                  <a:ea typeface="+mn-ea"/>
+                  <a:cs typeface="+mn-cs"/>
+                </a:rPr>
+                <a:t>Candidate beats</a:t>
+              </a:r>
+              <a:br/>
+              <a:r>
+                <a:rPr lang="en-US" sz="1280" dirty="0">
+                  <a:solidFill>
+                    <a:srgbClr val="FBF7EE"/>
+                  </a:solidFill>
+                  <a:latin typeface="+mn-lt"/>
+                  <a:ea typeface="+mn-ea"/>
+                  <a:cs typeface="+mn-cs"/>
+                </a:rPr>
+                <a:t>matched controls</a:t>
+              </a:r>
+            </a:p>
+          </p:txBody>
+        </p:sp>
+        <p:sp>
+          <p:nvSpPr>
+            <p:cNvPr id="38" name="Rectangle 38"/>
+            <p:cNvSpPr/>
+            <p:nvPr/>
+          </p:nvSpPr>
+          <p:spPr>
+            <a:xfrm>
+              <a:off x="4267200" y="2495550"/>
+              <a:ext cx="1676400" cy="2895600"/>
+            </a:xfrm>
+            <a:prstGeom prst="rect">
+              <a:avLst/>
+            </a:prstGeom>
+            <a:solidFill>
+              <a:schemeClr val="lt2"/>
+            </a:solidFill>
+            <a:ln>
+              <a:noFill/>
+            </a:ln>
+          </p:spPr>
+        </p:sp>
+        <p:sp>
+          <p:nvSpPr>
+            <p:cNvPr id="39" name="TextBox 39"/>
+            <p:cNvSpPr txBox="1"/>
+            <p:nvPr/>
+          </p:nvSpPr>
+          <p:spPr>
+            <a:xfrm>
+              <a:off x="4412742" y="2664142"/>
+              <a:ext cx="558104" cy="264033"/>
+            </a:xfrm>
+            <a:prstGeom prst="rect">
+              <a:avLst/>
+            </a:prstGeom>
+            <a:noFill/>
+            <a:ln>
+              <a:noFill/>
+            </a:ln>
+          </p:spPr>
+          <p:txBody>
+            <a:bodyPr wrap="none" lIns="0" tIns="0" rIns="0" bIns="0" anchor="t" anchorCtr="0">
+              <a:spAutoFit/>
+            </a:bodyPr>
+            <a:lstStyle/>
+            <a:p>
+              <a:pPr algn="l"/>
+              <a:r>
+                <a:rPr lang="en-US" sz="1350" b="1" dirty="0">
+                  <a:solidFill>
+                    <a:schemeClr val="accent2"/>
+                  </a:solidFill>
+                  <a:latin typeface="+mn-lt"/>
+                  <a:ea typeface="+mn-ea"/>
+                  <a:cs typeface="+mn-cs"/>
+                </a:rPr>
+                <a:t>NOISE</a:t>
+              </a:r>
+            </a:p>
+          </p:txBody>
+        </p:sp>
+        <p:sp>
+          <p:nvSpPr>
+            <p:cNvPr id="40" name="TextBox 40"/>
+            <p:cNvSpPr txBox="1"/>
+            <p:nvPr/>
+          </p:nvSpPr>
+          <p:spPr>
+            <a:xfrm>
+              <a:off x="4410837" y="2976086"/>
+              <a:ext cx="1359294" cy="613600"/>
             </a:xfrm>
             <a:prstGeom prst="rect">
               <a:avLst/>
@@ -9361,38 +9808,38 @@
               <a:r>
                 <a:rPr lang="en-US" sz="1720" b="1" dirty="0">
                   <a:solidFill>
-                    <a:srgbClr val="FFFFFF"/>
+                    <a:schemeClr val="accent1"/>
                   </a:solidFill>
                   <a:latin typeface="+mj-lt"/>
                   <a:ea typeface="+mj-ea"/>
                   <a:cs typeface="+mj-cs"/>
                 </a:rPr>
-                <a:t>Perceval</a:t>
+                <a:t>Loss · drift</a:t>
               </a:r>
               <a:br/>
               <a:r>
                 <a:rPr lang="en-US" sz="1720" b="1" dirty="0">
                   <a:solidFill>
-                    <a:srgbClr val="FFFFFF"/>
+                    <a:schemeClr val="accent1"/>
                   </a:solidFill>
                   <a:latin typeface="+mj-lt"/>
                   <a:ea typeface="+mj-ea"/>
                   <a:cs typeface="+mj-cs"/>
                 </a:rPr>
-                <a:t>cross-check</a:t>
-              </a:r>
-            </a:p>
-          </p:txBody>
-        </p:sp>
-        <p:sp>
-          <p:nvSpPr>
-            <p:cNvPr id="29" name="TextBox 29"/>
-            <p:cNvSpPr txBox="1"/>
-            <p:nvPr/>
-          </p:nvSpPr>
-          <p:spPr>
-            <a:xfrm>
-              <a:off x="2584704" y="3594735"/>
+                <a:t>detectors</a:t>
+              </a:r>
+            </a:p>
+          </p:txBody>
+        </p:sp>
+        <p:sp>
+          <p:nvSpPr>
+            <p:cNvPr id="41" name="TextBox 41"/>
+            <p:cNvSpPr txBox="1"/>
+            <p:nvPr/>
+          </p:nvSpPr>
+          <p:spPr>
+            <a:xfrm>
+              <a:off x="4413504" y="3747135"/>
               <a:ext cx="1051682" cy="234696"/>
             </a:xfrm>
             <a:prstGeom prst="rect">
@@ -9413,7 +9860,7 @@
               <a:r>
                 <a:rPr lang="en-US" sz="1200" b="1" dirty="0">
                   <a:solidFill>
-                    <a:srgbClr val="B9D0C7"/>
+                    <a:schemeClr val="accent3"/>
                   </a:solidFill>
                   <a:latin typeface="+mn-lt"/>
                   <a:ea typeface="+mn-ea"/>
@@ -9426,14 +9873,14 @@
         </p:sp>
         <p:sp>
           <p:nvSpPr>
-            <p:cNvPr id="30" name="TextBox 30"/>
-            <p:cNvSpPr txBox="1"/>
-            <p:nvPr/>
-          </p:nvSpPr>
-          <p:spPr>
-            <a:xfrm>
-              <a:off x="2584323" y="3843814"/>
-              <a:ext cx="1543007" cy="249364"/>
+            <p:cNvPr id="42" name="TextBox 42"/>
+            <p:cNvSpPr txBox="1"/>
+            <p:nvPr/>
+          </p:nvSpPr>
+          <p:spPr>
+            <a:xfrm>
+              <a:off x="4413123" y="3996214"/>
+              <a:ext cx="1586555" cy="249364"/>
             </a:xfrm>
             <a:prstGeom prst="rect">
               <a:avLst/>
@@ -9453,26 +9900,26 @@
               <a:r>
                 <a:rPr lang="en-US" sz="1280" dirty="0">
                   <a:solidFill>
-                    <a:srgbClr val="FBF7EE"/>
-                  </a:solidFill>
-                  <a:latin typeface="+mn-lt"/>
-                  <a:ea typeface="+mn-ea"/>
-                  <a:cs typeface="+mn-cs"/>
-                </a:rPr>
-                <a:t>Verified simulator</a:t>
-              </a:r>
-            </a:p>
-          </p:txBody>
-        </p:sp>
-        <p:sp>
-          <p:nvSpPr>
-            <p:cNvPr id="31" name="TextBox 31"/>
-            <p:cNvSpPr txBox="1"/>
-            <p:nvPr/>
-          </p:nvSpPr>
-          <p:spPr>
-            <a:xfrm>
-              <a:off x="2584704" y="4299585"/>
+                    <a:schemeClr val="dk1"/>
+                  </a:solidFill>
+                  <a:latin typeface="+mn-lt"/>
+                  <a:ea typeface="+mn-ea"/>
+                  <a:cs typeface="+mn-cs"/>
+                </a:rPr>
+                <a:t>Robustness curves</a:t>
+              </a:r>
+            </a:p>
+          </p:txBody>
+        </p:sp>
+        <p:sp>
+          <p:nvSpPr>
+            <p:cNvPr id="43" name="TextBox 43"/>
+            <p:cNvSpPr txBox="1"/>
+            <p:nvPr/>
+          </p:nvSpPr>
+          <p:spPr>
+            <a:xfrm>
+              <a:off x="4413504" y="4451985"/>
               <a:ext cx="361676" cy="234696"/>
             </a:xfrm>
             <a:prstGeom prst="rect">
@@ -9493,7 +9940,7 @@
               <a:r>
                 <a:rPr lang="en-US" sz="1200" b="1" dirty="0">
                   <a:solidFill>
-                    <a:srgbClr val="B9D0C7"/>
+                    <a:schemeClr val="accent2"/>
                   </a:solidFill>
                   <a:latin typeface="+mn-lt"/>
                   <a:ea typeface="+mn-ea"/>
@@ -9506,14 +9953,14 @@
         </p:sp>
         <p:sp>
           <p:nvSpPr>
-            <p:cNvPr id="32" name="TextBox 32"/>
-            <p:cNvSpPr txBox="1"/>
-            <p:nvPr/>
-          </p:nvSpPr>
-          <p:spPr>
-            <a:xfrm>
-              <a:off x="2584323" y="4548664"/>
-              <a:ext cx="1492250" cy="487490"/>
+            <p:cNvPr id="44" name="TextBox 44"/>
+            <p:cNvSpPr txBox="1"/>
+            <p:nvPr/>
+          </p:nvSpPr>
+          <p:spPr>
+            <a:xfrm>
+              <a:off x="4413123" y="4701064"/>
+              <a:ext cx="1370330" cy="487490"/>
             </a:xfrm>
             <a:prstGeom prst="rect">
               <a:avLst/>
@@ -9537,45 +9984,45 @@
               <a:r>
                 <a:rPr lang="en-US" sz="1280" dirty="0">
                   <a:solidFill>
-                    <a:srgbClr val="FBF7EE"/>
-                  </a:solidFill>
-                  <a:latin typeface="+mn-lt"/>
-                  <a:ea typeface="+mn-ea"/>
-                  <a:cs typeface="+mn-cs"/>
-                </a:rPr>
-                <a:t>Probability model</a:t>
+                    <a:schemeClr val="dk1"/>
+                  </a:solidFill>
+                  <a:latin typeface="+mn-lt"/>
+                  <a:ea typeface="+mn-ea"/>
+                  <a:cs typeface="+mn-cs"/>
+                </a:rPr>
+                <a:t>No collapse under</a:t>
               </a:r>
               <a:br/>
               <a:r>
                 <a:rPr lang="en-US" sz="1280" dirty="0">
                   <a:solidFill>
-                    <a:srgbClr val="FBF7EE"/>
-                  </a:solidFill>
-                  <a:latin typeface="+mn-lt"/>
-                  <a:ea typeface="+mn-ea"/>
-                  <a:cs typeface="+mn-cs"/>
-                </a:rPr>
-                <a:t>agrees numerically</a:t>
-              </a:r>
-            </a:p>
-          </p:txBody>
-        </p:sp>
-        <p:sp>
-          <p:nvSpPr>
-            <p:cNvPr id="33" name="Rectangle 33"/>
+                    <a:schemeClr val="dk1"/>
+                  </a:solidFill>
+                  <a:latin typeface="+mn-lt"/>
+                  <a:ea typeface="+mn-ea"/>
+                  <a:cs typeface="+mn-cs"/>
+                </a:rPr>
+                <a:t>credible noise</a:t>
+              </a:r>
+            </a:p>
+          </p:txBody>
+        </p:sp>
+        <p:sp>
+          <p:nvSpPr>
+            <p:cNvPr id="45" name="Rectangle 45"/>
             <p:cNvSpPr/>
             <p:nvPr/>
           </p:nvSpPr>
           <p:spPr>
             <a:xfrm>
-              <a:off x="4267200" y="2343150"/>
-              <a:ext cx="1676400" cy="2857500"/>
+              <a:off x="6096000" y="2495550"/>
+              <a:ext cx="1676400" cy="2895600"/>
             </a:xfrm>
             <a:prstGeom prst="rect">
               <a:avLst/>
             </a:prstGeom>
             <a:solidFill>
-              <a:schemeClr val="lt2"/>
+              <a:schemeClr val="accent1"/>
             </a:solidFill>
             <a:ln>
               <a:noFill/>
@@ -9584,14 +10031,14 @@
         </p:sp>
         <p:sp>
           <p:nvSpPr>
-            <p:cNvPr id="34" name="TextBox 34"/>
-            <p:cNvSpPr txBox="1"/>
-            <p:nvPr/>
-          </p:nvSpPr>
-          <p:spPr>
-            <a:xfrm>
-              <a:off x="4412742" y="2511742"/>
-              <a:ext cx="1052086" cy="264033"/>
+            <p:cNvPr id="46" name="TextBox 46"/>
+            <p:cNvSpPr txBox="1"/>
+            <p:nvPr/>
+          </p:nvSpPr>
+          <p:spPr>
+            <a:xfrm>
+              <a:off x="6241542" y="2664142"/>
+              <a:ext cx="679079" cy="264033"/>
             </a:xfrm>
             <a:prstGeom prst="rect">
               <a:avLst/>
@@ -9611,27 +10058,27 @@
               <a:r>
                 <a:rPr lang="en-US" sz="1350" b="1" dirty="0">
                   <a:solidFill>
-                    <a:schemeClr val="accent2"/>
-                  </a:solidFill>
-                  <a:latin typeface="+mn-lt"/>
-                  <a:ea typeface="+mn-ea"/>
-                  <a:cs typeface="+mn-cs"/>
-                </a:rPr>
-                <a:t>BENCHMARK</a:t>
-              </a:r>
-            </a:p>
-          </p:txBody>
-        </p:sp>
-        <p:sp>
-          <p:nvSpPr>
-            <p:cNvPr id="35" name="TextBox 35"/>
-            <p:cNvSpPr txBox="1"/>
-            <p:nvPr/>
-          </p:nvSpPr>
-          <p:spPr>
-            <a:xfrm>
-              <a:off x="4410837" y="2823686"/>
-              <a:ext cx="1531315" cy="613600"/>
+                    <a:srgbClr val="B9D0C7"/>
+                  </a:solidFill>
+                  <a:latin typeface="+mn-lt"/>
+                  <a:ea typeface="+mn-ea"/>
+                  <a:cs typeface="+mn-cs"/>
+                </a:rPr>
+                <a:t>FREEZE</a:t>
+              </a:r>
+            </a:p>
+          </p:txBody>
+        </p:sp>
+        <p:sp>
+          <p:nvSpPr>
+            <p:cNvPr id="47" name="TextBox 47"/>
+            <p:cNvSpPr txBox="1"/>
+            <p:nvPr/>
+          </p:nvSpPr>
+          <p:spPr>
+            <a:xfrm>
+              <a:off x="6239637" y="2976086"/>
+              <a:ext cx="1095527" cy="613600"/>
             </a:xfrm>
             <a:prstGeom prst="rect">
               <a:avLst/>
@@ -9655,38 +10102,38 @@
               <a:r>
                 <a:rPr lang="en-US" sz="1720" b="1" dirty="0">
                   <a:solidFill>
-                    <a:schemeClr val="accent1"/>
+                    <a:srgbClr val="FFFFFF"/>
                   </a:solidFill>
                   <a:latin typeface="+mj-lt"/>
                   <a:ea typeface="+mj-ea"/>
                   <a:cs typeface="+mj-cs"/>
                 </a:rPr>
-                <a:t>Five folds</a:t>
+                <a:t>Hardware</a:t>
               </a:r>
               <a:br/>
               <a:r>
                 <a:rPr lang="en-US" sz="1720" b="1" dirty="0">
                   <a:solidFill>
-                    <a:schemeClr val="accent1"/>
+                    <a:srgbClr val="FFFFFF"/>
                   </a:solidFill>
                   <a:latin typeface="+mj-lt"/>
                   <a:ea typeface="+mj-ea"/>
                   <a:cs typeface="+mj-cs"/>
                 </a:rPr>
-                <a:t>paired models</a:t>
-              </a:r>
-            </a:p>
-          </p:txBody>
-        </p:sp>
-        <p:sp>
-          <p:nvSpPr>
-            <p:cNvPr id="36" name="TextBox 36"/>
-            <p:cNvSpPr txBox="1"/>
-            <p:nvPr/>
-          </p:nvSpPr>
-          <p:spPr>
-            <a:xfrm>
-              <a:off x="4413504" y="3594735"/>
+                <a:t>candidate</a:t>
+              </a:r>
+            </a:p>
+          </p:txBody>
+        </p:sp>
+        <p:sp>
+          <p:nvSpPr>
+            <p:cNvPr id="48" name="TextBox 48"/>
+            <p:cNvSpPr txBox="1"/>
+            <p:nvPr/>
+          </p:nvSpPr>
+          <p:spPr>
+            <a:xfrm>
+              <a:off x="6242304" y="3747135"/>
               <a:ext cx="1051682" cy="234696"/>
             </a:xfrm>
             <a:prstGeom prst="rect">
@@ -9707,7 +10154,7 @@
               <a:r>
                 <a:rPr lang="en-US" sz="1200" b="1" dirty="0">
                   <a:solidFill>
-                    <a:schemeClr val="accent3"/>
+                    <a:srgbClr val="B9D0C7"/>
                   </a:solidFill>
                   <a:latin typeface="+mn-lt"/>
                   <a:ea typeface="+mn-ea"/>
@@ -9720,14 +10167,14 @@
         </p:sp>
         <p:sp>
           <p:nvSpPr>
-            <p:cNvPr id="37" name="TextBox 37"/>
-            <p:cNvSpPr txBox="1"/>
-            <p:nvPr/>
-          </p:nvSpPr>
-          <p:spPr>
-            <a:xfrm>
-              <a:off x="4413123" y="3843814"/>
-              <a:ext cx="1319182" cy="249364"/>
+            <p:cNvPr id="49" name="TextBox 49"/>
+            <p:cNvSpPr txBox="1"/>
+            <p:nvPr/>
+          </p:nvSpPr>
+          <p:spPr>
+            <a:xfrm>
+              <a:off x="6241923" y="3996214"/>
+              <a:ext cx="1354199" cy="249364"/>
             </a:xfrm>
             <a:prstGeom prst="rect">
               <a:avLst/>
@@ -9747,26 +10194,26 @@
               <a:r>
                 <a:rPr lang="en-US" sz="1280" dirty="0">
                   <a:solidFill>
-                    <a:schemeClr val="dk1"/>
-                  </a:solidFill>
-                  <a:latin typeface="+mn-lt"/>
-                  <a:ea typeface="+mn-ea"/>
-                  <a:cs typeface="+mn-cs"/>
-                </a:rPr>
-                <a:t>Fold-level table</a:t>
-              </a:r>
-            </a:p>
-          </p:txBody>
-        </p:sp>
-        <p:sp>
-          <p:nvSpPr>
-            <p:cNvPr id="38" name="TextBox 38"/>
-            <p:cNvSpPr txBox="1"/>
-            <p:nvPr/>
-          </p:nvSpPr>
-          <p:spPr>
-            <a:xfrm>
-              <a:off x="4413504" y="4299585"/>
+                    <a:srgbClr val="FBF7EE"/>
+                  </a:solidFill>
+                  <a:latin typeface="+mn-lt"/>
+                  <a:ea typeface="+mn-ea"/>
+                  <a:cs typeface="+mn-cs"/>
+                </a:rPr>
+                <a:t>Frozen run spec</a:t>
+              </a:r>
+            </a:p>
+          </p:txBody>
+        </p:sp>
+        <p:sp>
+          <p:nvSpPr>
+            <p:cNvPr id="50" name="TextBox 50"/>
+            <p:cNvSpPr txBox="1"/>
+            <p:nvPr/>
+          </p:nvSpPr>
+          <p:spPr>
+            <a:xfrm>
+              <a:off x="6242304" y="4451985"/>
               <a:ext cx="361676" cy="234696"/>
             </a:xfrm>
             <a:prstGeom prst="rect">
@@ -9787,7 +10234,7 @@
               <a:r>
                 <a:rPr lang="en-US" sz="1200" b="1" dirty="0">
                   <a:solidFill>
-                    <a:schemeClr val="accent2"/>
+                    <a:srgbClr val="B9D0C7"/>
                   </a:solidFill>
                   <a:latin typeface="+mn-lt"/>
                   <a:ea typeface="+mn-ea"/>
@@ -9800,14 +10247,14 @@
         </p:sp>
         <p:sp>
           <p:nvSpPr>
-            <p:cNvPr id="39" name="TextBox 39"/>
-            <p:cNvSpPr txBox="1"/>
-            <p:nvPr/>
-          </p:nvSpPr>
-          <p:spPr>
-            <a:xfrm>
-              <a:off x="4413123" y="4548664"/>
-              <a:ext cx="1687322" cy="487490"/>
+            <p:cNvPr id="51" name="TextBox 51"/>
+            <p:cNvSpPr txBox="1"/>
+            <p:nvPr/>
+          </p:nvSpPr>
+          <p:spPr>
+            <a:xfrm>
+              <a:off x="6242304" y="4709160"/>
+              <a:ext cx="1414272" cy="472821"/>
             </a:xfrm>
             <a:prstGeom prst="rect">
               <a:avLst/>
@@ -9829,335 +10276,41 @@
                 </a:lnSpc>
               </a:pPr>
               <a:r>
-                <a:rPr lang="en-US" sz="1280" dirty="0">
-                  <a:solidFill>
-                    <a:schemeClr val="dk1"/>
-                  </a:solidFill>
-                  <a:latin typeface="+mn-lt"/>
-                  <a:ea typeface="+mn-ea"/>
-                  <a:cs typeface="+mn-cs"/>
-                </a:rPr>
-                <a:t>Stable paired ranking</a:t>
+                <a:rPr lang="en-US" sz="1200" dirty="0">
+                  <a:solidFill>
+                    <a:srgbClr val="FBF7EE"/>
+                  </a:solidFill>
+                  <a:latin typeface="+mn-lt"/>
+                  <a:ea typeface="+mn-ea"/>
+                  <a:cs typeface="+mn-cs"/>
+                </a:rPr>
+                <a:t>Shots · calibration</a:t>
               </a:r>
               <a:br/>
               <a:r>
-                <a:rPr lang="en-US" sz="1280" dirty="0">
-                  <a:solidFill>
-                    <a:schemeClr val="dk1"/>
-                  </a:solidFill>
-                  <a:latin typeface="+mn-lt"/>
-                  <a:ea typeface="+mn-ea"/>
-                  <a:cs typeface="+mn-cs"/>
-                </a:rPr>
-                <a:t>across outer folds</a:t>
-              </a:r>
-            </a:p>
-          </p:txBody>
-        </p:sp>
-        <p:sp>
-          <p:nvSpPr>
-            <p:cNvPr id="40" name="Rectangle 40"/>
+                <a:rPr lang="en-US" sz="1200" dirty="0">
+                  <a:solidFill>
+                    <a:srgbClr val="FBF7EE"/>
+                  </a:solidFill>
+                  <a:latin typeface="+mn-lt"/>
+                  <a:ea typeface="+mn-ea"/>
+                  <a:cs typeface="+mn-cs"/>
+                </a:rPr>
+                <a:t>metadata locked</a:t>
+              </a:r>
+            </a:p>
+          </p:txBody>
+        </p:sp>
+        <p:sp>
+          <p:nvSpPr>
+            <p:cNvPr id="52" name="Rectangle 52"/>
             <p:cNvSpPr/>
             <p:nvPr/>
           </p:nvSpPr>
           <p:spPr>
             <a:xfrm>
-              <a:off x="6096000" y="2343150"/>
-              <a:ext cx="1676400" cy="2857500"/>
-            </a:xfrm>
-            <a:prstGeom prst="rect">
-              <a:avLst/>
-            </a:prstGeom>
-            <a:solidFill>
-              <a:schemeClr val="accent1"/>
-            </a:solidFill>
-            <a:ln>
-              <a:noFill/>
-            </a:ln>
-          </p:spPr>
-        </p:sp>
-        <p:sp>
-          <p:nvSpPr>
-            <p:cNvPr id="41" name="TextBox 41"/>
-            <p:cNvSpPr txBox="1"/>
-            <p:nvPr/>
-          </p:nvSpPr>
-          <p:spPr>
-            <a:xfrm>
-              <a:off x="6241542" y="2511742"/>
-              <a:ext cx="1183142" cy="264033"/>
-            </a:xfrm>
-            <a:prstGeom prst="rect">
-              <a:avLst/>
-            </a:prstGeom>
-            <a:noFill/>
-            <a:ln>
-              <a:noFill/>
-            </a:ln>
-          </p:spPr>
-          <p:txBody>
-            <a:bodyPr wrap="none" lIns="0" tIns="0" rIns="0" bIns="0" anchor="t" anchorCtr="0">
-              <a:spAutoFit/>
-            </a:bodyPr>
-            <a:lstStyle/>
-            <a:p>
-              <a:pPr algn="l"/>
-              <a:r>
-                <a:rPr lang="en-US" sz="1350" b="1" dirty="0">
-                  <a:solidFill>
-                    <a:srgbClr val="B9D0C7"/>
-                  </a:solidFill>
-                  <a:latin typeface="+mn-lt"/>
-                  <a:ea typeface="+mn-ea"/>
-                  <a:cs typeface="+mn-cs"/>
-                </a:rPr>
-                <a:t>STRESS TEST</a:t>
-              </a:r>
-            </a:p>
-          </p:txBody>
-        </p:sp>
-        <p:sp>
-          <p:nvSpPr>
-            <p:cNvPr id="42" name="TextBox 42"/>
-            <p:cNvSpPr txBox="1"/>
-            <p:nvPr/>
-          </p:nvSpPr>
-          <p:spPr>
-            <a:xfrm>
-              <a:off x="6239637" y="2823686"/>
-              <a:ext cx="1359294" cy="613600"/>
-            </a:xfrm>
-            <a:prstGeom prst="rect">
-              <a:avLst/>
-            </a:prstGeom>
-            <a:noFill/>
-            <a:ln>
-              <a:noFill/>
-            </a:ln>
-          </p:spPr>
-          <p:txBody>
-            <a:bodyPr wrap="none" lIns="0" tIns="0" rIns="0" bIns="0" anchor="t" anchorCtr="0">
-              <a:spAutoFit/>
-            </a:bodyPr>
-            <a:lstStyle/>
-            <a:p>
-              <a:pPr algn="l">
-                <a:lnSpc>
-                  <a:spcPts val="2175"/>
-                </a:lnSpc>
-              </a:pPr>
-              <a:r>
-                <a:rPr lang="en-US" sz="1720" b="1" dirty="0">
-                  <a:solidFill>
-                    <a:srgbClr val="FFFFFF"/>
-                  </a:solidFill>
-                  <a:latin typeface="+mj-lt"/>
-                  <a:ea typeface="+mj-ea"/>
-                  <a:cs typeface="+mj-cs"/>
-                </a:rPr>
-                <a:t>Finite shots</a:t>
-              </a:r>
-              <a:br/>
-              <a:r>
-                <a:rPr lang="en-US" sz="1720" b="1" dirty="0">
-                  <a:solidFill>
-                    <a:srgbClr val="FFFFFF"/>
-                  </a:solidFill>
-                  <a:latin typeface="+mj-lt"/>
-                  <a:ea typeface="+mj-ea"/>
-                  <a:cs typeface="+mj-cs"/>
-                </a:rPr>
-                <a:t>noise model</a:t>
-              </a:r>
-            </a:p>
-          </p:txBody>
-        </p:sp>
-        <p:sp>
-          <p:nvSpPr>
-            <p:cNvPr id="43" name="TextBox 43"/>
-            <p:cNvSpPr txBox="1"/>
-            <p:nvPr/>
-          </p:nvSpPr>
-          <p:spPr>
-            <a:xfrm>
-              <a:off x="6242304" y="3594735"/>
-              <a:ext cx="1051682" cy="234696"/>
-            </a:xfrm>
-            <a:prstGeom prst="rect">
-              <a:avLst/>
-            </a:prstGeom>
-            <a:noFill/>
-            <a:ln>
-              <a:noFill/>
-            </a:ln>
-          </p:spPr>
-          <p:txBody>
-            <a:bodyPr wrap="none" lIns="0" tIns="0" rIns="0" bIns="0" anchor="t" anchorCtr="0">
-              <a:spAutoFit/>
-            </a:bodyPr>
-            <a:lstStyle/>
-            <a:p>
-              <a:pPr algn="l"/>
-              <a:r>
-                <a:rPr lang="en-US" sz="1200" b="1" dirty="0">
-                  <a:solidFill>
-                    <a:srgbClr val="B9D0C7"/>
-                  </a:solidFill>
-                  <a:latin typeface="+mn-lt"/>
-                  <a:ea typeface="+mn-ea"/>
-                  <a:cs typeface="+mn-cs"/>
-                </a:rPr>
-                <a:t>DELIVERABLE</a:t>
-              </a:r>
-            </a:p>
-          </p:txBody>
-        </p:sp>
-        <p:sp>
-          <p:nvSpPr>
-            <p:cNvPr id="44" name="TextBox 44"/>
-            <p:cNvSpPr txBox="1"/>
-            <p:nvPr/>
-          </p:nvSpPr>
-          <p:spPr>
-            <a:xfrm>
-              <a:off x="6241923" y="3843814"/>
-              <a:ext cx="1586555" cy="249364"/>
-            </a:xfrm>
-            <a:prstGeom prst="rect">
-              <a:avLst/>
-            </a:prstGeom>
-            <a:noFill/>
-            <a:ln>
-              <a:noFill/>
-            </a:ln>
-          </p:spPr>
-          <p:txBody>
-            <a:bodyPr wrap="none" lIns="0" tIns="0" rIns="0" bIns="0" anchor="t" anchorCtr="0">
-              <a:spAutoFit/>
-            </a:bodyPr>
-            <a:lstStyle/>
-            <a:p>
-              <a:pPr algn="l"/>
-              <a:r>
-                <a:rPr lang="en-US" sz="1280" dirty="0">
-                  <a:solidFill>
-                    <a:srgbClr val="FBF7EE"/>
-                  </a:solidFill>
-                  <a:latin typeface="+mn-lt"/>
-                  <a:ea typeface="+mn-ea"/>
-                  <a:cs typeface="+mn-cs"/>
-                </a:rPr>
-                <a:t>Robustness curves</a:t>
-              </a:r>
-            </a:p>
-          </p:txBody>
-        </p:sp>
-        <p:sp>
-          <p:nvSpPr>
-            <p:cNvPr id="45" name="TextBox 45"/>
-            <p:cNvSpPr txBox="1"/>
-            <p:nvPr/>
-          </p:nvSpPr>
-          <p:spPr>
-            <a:xfrm>
-              <a:off x="6242304" y="4299585"/>
-              <a:ext cx="361676" cy="234696"/>
-            </a:xfrm>
-            <a:prstGeom prst="rect">
-              <a:avLst/>
-            </a:prstGeom>
-            <a:noFill/>
-            <a:ln>
-              <a:noFill/>
-            </a:ln>
-          </p:spPr>
-          <p:txBody>
-            <a:bodyPr wrap="none" lIns="0" tIns="0" rIns="0" bIns="0" anchor="t" anchorCtr="0">
-              <a:spAutoFit/>
-            </a:bodyPr>
-            <a:lstStyle/>
-            <a:p>
-              <a:pPr algn="l"/>
-              <a:r>
-                <a:rPr lang="en-US" sz="1200" b="1" dirty="0">
-                  <a:solidFill>
-                    <a:srgbClr val="B9D0C7"/>
-                  </a:solidFill>
-                  <a:latin typeface="+mn-lt"/>
-                  <a:ea typeface="+mn-ea"/>
-                  <a:cs typeface="+mn-cs"/>
-                </a:rPr>
-                <a:t>EXIT</a:t>
-              </a:r>
-            </a:p>
-          </p:txBody>
-        </p:sp>
-        <p:sp>
-          <p:nvSpPr>
-            <p:cNvPr id="46" name="TextBox 46"/>
-            <p:cNvSpPr txBox="1"/>
-            <p:nvPr/>
-          </p:nvSpPr>
-          <p:spPr>
-            <a:xfrm>
-              <a:off x="6241923" y="4548664"/>
-              <a:ext cx="1370330" cy="487490"/>
-            </a:xfrm>
-            <a:prstGeom prst="rect">
-              <a:avLst/>
-            </a:prstGeom>
-            <a:noFill/>
-            <a:ln>
-              <a:noFill/>
-            </a:ln>
-          </p:spPr>
-          <p:txBody>
-            <a:bodyPr wrap="none" lIns="0" tIns="0" rIns="0" bIns="0" anchor="t" anchorCtr="0">
-              <a:spAutoFit/>
-            </a:bodyPr>
-            <a:lstStyle/>
-            <a:p>
-              <a:pPr algn="l">
-                <a:lnSpc>
-                  <a:spcPts val="1875"/>
-                </a:lnSpc>
-              </a:pPr>
-              <a:r>
-                <a:rPr lang="en-US" sz="1280" dirty="0">
-                  <a:solidFill>
-                    <a:srgbClr val="FBF7EE"/>
-                  </a:solidFill>
-                  <a:latin typeface="+mn-lt"/>
-                  <a:ea typeface="+mn-ea"/>
-                  <a:cs typeface="+mn-cs"/>
-                </a:rPr>
-                <a:t>No collapse under</a:t>
-              </a:r>
-              <a:br/>
-              <a:r>
-                <a:rPr lang="en-US" sz="1280" dirty="0">
-                  <a:solidFill>
-                    <a:srgbClr val="FBF7EE"/>
-                  </a:solidFill>
-                  <a:latin typeface="+mn-lt"/>
-                  <a:ea typeface="+mn-ea"/>
-                  <a:cs typeface="+mn-cs"/>
-                </a:rPr>
-                <a:t>credible noise</a:t>
-              </a:r>
-            </a:p>
-          </p:txBody>
-        </p:sp>
-        <p:sp>
-          <p:nvSpPr>
-            <p:cNvPr id="47" name="Rectangle 47"/>
-            <p:cNvSpPr/>
-            <p:nvPr/>
-          </p:nvSpPr>
-          <p:spPr>
-            <a:xfrm>
-              <a:off x="7924800" y="2343150"/>
-              <a:ext cx="1676400" cy="2857500"/>
+              <a:off x="7924800" y="2495550"/>
+              <a:ext cx="1676400" cy="2895600"/>
             </a:xfrm>
             <a:prstGeom prst="rect">
               <a:avLst/>
@@ -10177,14 +10330,14 @@
         </p:sp>
         <p:sp>
           <p:nvSpPr>
-            <p:cNvPr id="48" name="TextBox 48"/>
-            <p:cNvSpPr txBox="1"/>
-            <p:nvPr/>
-          </p:nvSpPr>
-          <p:spPr>
-            <a:xfrm>
-              <a:off x="8070342" y="2511742"/>
-              <a:ext cx="1445255" cy="264033"/>
+            <p:cNvPr id="53" name="TextBox 53"/>
+            <p:cNvSpPr txBox="1"/>
+            <p:nvPr/>
+          </p:nvSpPr>
+          <p:spPr>
+            <a:xfrm>
+              <a:off x="8070342" y="2664142"/>
+              <a:ext cx="890786" cy="264033"/>
             </a:xfrm>
             <a:prstGeom prst="rect">
               <a:avLst/>
@@ -10210,20 +10363,20 @@
                   <a:ea typeface="+mn-ea"/>
                   <a:cs typeface="+mn-cs"/>
                 </a:rPr>
-                <a:t>HARDWARE GATE</a:t>
-              </a:r>
-            </a:p>
-          </p:txBody>
-        </p:sp>
-        <p:sp>
-          <p:nvSpPr>
-            <p:cNvPr id="49" name="TextBox 49"/>
-            <p:cNvSpPr txBox="1"/>
-            <p:nvPr/>
-          </p:nvSpPr>
-          <p:spPr>
-            <a:xfrm>
-              <a:off x="8068437" y="2823686"/>
+                <a:t>QPU GATE</a:t>
+              </a:r>
+            </a:p>
+          </p:txBody>
+        </p:sp>
+        <p:sp>
+          <p:nvSpPr>
+            <p:cNvPr id="54" name="TextBox 54"/>
+            <p:cNvSpPr txBox="1"/>
+            <p:nvPr/>
+          </p:nvSpPr>
+          <p:spPr>
+            <a:xfrm>
+              <a:off x="8068437" y="2976086"/>
               <a:ext cx="1645996" cy="613600"/>
             </a:xfrm>
             <a:prstGeom prst="rect">
@@ -10273,13 +10426,13 @@
         </p:sp>
         <p:sp>
           <p:nvSpPr>
-            <p:cNvPr id="50" name="TextBox 50"/>
-            <p:cNvSpPr txBox="1"/>
-            <p:nvPr/>
-          </p:nvSpPr>
-          <p:spPr>
-            <a:xfrm>
-              <a:off x="8071104" y="3594735"/>
+            <p:cNvPr id="55" name="TextBox 55"/>
+            <p:cNvSpPr txBox="1"/>
+            <p:nvPr/>
+          </p:nvSpPr>
+          <p:spPr>
+            <a:xfrm>
+              <a:off x="8071104" y="3747135"/>
               <a:ext cx="1051682" cy="234696"/>
             </a:xfrm>
             <a:prstGeom prst="rect">
@@ -10313,13 +10466,13 @@
         </p:sp>
         <p:sp>
           <p:nvSpPr>
-            <p:cNvPr id="51" name="TextBox 51"/>
-            <p:cNvSpPr txBox="1"/>
-            <p:nvPr/>
-          </p:nvSpPr>
-          <p:spPr>
-            <a:xfrm>
-              <a:off x="8070723" y="3843814"/>
+            <p:cNvPr id="56" name="TextBox 56"/>
+            <p:cNvSpPr txBox="1"/>
+            <p:nvPr/>
+          </p:nvSpPr>
+          <p:spPr>
+            <a:xfrm>
+              <a:off x="8070723" y="3996214"/>
               <a:ext cx="1456863" cy="249364"/>
             </a:xfrm>
             <a:prstGeom prst="rect">
@@ -10353,13 +10506,13 @@
         </p:sp>
         <p:sp>
           <p:nvSpPr>
-            <p:cNvPr id="52" name="TextBox 52"/>
-            <p:cNvSpPr txBox="1"/>
-            <p:nvPr/>
-          </p:nvSpPr>
-          <p:spPr>
-            <a:xfrm>
-              <a:off x="8071104" y="4299585"/>
+            <p:cNvPr id="57" name="TextBox 57"/>
+            <p:cNvSpPr txBox="1"/>
+            <p:nvPr/>
+          </p:nvSpPr>
+          <p:spPr>
+            <a:xfrm>
+              <a:off x="8071104" y="4451985"/>
               <a:ext cx="361676" cy="234696"/>
             </a:xfrm>
             <a:prstGeom prst="rect">
@@ -10393,14 +10546,14 @@
         </p:sp>
         <p:sp>
           <p:nvSpPr>
-            <p:cNvPr id="53" name="TextBox 53"/>
-            <p:cNvSpPr txBox="1"/>
-            <p:nvPr/>
-          </p:nvSpPr>
-          <p:spPr>
-            <a:xfrm>
-              <a:off x="8070723" y="4548664"/>
-              <a:ext cx="1597914" cy="487490"/>
+            <p:cNvPr id="58" name="TextBox 58"/>
+            <p:cNvSpPr txBox="1"/>
+            <p:nvPr/>
+          </p:nvSpPr>
+          <p:spPr>
+            <a:xfrm>
+              <a:off x="8070723" y="4701064"/>
+              <a:ext cx="1321562" cy="487490"/>
             </a:xfrm>
             <a:prstGeom prst="rect">
               <a:avLst/>
@@ -10430,7 +10583,7 @@
                   <a:ea typeface="+mn-ea"/>
                   <a:cs typeface="+mn-cs"/>
                 </a:rPr>
-                <a:t>Run only after prior</a:t>
+                <a:t>Run only after</a:t>
               </a:r>
               <a:br/>
               <a:r>
@@ -10442,21 +10595,21 @@
                   <a:ea typeface="+mn-ea"/>
                   <a:cs typeface="+mn-cs"/>
                 </a:rPr>
-                <a:t>gates pass</a:t>
-              </a:r>
-            </a:p>
-          </p:txBody>
-        </p:sp>
-        <p:sp>
-          <p:nvSpPr>
-            <p:cNvPr id="54" name="Rectangle 54"/>
+                <a:t>prior gates pass</a:t>
+              </a:r>
+            </a:p>
+          </p:txBody>
+        </p:sp>
+        <p:sp>
+          <p:nvSpPr>
+            <p:cNvPr id="59" name="Rectangle 59"/>
             <p:cNvSpPr/>
             <p:nvPr/>
           </p:nvSpPr>
           <p:spPr>
             <a:xfrm>
-              <a:off x="9753600" y="2343150"/>
-              <a:ext cx="1828800" cy="2857500"/>
+              <a:off x="9753600" y="2495550"/>
+              <a:ext cx="1828800" cy="2895600"/>
             </a:xfrm>
             <a:prstGeom prst="rect">
               <a:avLst/>
@@ -10471,13 +10624,13 @@
         </p:sp>
         <p:sp>
           <p:nvSpPr>
-            <p:cNvPr id="55" name="TextBox 55"/>
-            <p:cNvSpPr txBox="1"/>
-            <p:nvPr/>
-          </p:nvSpPr>
-          <p:spPr>
-            <a:xfrm>
-              <a:off x="9899142" y="2511742"/>
+            <p:cNvPr id="60" name="TextBox 60"/>
+            <p:cNvSpPr txBox="1"/>
+            <p:nvPr/>
+          </p:nvSpPr>
+          <p:spPr>
+            <a:xfrm>
+              <a:off x="9899142" y="2664142"/>
               <a:ext cx="628673" cy="264033"/>
             </a:xfrm>
             <a:prstGeom prst="rect">
@@ -10511,14 +10664,14 @@
         </p:sp>
         <p:sp>
           <p:nvSpPr>
-            <p:cNvPr id="56" name="TextBox 56"/>
-            <p:cNvSpPr txBox="1"/>
-            <p:nvPr/>
-          </p:nvSpPr>
-          <p:spPr>
-            <a:xfrm>
-              <a:off x="9897237" y="2823686"/>
-              <a:ext cx="2058848" cy="613600"/>
+            <p:cNvPr id="61" name="TextBox 61"/>
+            <p:cNvSpPr txBox="1"/>
+            <p:nvPr/>
+          </p:nvSpPr>
+          <p:spPr>
+            <a:xfrm>
+              <a:off x="9897237" y="2976086"/>
+              <a:ext cx="1347826" cy="613600"/>
             </a:xfrm>
             <a:prstGeom prst="rect">
               <a:avLst/>
@@ -10560,20 +10713,20 @@
                   <a:ea typeface="+mj-ea"/>
                   <a:cs typeface="+mj-cs"/>
                 </a:rPr>
-                <a:t>report · go / stop</a:t>
-              </a:r>
-            </a:p>
-          </p:txBody>
-        </p:sp>
-        <p:sp>
-          <p:nvSpPr>
-            <p:cNvPr id="57" name="TextBox 57"/>
-            <p:cNvSpPr txBox="1"/>
-            <p:nvPr/>
-          </p:nvSpPr>
-          <p:spPr>
-            <a:xfrm>
-              <a:off x="9899904" y="3594735"/>
+                <a:t>replication</a:t>
+              </a:r>
+            </a:p>
+          </p:txBody>
+        </p:sp>
+        <p:sp>
+          <p:nvSpPr>
+            <p:cNvPr id="62" name="TextBox 62"/>
+            <p:cNvSpPr txBox="1"/>
+            <p:nvPr/>
+          </p:nvSpPr>
+          <p:spPr>
+            <a:xfrm>
+              <a:off x="9899904" y="3747135"/>
               <a:ext cx="1051682" cy="234696"/>
             </a:xfrm>
             <a:prstGeom prst="rect">
@@ -10607,13 +10760,13 @@
         </p:sp>
         <p:sp>
           <p:nvSpPr>
-            <p:cNvPr id="58" name="TextBox 58"/>
-            <p:cNvSpPr txBox="1"/>
-            <p:nvPr/>
-          </p:nvSpPr>
-          <p:spPr>
-            <a:xfrm>
-              <a:off x="9899523" y="3843814"/>
+            <p:cNvPr id="63" name="TextBox 63"/>
+            <p:cNvSpPr txBox="1"/>
+            <p:nvPr/>
+          </p:nvSpPr>
+          <p:spPr>
+            <a:xfrm>
+              <a:off x="9899523" y="3996214"/>
               <a:ext cx="1190214" cy="249364"/>
             </a:xfrm>
             <a:prstGeom prst="rect">
@@ -10647,13 +10800,13 @@
         </p:sp>
         <p:sp>
           <p:nvSpPr>
-            <p:cNvPr id="59" name="TextBox 59"/>
-            <p:cNvSpPr txBox="1"/>
-            <p:nvPr/>
-          </p:nvSpPr>
-          <p:spPr>
-            <a:xfrm>
-              <a:off x="9899904" y="4299585"/>
+            <p:cNvPr id="64" name="TextBox 64"/>
+            <p:cNvSpPr txBox="1"/>
+            <p:nvPr/>
+          </p:nvSpPr>
+          <p:spPr>
+            <a:xfrm>
+              <a:off x="9899904" y="4451985"/>
               <a:ext cx="361676" cy="234696"/>
             </a:xfrm>
             <a:prstGeom prst="rect">
@@ -10687,13 +10840,13 @@
         </p:sp>
         <p:sp>
           <p:nvSpPr>
-            <p:cNvPr id="60" name="TextBox 60"/>
-            <p:cNvSpPr txBox="1"/>
-            <p:nvPr/>
-          </p:nvSpPr>
-          <p:spPr>
-            <a:xfrm>
-              <a:off x="9899523" y="4548664"/>
+            <p:cNvPr id="65" name="TextBox 65"/>
+            <p:cNvSpPr txBox="1"/>
+            <p:nvPr/>
+          </p:nvSpPr>
+          <p:spPr>
+            <a:xfrm>
+              <a:off x="9899523" y="4701064"/>
               <a:ext cx="1467866" cy="487490"/>
             </a:xfrm>
             <a:prstGeom prst="rect">
@@ -10744,28 +10897,28 @@
       </p:grpSp>
       <p:grpSp>
         <p:nvGrpSpPr>
-          <p:cNvPr id="64" name="Group 64"/>
+          <p:cNvPr id="69" name="Group 69"/>
           <p:cNvGrpSpPr/>
           <p:nvPr/>
         </p:nvGrpSpPr>
         <p:grpSpPr>
           <a:xfrm>
-            <a:off x="609600" y="5467350"/>
-            <a:ext cx="10972800" cy="590550"/>
-            <a:chOff x="609600" y="5467350"/>
-            <a:chExt cx="10972800" cy="590550"/>
+            <a:off x="609600" y="5562600"/>
+            <a:ext cx="10972800" cy="495300"/>
+            <a:chOff x="609600" y="5562600"/>
+            <a:chExt cx="10972800" cy="495300"/>
           </a:xfrm>
         </p:grpSpPr>
         <p:sp>
           <p:nvSpPr>
-            <p:cNvPr id="62" name="Rectangle 62"/>
+            <p:cNvPr id="67" name="Rectangle 67"/>
             <p:cNvSpPr/>
             <p:nvPr/>
           </p:nvSpPr>
           <p:spPr>
             <a:xfrm>
-              <a:off x="609600" y="5467350"/>
-              <a:ext cx="10972800" cy="590550"/>
+              <a:off x="609600" y="5562600"/>
+              <a:ext cx="10972800" cy="495300"/>
             </a:xfrm>
             <a:prstGeom prst="rect">
               <a:avLst/>
@@ -10780,14 +10933,14 @@
         </p:sp>
         <p:sp>
           <p:nvSpPr>
-            <p:cNvPr id="63" name="TextBox 63"/>
-            <p:cNvSpPr txBox="1"/>
-            <p:nvPr/>
-          </p:nvSpPr>
-          <p:spPr>
-            <a:xfrm>
-              <a:off x="1960873" y="5676900"/>
-              <a:ext cx="8270253" cy="293370"/>
+            <p:cNvPr id="68" name="TextBox 68"/>
+            <p:cNvSpPr txBox="1"/>
+            <p:nvPr/>
+          </p:nvSpPr>
+          <p:spPr>
+            <a:xfrm>
+              <a:off x="1897153" y="5715000"/>
+              <a:ext cx="8397694" cy="293370"/>
             </a:xfrm>
             <a:prstGeom prst="rect">
               <a:avLst/>
@@ -10813,7 +10966,7 @@
                   <a:ea typeface="+mn-ea"/>
                   <a:cs typeface="+mn-cs"/>
                 </a:rPr>
-                <a:t>Each block removes one uncertainty before scarce hardware time is requested.</a:t>
+                <a:t>The 12-week clock begins with five-fold replication—not work already completed.</a:t>
               </a:r>
             </a:p>
           </p:txBody>
@@ -10821,7 +10974,7 @@
       </p:grpSp>
       <p:grpSp>
         <p:nvGrpSpPr>
-          <p:cNvPr id="66" name="Group 66"/>
+          <p:cNvPr id="71" name="Group 71"/>
           <p:cNvGrpSpPr/>
           <p:nvPr/>
         </p:nvGrpSpPr>
@@ -10835,7 +10988,7 @@
         </p:grpSpPr>
         <p:sp>
           <p:nvSpPr>
-            <p:cNvPr id="65" name="TextBox 65"/>
+            <p:cNvPr id="70" name="TextBox 70"/>
             <p:cNvSpPr txBox="1"/>
             <p:nvPr/>
           </p:nvSpPr>

</xml_diff>

<commit_message>
Polish interview deck and add rehearsal materials
</commit_message>
<xml_diff>
--- a/deliverables/Quanova_Photonic_QML_Interview_Case_Study_20260911.pptx
+++ b/deliverables/Quanova_Photonic_QML_Interview_Case_Study_20260911.pptx
@@ -355,7 +355,7 @@
             <a:pPr/>
             <a:r>
               <a:rPr lang="en-US" dirty="0"/>
-              <a:t>I would investigate few-label industrial defect inspection using a fixed photonic reservoir. I chose it because expert defect labels are costly, photonic interference provides a compact nonlinear feature map, and the idea can be evaluated rigorously within twelve weeks using public data, matched classical controls, and a staged path from simulation to hardware. I have already completed a de-risking pilot: Q1 reached a macro-F1 of 0.8708 at forty-eight labels per class. That result shows useful signal, but it does not yet show a practical or quantum advantage.</a:t>
+              <a:t>Good afternoon. I am Nguyen Ngo Nhat Nam, and I would investigate few-label industrial defect inspection using a fixed photonic reservoir. I chose it for three reasons: expert defect labels are costly, photonic interference offers a compact nonlinear feature map, and the idea can be evaluated rigorously within twelve weeks using public data, matched controls, and a staged path from simulation to hardware. I have already completed a de-risking pilot. Q1 reached 0.8708 macro-F1 at forty-eight labels per class. That is useful signal, but it is not evidence of practical or quantum advantage.</a:t>
             </a:r>
           </a:p>
         </p:txBody>
@@ -415,7 +415,7 @@
             <a:pPr/>
             <a:r>
               <a:rPr lang="en-US" dirty="0"/>
-              <a:t>My application choice is few-label industrial defect inspection with a fixed photonic reservoir. I chose it because label scarcity is real, the compact phase-encoded feature map fits Quandela’s simulator-to-hardware workflow, and the evidence can be produced within twelve weeks. The completed pilot says the idea is technically feasible and scientifically interesting, but it has not demonstrated practical advantage. I would continue only through the predefined next gates: Q1 must close the ELM or RBF gap across outer folds, or demonstrate a resource trade-off that matters in practice. If it continues to beat only RFF while the strong controls remain better, I would report feasibility without utility and stop. The repository linked here contains the protocol, implementation, results, and presentation artifacts needed to reproduce that decision.</a:t>
+              <a:t>My recommendation is to continue this application only through a decision-changing test. The case is worth testing because label scarcity is real, the compact circuit fits Quandela’s simulator-to-hardware path, and the pilot proves that the workflow can be executed. It has not yet demonstrated practical advantage. I would continue only if the preregistered accuracy-parity or label-efficiency gate passes. If Q1 still beats only RFF while ELM and RBF-SVM remain stronger, I would report technical feasibility without utility and stop. The repository link contains the protocol, implementation, results, and presentation artifacts needed to audit that decision. Thank you.</a:t>
             </a:r>
           </a:p>
         </p:txBody>
@@ -475,7 +475,7 @@
             <a:pPr/>
             <a:r>
               <a:rPr lang="en-US" dirty="0"/>
-              <a:t>The application begins with a real operational constraint: industrial inspection images can be plentiful, while reliable defect labels require scarce expert time. That makes performance at twelve, twenty-four, and forty-eight labels per class a meaningful and measurable target. NEU-CLS provides 1,800 audited images across six balanced surface-defect classes, so the first feasibility study can run without waiting for proprietary data collection. The evaluation also has a clear failure mode. One exact duplicate pair, Pa_101 and Pa_105, stays in the same group, and the pilot test fold holds sixty images per class with no sample or duplicate-group overlap. This gives the project three properties I want in a short research assignment: a real need, accessible evidence, and a quantitative decision metric.</a:t>
+              <a:t>The operational constraint is label scarcity. Inspection images may be plentiful, but reliable defect labels consume expert time. Performance at twelve, twenty-four, and forty-eight labels per class is therefore a meaningful target. NEU-CLS gives 1,800 audited images across six balanced steel-surface defect classes, so the study can start without waiting for proprietary data. The evaluation also has a clear failure mode: the exact duplicate pair Pa_101 and Pa_105 remains in one group, and the pilot test fold contains sixty images per class with no sample or duplicate-group overlap. This gives a real need, accessible evidence, and a quantitative decision.</a:t>
             </a:r>
           </a:p>
         </p:txBody>
@@ -535,7 +535,7 @@
             <a:pPr/>
             <a:r>
               <a:rPr lang="en-US" dirty="0"/>
-              <a:t>The architecture is deliberately hybrid and small. A frozen OpenCLIP encoder produces image embeddings; PCA is fitted on training data only and reduces each embedding to five values scaled into the phase range from minus pi to pi. Those phases enter a fixed six-mode, two-photon circuit, and postselection converts twenty-one possible outcomes into fifteen conditional probabilities for a linear readout. The trainable part remains classical, so the experiment isolates the contribution of the photonic map without requiring a costly variational loop. Perceval provides the primary Quandela simulation layer, and a second implementation path in MerLin reproduces its probabilities to machine precision. Here, independent means a separate code path, not an independent organization or external replication. Both simulator checks are complete. A remote QPU subset is the proposed final validation gate and has not yet been executed, so the current evidence must not be described as a hardware result.</a:t>
+              <a:t>The architecture is deliberately hybrid and small. A frozen OpenCLIP encoder produces an image embedding. Principal component analysis is fitted on training data only and reduces it to five values scaled from minus pi to pi. Those phases enter a fixed six-mode, two-photon circuit. Postselection turns twenty-one possible outcomes into fifteen conditional probabilities for a linear readout. Only the readout is trained, which isolates the feature map and avoids a costly variational loop. Perceval is the primary simulation layer. A second implementation in MerLin reproduces the probabilities to machine precision. That is a separate code path inside the same ecosystem, not external replication. Both checks are complete. Remote QPU execution remains a proposed final gate, subject to access.</a:t>
             </a:r>
           </a:p>
         </p:txBody>
@@ -595,7 +595,7 @@
             <a:pPr/>
             <a:r>
               <a:rPr lang="en-US" dirty="0"/>
-              <a:t>The feasibility question is narrower than asking whether quantum machine learning is generally better. At the same five-dimensional compressed input and fifteen-dimensional output, can Q1 beat a matched random Fourier feature map and close the gap to stronger nonlinear controls such as ELM and RBF-SVM? Alternatively, can it demonstrate an accuracy, sampling, or resource trade-off with practical value? The benchmark uses paired label budgets of twelve, twenty-four, and forty-eight examples per class, three nested subset seeds, and the same locked outer test fold. Seven model families separate the effects of full embeddings, PCA compression, nonlinear mapping, and output dimension. Hyperparameters are selected using validation macro-F1 only, while map seeds are averaged rather than selected. Each selected train-fitted pipeline is evaluated on test once, which produces multiple R1 test evaluations across families, budgets, subsets, and map seeds; those repetitions still share one outer test fold. The continue gate is evidence against strong controls across outer folds or a useful resource trade-off. If Q1 only beats RFF, the stop conclusion is feasibility without utility.</a:t>
+              <a:t>The question is specific: from the same PCA-five input, can Q1’s fifteen-dimensional photonic features beat matched fifteen-dimensional controls and approach PCA-five RBF-SVM? RFF means random Fourier features; ELM means extreme learning machine; and RBF-SVM means radial-basis-function support vector machine. The protocol uses nested label budgets, validation-only selection, averaged map seeds, and one test evaluation per selected fitted pipeline. I would preregister two pass routes. Accuracy passes if Q1 is within 0.02 macro-F1 of PCA-five RBF-SVM on at least four of five outer folds. Resource value passes if Q1 with twenty-four labels per class reaches the forty-eight-label RBF-SVM within 0.02 on at least four folds, using at most two thousand launched shots per image and an acceptance rate of at least 0.70. If neither route passes, or Q1 fails both matched controls on at least four folds, I stop.</a:t>
             </a:r>
           </a:p>
         </p:txBody>
@@ -655,7 +655,7 @@
             <a:pPr/>
             <a:r>
               <a:rPr lang="en-US" dirty="0"/>
-              <a:t>The pilot is pre-study evidence and does not consume the proposed twelve-week project. The dataset audit, frozen protocol, Perceval and MerLin code-path verification, finite-shot check, and fold-zero result are already complete. Weeks one and two therefore begin with replication across all five outer folds. Weeks three and four ablate PCA dimension, circuit design, and measurement choices to select a credible candidate. Weeks five and six test photon loss, phase drift, partial distinguishability, detector effects, and noise-aware training. Weeks seven and eight select and freeze the hardware candidate, preprocessing, shot definition, calibration fields, and evaluation subset. Weeks nine and ten run the remote QPU subset with raw counts and calibration metadata, but only if the prior gates pass. Weeks eleven and twelve replicate on harder data or through an independent evaluation, account for resources, and issue the go-or-stop decision memo. The completed pilot shows that I can execute the workflow; the proposed clock is reserved for evidence that can change the application decision.</a:t>
+              <a:t>The pilot is pre-study evidence; it does not consume the twelve-week project. The dataset audit, frozen protocol, simulator checks, finite-shot test, and fold-zero result are complete. Weeks one and two replicate all five outer folds. Weeks three and four ablate PCA dimension, circuit design, and measurement choices. Weeks five and six add loss, phase drift, partial distinguishability, detector effects, and noise-aware training. Weeks seven and eight select and freeze one hardware candidate, including preprocessing, shot definition, and calibration fields. Weeks nine and ten run a remote QPU subset only if the earlier gates pass. Weeks eleven and twelve use harder data or an independent evaluation, account for resources, and produce a go-or-stop memo.</a:t>
             </a:r>
           </a:p>
         </p:txBody>
@@ -715,7 +715,7 @@
             <a:pPr/>
             <a:r>
               <a:rPr lang="en-US" dirty="0"/>
-              <a:t>The completed pilot provides early evidence rather than the final answer. Q1 macro-F1 rises from 0.7812 at twelve labels per class to 0.7886 at twenty-four and 0.8708 at forty-eight. The upward trend means the photonic feature map contains useful class information. However, the full CLIP linear baseline starts at 0.9242 and reaches 0.9852 at the largest budget. Each point is the mean across three subset seeds, with sample-standard-deviation error bars, but all points reuse one outer test fold. The disciplined interpretation is therefore that Q1 learns useful structure on this pilot, while the current configuration does not justify replacing the full embedding or claiming competitive advantage.</a:t>
+              <a:t>Here is the primary pilot evidence. Q1 rises from 0.7812 at twelve labels per class to 0.7886 at twenty-four and 0.8708 at forty-eight. The upward trend shows that the photonic features contain class information. The full OpenCLIP linear baseline, however, starts at 0.9242 and reaches 0.9852. Each point averages three subset seeds, with sample-standard-deviation error bars, but all points reuse one outer test fold. The correct conclusion is that Q1 learns useful structure on this pilot while the current configuration does not justify replacing the full embedding or claiming an advantage.</a:t>
             </a:r>
           </a:p>
         </p:txBody>
@@ -775,7 +775,7 @@
             <a:pPr/>
             <a:r>
               <a:rPr lang="en-US" dirty="0"/>
-              <a:t>The diagnostic result changes what the next experiment should test. Moving from the full embedding to PCA-five costs the linear baseline 0.1018, 0.0993, and 0.0713 macro-F1 across the three budgets, so important information is lost before the nonlinear map is evaluated. Within the compressed comparison, Q1 beats matched RFF by 0.3133, 0.2238, and 0.2307. It still trails ELM by between roughly 0.02 and 0.04, and trails PCA-five RBF by about 0.05 to 0.06 at every budget. The surviving claim is specific: the photonic map is better than one weak matched random map, but not the stronger nonlinear controls. The next study must therefore vary representation size and circuit design separately rather than attributing the entire gap to photonics.</a:t>
+              <a:t>The diagnosis changes the next experiment. Compressing the full embedding to five principal components costs the linear baseline about 0.07 to 0.10 macro-F1, so information is lost before the nonlinear map is tested. Within the compressed comparison, Q1 beats the locked RFF-fifteen comparator by about 0.22 to 0.31. It still trails ELM by roughly 0.02 to 0.04 and PCA-five RBF-SVM by about 0.05 to 0.06. The surviving claim is narrow: this photonic map is better than one matched random-feature control, but not the stronger nonlinear controls. I would therefore vary representation size and circuit design separately.</a:t>
             </a:r>
           </a:p>
         </p:txBody>
@@ -835,7 +835,7 @@
             <a:pPr/>
             <a:r>
               <a:rPr lang="en-US" dirty="0"/>
-              <a:t>The finite-shot test asks whether sampled output probabilities behave stably enough to support a later hardware comparison. Mean macro-F1 is 0.7662 with five hundred launched shots, 0.7739 with two thousand, and 0.7725 with eight thousand, based on fifteen evaluations at each level. Acceptance remains close to 0.754, and none of the forty-five evaluations suffers a zero-acceptance failure. Increasing shots does not produce a monotonic accuracy recovery, so shot count alone does not close the model gap. This experiment tests sampling and postselection around an ideal-trained readout. It does not yet include photon loss, phase drift, partial distinguishability, detector noise, or noise-aware training, which are explicit tasks in the proposed twelve-week plan.</a:t>
+              <a:t>The finite-shot test asks whether sampled probabilities are stable enough for a later hardware comparison. Macro-F1 is 0.7662 at five hundred launched shots, 0.7739 at two thousand, and 0.7725 at eight thousand. Each shot level contains fifteen evaluations: three map seeds times five sampling seeds. Across all three levels, that is forty-five evaluations on the same outer test fold. Acceptance stays near 0.754, with no zero-acceptance failure. More shots do not recover accuracy monotonically, so shot count alone does not close the gap. This tests sampling around an ideal-trained readout; loss, drift, distinguishability, detectors, and noise-aware training remain future work.</a:t>
             </a:r>
           </a:p>
         </p:txBody>
@@ -895,7 +895,7 @@
             <a:pPr/>
             <a:r>
               <a:rPr lang="en-US" dirty="0"/>
-              <a:t>The current evidence supports a calibrated three-level verdict. Technical feasibility is proven: the pipeline executes, simulator semantics agree independently, and the artifacts are reproducible. Application signal is partially answered: Q1 improves with labels, the paired one-fold ranking is known, and finite-shot sampling is stable in the tested range. Practical utility remains unanswered because we do not yet have five-fold generalization, realistic photonic noise, or remote hardware execution. Runtime does not block that work. On the measured local CPU run, OpenCLIP extraction took 96.57 seconds and the first benchmark after embeddings took about 59.9 seconds. The real bottleneck is scientific validity under more folds, harder data, realistic noise, and calibrated hardware—not local computation time.</a:t>
+              <a:t>The evidence supports a three-level verdict. Technical feasibility is proven: the pipeline executes, two implementations agree, and the artifacts are reproducible. Application signal is partly answered: Q1 improves with labels, the paired one-fold ranking is known, and finite-shot sampling is stable in the tested range. Practical utility remains open because five-fold generalization, realistic noise, and remote hardware are unfinished. Local runtime is not the constraint: cached OpenCLIP extraction took 96.57 seconds, and the pilot model grid took about 59.9 seconds on CPU. The bottleneck is scientific validity under more folds, stronger controls, realistic noise, and calibrated hardware.</a:t>
             </a:r>
           </a:p>
         </p:txBody>
@@ -1447,16 +1447,16 @@
       </p:sp>
       <p:grpSp>
         <p:nvGrpSpPr>
-          <p:cNvPr id="6" name="Group 6"/>
+          <p:cNvPr id="7" name="Group 7"/>
           <p:cNvGrpSpPr/>
           <p:nvPr/>
         </p:nvGrpSpPr>
         <p:grpSpPr>
           <a:xfrm>
             <a:off x="593598" y="501968"/>
-            <a:ext cx="9000125" cy="1801844"/>
+            <a:ext cx="9000125" cy="2060638"/>
             <a:chOff x="593598" y="501968"/>
-            <a:chExt cx="9000125" cy="1801844"/>
+            <a:chExt cx="9000125" cy="2060638"/>
           </a:xfrm>
         </p:grpSpPr>
         <p:sp>
@@ -1488,7 +1488,7 @@
               <a:r>
                 <a:rPr lang="en-US" sz="1350" b="1" spc="105" dirty="0">
                   <a:solidFill>
-                    <a:schemeClr val="accent3"/>
+                    <a:schemeClr val="accent6"/>
                   </a:solidFill>
                   <a:latin typeface="+mn-lt"/>
                   <a:ea typeface="+mn-ea"/>
@@ -1595,10 +1595,50 @@
             </a:p>
           </p:txBody>
         </p:sp>
+        <p:sp>
+          <p:nvSpPr>
+            <p:cNvPr id="6" name="TextBox 6"/>
+            <p:cNvSpPr txBox="1"/>
+            <p:nvPr/>
+          </p:nvSpPr>
+          <p:spPr>
+            <a:xfrm>
+              <a:off x="603504" y="2327910"/>
+              <a:ext cx="8416585" cy="234696"/>
+            </a:xfrm>
+            <a:prstGeom prst="rect">
+              <a:avLst/>
+            </a:prstGeom>
+            <a:noFill/>
+            <a:ln>
+              <a:noFill/>
+            </a:ln>
+          </p:spPr>
+          <p:txBody>
+            <a:bodyPr wrap="none" lIns="0" tIns="0" rIns="0" bIns="0" anchor="t" anchorCtr="0">
+              <a:spAutoFit/>
+            </a:bodyPr>
+            <a:lstStyle/>
+            <a:p>
+              <a:pPr algn="l"/>
+              <a:r>
+                <a:rPr lang="en-US" sz="1200" b="1" spc="38" dirty="0">
+                  <a:solidFill>
+                    <a:schemeClr val="accent6"/>
+                  </a:solidFill>
+                  <a:latin typeface="+mn-lt"/>
+                  <a:ea typeface="+mn-ea"/>
+                  <a:cs typeface="+mn-cs"/>
+                </a:rPr>
+                <a:t>NGUYEN NGO NHAT NAM · R&amp;D QUANTUM OPTICS ENGINEER CANDIDATE · 15 SEP 2026 · 15:30 GMT+7</a:t>
+              </a:r>
+            </a:p>
+          </p:txBody>
+        </p:sp>
       </p:grpSp>
       <p:grpSp>
         <p:nvGrpSpPr>
-          <p:cNvPr id="19" name="Group 19"/>
+          <p:cNvPr id="20" name="Group 20"/>
           <p:cNvGrpSpPr/>
           <p:nvPr/>
         </p:nvGrpSpPr>
@@ -1612,7 +1652,7 @@
         </p:grpSpPr>
         <p:sp>
           <p:nvSpPr>
-            <p:cNvPr id="7" name="Rectangle 7"/>
+            <p:cNvPr id="8" name="Rectangle 8"/>
             <p:cNvSpPr/>
             <p:nvPr/>
           </p:nvSpPr>
@@ -1634,7 +1674,7 @@
         </p:sp>
         <p:sp>
           <p:nvSpPr>
-            <p:cNvPr id="8" name="TextBox 8"/>
+            <p:cNvPr id="9" name="TextBox 9"/>
             <p:cNvSpPr txBox="1"/>
             <p:nvPr/>
           </p:nvSpPr>
@@ -1661,7 +1701,7 @@
               <a:r>
                 <a:rPr lang="en-US" sz="1350" b="1" dirty="0">
                   <a:solidFill>
-                    <a:schemeClr val="accent2"/>
+                    <a:schemeClr val="accent5"/>
                   </a:solidFill>
                   <a:latin typeface="+mn-lt"/>
                   <a:ea typeface="+mn-ea"/>
@@ -1674,7 +1714,7 @@
         </p:sp>
         <p:sp>
           <p:nvSpPr>
-            <p:cNvPr id="9" name="TextBox 9"/>
+            <p:cNvPr id="10" name="TextBox 10"/>
             <p:cNvSpPr txBox="1"/>
             <p:nvPr/>
           </p:nvSpPr>
@@ -1714,7 +1754,7 @@
         </p:sp>
         <p:sp>
           <p:nvSpPr>
-            <p:cNvPr id="10" name="TextBox 10"/>
+            <p:cNvPr id="11" name="TextBox 11"/>
             <p:cNvSpPr txBox="1"/>
             <p:nvPr/>
           </p:nvSpPr>
@@ -1770,7 +1810,7 @@
         </p:sp>
         <p:sp>
           <p:nvSpPr>
-            <p:cNvPr id="11" name="Rectangle 11"/>
+            <p:cNvPr id="12" name="Rectangle 12"/>
             <p:cNvSpPr/>
             <p:nvPr/>
           </p:nvSpPr>
@@ -1792,7 +1832,7 @@
         </p:sp>
         <p:sp>
           <p:nvSpPr>
-            <p:cNvPr id="12" name="TextBox 12"/>
+            <p:cNvPr id="13" name="TextBox 13"/>
             <p:cNvSpPr txBox="1"/>
             <p:nvPr/>
           </p:nvSpPr>
@@ -1832,7 +1872,7 @@
         </p:sp>
         <p:sp>
           <p:nvSpPr>
-            <p:cNvPr id="13" name="TextBox 13"/>
+            <p:cNvPr id="14" name="TextBox 14"/>
             <p:cNvSpPr txBox="1"/>
             <p:nvPr/>
           </p:nvSpPr>
@@ -1872,7 +1912,7 @@
         </p:sp>
         <p:sp>
           <p:nvSpPr>
-            <p:cNvPr id="14" name="TextBox 14"/>
+            <p:cNvPr id="15" name="TextBox 15"/>
             <p:cNvSpPr txBox="1"/>
             <p:nvPr/>
           </p:nvSpPr>
@@ -1928,7 +1968,7 @@
         </p:sp>
         <p:sp>
           <p:nvSpPr>
-            <p:cNvPr id="15" name="Rectangle 15"/>
+            <p:cNvPr id="16" name="Rectangle 16"/>
             <p:cNvSpPr/>
             <p:nvPr/>
           </p:nvSpPr>
@@ -1950,7 +1990,7 @@
         </p:sp>
         <p:sp>
           <p:nvSpPr>
-            <p:cNvPr id="16" name="TextBox 16"/>
+            <p:cNvPr id="17" name="TextBox 17"/>
             <p:cNvSpPr txBox="1"/>
             <p:nvPr/>
           </p:nvSpPr>
@@ -1977,7 +2017,7 @@
               <a:r>
                 <a:rPr lang="en-US" sz="1350" b="1" dirty="0">
                   <a:solidFill>
-                    <a:schemeClr val="accent2"/>
+                    <a:schemeClr val="accent5"/>
                   </a:solidFill>
                   <a:latin typeface="+mn-lt"/>
                   <a:ea typeface="+mn-ea"/>
@@ -1990,7 +2030,7 @@
         </p:sp>
         <p:sp>
           <p:nvSpPr>
-            <p:cNvPr id="17" name="TextBox 17"/>
+            <p:cNvPr id="18" name="TextBox 18"/>
             <p:cNvSpPr txBox="1"/>
             <p:nvPr/>
           </p:nvSpPr>
@@ -2030,7 +2070,7 @@
         </p:sp>
         <p:sp>
           <p:nvSpPr>
-            <p:cNvPr id="18" name="TextBox 18"/>
+            <p:cNvPr id="19" name="TextBox 19"/>
             <p:cNvSpPr txBox="1"/>
             <p:nvPr/>
           </p:nvSpPr>
@@ -2087,7 +2127,7 @@
       </p:grpSp>
       <p:grpSp>
         <p:nvGrpSpPr>
-          <p:cNvPr id="27" name="Group 27"/>
+          <p:cNvPr id="28" name="Group 28"/>
           <p:cNvGrpSpPr/>
           <p:nvPr/>
         </p:nvGrpSpPr>
@@ -2101,7 +2141,7 @@
         </p:grpSpPr>
         <p:sp>
           <p:nvSpPr>
-            <p:cNvPr id="20" name="Rectangle 20"/>
+            <p:cNvPr id="21" name="Rectangle 21"/>
             <p:cNvSpPr/>
             <p:nvPr/>
           </p:nvSpPr>
@@ -2123,7 +2163,7 @@
         </p:sp>
         <p:sp>
           <p:nvSpPr>
-            <p:cNvPr id="21" name="TextBox 21"/>
+            <p:cNvPr id="22" name="TextBox 22"/>
             <p:cNvSpPr txBox="1"/>
             <p:nvPr/>
           </p:nvSpPr>
@@ -2163,7 +2203,7 @@
         </p:sp>
         <p:sp>
           <p:nvSpPr>
-            <p:cNvPr id="22" name="TextBox 22"/>
+            <p:cNvPr id="23" name="TextBox 23"/>
             <p:cNvSpPr txBox="1"/>
             <p:nvPr/>
           </p:nvSpPr>
@@ -2203,7 +2243,7 @@
         </p:sp>
         <p:sp>
           <p:nvSpPr>
-            <p:cNvPr id="23" name="TextBox 23"/>
+            <p:cNvPr id="24" name="TextBox 24"/>
             <p:cNvSpPr txBox="1"/>
             <p:nvPr/>
           </p:nvSpPr>
@@ -2243,7 +2283,7 @@
         </p:sp>
         <p:sp>
           <p:nvSpPr>
-            <p:cNvPr id="24" name="Line 24"/>
+            <p:cNvPr id="25" name="Line 25"/>
             <p:cNvSpPr/>
             <p:nvPr/>
           </p:nvSpPr>
@@ -2279,7 +2319,7 @@
         </p:sp>
         <p:sp>
           <p:nvSpPr>
-            <p:cNvPr id="25" name="TextBox 25"/>
+            <p:cNvPr id="26" name="TextBox 26"/>
             <p:cNvSpPr txBox="1"/>
             <p:nvPr/>
           </p:nvSpPr>
@@ -2319,7 +2359,7 @@
         </p:sp>
         <p:sp>
           <p:nvSpPr>
-            <p:cNvPr id="26" name="TextBox 26"/>
+            <p:cNvPr id="27" name="TextBox 27"/>
             <p:cNvSpPr txBox="1"/>
             <p:nvPr/>
           </p:nvSpPr>
@@ -2376,7 +2416,7 @@
       </p:grpSp>
       <p:grpSp>
         <p:nvGrpSpPr>
-          <p:cNvPr id="29" name="Group 29"/>
+          <p:cNvPr id="30" name="Group 30"/>
           <p:cNvGrpSpPr/>
           <p:nvPr/>
         </p:nvGrpSpPr>
@@ -2390,7 +2430,7 @@
         </p:grpSpPr>
         <p:sp>
           <p:nvSpPr>
-            <p:cNvPr id="28" name="TextBox 28"/>
+            <p:cNvPr id="29" name="TextBox 29"/>
             <p:cNvSpPr txBox="1"/>
             <p:nvPr/>
           </p:nvSpPr>
@@ -2530,7 +2570,7 @@
               <a:r>
                 <a:rPr lang="en-US" sz="1350" b="1" spc="105" dirty="0">
                   <a:solidFill>
-                    <a:schemeClr val="accent3"/>
+                    <a:schemeClr val="accent6"/>
                   </a:solidFill>
                   <a:latin typeface="+mn-lt"/>
                   <a:ea typeface="+mn-ea"/>
@@ -2647,7 +2687,7 @@
               <a:r>
                 <a:rPr lang="en-US" sz="1350" b="1" dirty="0">
                   <a:solidFill>
-                    <a:schemeClr val="accent2"/>
+                    <a:schemeClr val="accent5"/>
                   </a:solidFill>
                   <a:latin typeface="+mn-lt"/>
                   <a:ea typeface="+mn-ea"/>
@@ -2950,8 +2990,8 @@
           </p:nvSpPr>
           <p:spPr>
             <a:xfrm>
-              <a:off x="827532" y="4554855"/>
-              <a:ext cx="3465766" cy="734568"/>
+              <a:off x="827913" y="4486751"/>
+              <a:ext cx="3333788" cy="691324"/>
             </a:xfrm>
             <a:prstGeom prst="rect">
               <a:avLst/>
@@ -2969,11 +3009,11 @@
             <a:p>
               <a:pPr algn="l">
                 <a:lnSpc>
-                  <a:spcPts val="2550"/>
+                  <a:spcPts val="2325"/>
                 </a:lnSpc>
               </a:pPr>
               <a:r>
-                <a:rPr lang="en-US" sz="2100" b="1" dirty="0">
+                <a:rPr lang="en-US" sz="2020" b="1" dirty="0">
                   <a:solidFill>
                     <a:schemeClr val="accent1"/>
                   </a:solidFill>
@@ -2985,7 +3025,7 @@
               </a:r>
               <a:br/>
               <a:r>
-                <a:rPr lang="en-US" sz="2100" b="1" dirty="0">
+                <a:rPr lang="en-US" sz="2020" b="1" dirty="0">
                   <a:solidFill>
                     <a:schemeClr val="accent1"/>
                   </a:solidFill>
@@ -3006,26 +3046,26 @@
           </p:nvSpPr>
           <p:spPr>
             <a:xfrm>
-              <a:off x="831342" y="5169218"/>
-              <a:ext cx="4207520" cy="264033"/>
-            </a:xfrm>
-            <a:prstGeom prst="rect">
-              <a:avLst/>
-            </a:prstGeom>
-            <a:noFill/>
-            <a:ln>
-              <a:noFill/>
-            </a:ln>
-          </p:spPr>
-          <p:txBody>
-            <a:bodyPr wrap="none" lIns="0" tIns="0" rIns="0" bIns="0" anchor="t" anchorCtr="0">
-              <a:spAutoFit/>
-            </a:bodyPr>
-            <a:lstStyle/>
-            <a:p>
-              <a:pPr algn="l"/>
-              <a:r>
-                <a:rPr lang="en-US" sz="1350" b="1" dirty="0">
+              <a:off x="831723" y="5196364"/>
+              <a:ext cx="3989302" cy="249364"/>
+            </a:xfrm>
+            <a:prstGeom prst="rect">
+              <a:avLst/>
+            </a:prstGeom>
+            <a:noFill/>
+            <a:ln>
+              <a:noFill/>
+            </a:ln>
+          </p:spPr>
+          <p:txBody>
+            <a:bodyPr wrap="none" lIns="0" tIns="0" rIns="0" bIns="0" anchor="t" anchorCtr="0">
+              <a:spAutoFit/>
+            </a:bodyPr>
+            <a:lstStyle/>
+            <a:p>
+              <a:pPr algn="l"/>
+              <a:r>
+                <a:rPr lang="en-US" sz="1280" b="1" dirty="0">
                   <a:solidFill>
                     <a:schemeClr val="accent1"/>
                   </a:solidFill>
@@ -3041,16 +3081,16 @@
       </p:grpSp>
       <p:grpSp>
         <p:nvGrpSpPr>
-          <p:cNvPr id="29" name="Group 29"/>
+          <p:cNvPr id="30" name="Group 30"/>
           <p:cNvGrpSpPr/>
           <p:nvPr/>
         </p:nvGrpSpPr>
         <p:grpSpPr>
           <a:xfrm>
             <a:off x="6598044" y="1562100"/>
-            <a:ext cx="5015711" cy="3905250"/>
+            <a:ext cx="5072849" cy="3905250"/>
             <a:chOff x="6598044" y="1562100"/>
-            <a:chExt cx="5015711" cy="3905250"/>
+            <a:chExt cx="5072849" cy="3905250"/>
           </a:xfrm>
         </p:grpSpPr>
         <p:sp>
@@ -3123,30 +3163,26 @@
           </p:nvSpPr>
           <p:spPr>
             <a:xfrm>
-              <a:off x="6885432" y="2097405"/>
-              <a:ext cx="3801809" cy="744093"/>
-            </a:xfrm>
-            <a:prstGeom prst="rect">
-              <a:avLst/>
-            </a:prstGeom>
-            <a:noFill/>
-            <a:ln>
-              <a:noFill/>
-            </a:ln>
-          </p:spPr>
-          <p:txBody>
-            <a:bodyPr wrap="none" lIns="0" tIns="0" rIns="0" bIns="0" anchor="t" anchorCtr="0">
-              <a:spAutoFit/>
-            </a:bodyPr>
-            <a:lstStyle/>
-            <a:p>
-              <a:pPr algn="l">
-                <a:lnSpc>
-                  <a:spcPts val="2625"/>
-                </a:lnSpc>
-              </a:pPr>
-              <a:r>
-                <a:rPr lang="en-US" sz="2100" b="1" dirty="0">
+              <a:off x="6886575" y="2093119"/>
+              <a:ext cx="4784318" cy="366712"/>
+            </a:xfrm>
+            <a:prstGeom prst="rect">
+              <a:avLst/>
+            </a:prstGeom>
+            <a:noFill/>
+            <a:ln>
+              <a:noFill/>
+            </a:ln>
+          </p:spPr>
+          <p:txBody>
+            <a:bodyPr wrap="none" lIns="0" tIns="0" rIns="0" bIns="0" anchor="t" anchorCtr="0">
+              <a:spAutoFit/>
+            </a:bodyPr>
+            <a:lstStyle/>
+            <a:p>
+              <a:pPr algn="l"/>
+              <a:r>
+                <a:rPr lang="en-US" sz="1880" b="1" dirty="0">
                   <a:solidFill>
                     <a:srgbClr val="FFFFFF"/>
                   </a:solidFill>
@@ -3154,11 +3190,39 @@
                   <a:ea typeface="+mj-ea"/>
                   <a:cs typeface="+mj-cs"/>
                 </a:rPr>
-                <a:t>Q1 closes the ELM / RBF gap</a:t>
-              </a:r>
-              <a:br/>
-              <a:r>
-                <a:rPr lang="en-US" sz="2100" b="1" dirty="0">
+                <a:t>Pass A · gap ≤ 0.02 on ≥4 / 5 folds</a:t>
+              </a:r>
+            </a:p>
+          </p:txBody>
+        </p:sp>
+        <p:sp>
+          <p:nvSpPr>
+            <p:cNvPr id="22" name="TextBox 22"/>
+            <p:cNvSpPr txBox="1"/>
+            <p:nvPr/>
+          </p:nvSpPr>
+          <p:spPr>
+            <a:xfrm>
+              <a:off x="6886575" y="2483644"/>
+              <a:ext cx="4184010" cy="366712"/>
+            </a:xfrm>
+            <a:prstGeom prst="rect">
+              <a:avLst/>
+            </a:prstGeom>
+            <a:noFill/>
+            <a:ln>
+              <a:noFill/>
+            </a:ln>
+          </p:spPr>
+          <p:txBody>
+            <a:bodyPr wrap="none" lIns="0" tIns="0" rIns="0" bIns="0" anchor="t" anchorCtr="0">
+              <a:spAutoFit/>
+            </a:bodyPr>
+            <a:lstStyle/>
+            <a:p>
+              <a:pPr algn="l"/>
+              <a:r>
+                <a:rPr lang="en-US" sz="1880" b="1" dirty="0">
                   <a:solidFill>
                     <a:srgbClr val="FFFFFF"/>
                   </a:solidFill>
@@ -3166,39 +3230,39 @@
                   <a:ea typeface="+mj-ea"/>
                   <a:cs typeface="+mj-cs"/>
                 </a:rPr>
-                <a:t>across outer folds</a:t>
-              </a:r>
-            </a:p>
-          </p:txBody>
-        </p:sp>
-        <p:sp>
-          <p:nvSpPr>
-            <p:cNvPr id="22" name="TextBox 22"/>
-            <p:cNvSpPr txBox="1"/>
-            <p:nvPr/>
-          </p:nvSpPr>
-          <p:spPr>
-            <a:xfrm>
-              <a:off x="6888480" y="2943225"/>
-              <a:ext cx="4144709" cy="293370"/>
-            </a:xfrm>
-            <a:prstGeom prst="rect">
-              <a:avLst/>
-            </a:prstGeom>
-            <a:noFill/>
-            <a:ln>
-              <a:noFill/>
-            </a:ln>
-          </p:spPr>
-          <p:txBody>
-            <a:bodyPr wrap="none" lIns="0" tIns="0" rIns="0" bIns="0" anchor="t" anchorCtr="0">
-              <a:spAutoFit/>
-            </a:bodyPr>
-            <a:lstStyle/>
-            <a:p>
-              <a:pPr algn="l"/>
-              <a:r>
-                <a:rPr lang="en-US" sz="1500" dirty="0">
+                <a:t>or Pass B · 2× label efficiency</a:t>
+              </a:r>
+            </a:p>
+          </p:txBody>
+        </p:sp>
+        <p:sp>
+          <p:nvSpPr>
+            <p:cNvPr id="23" name="TextBox 23"/>
+            <p:cNvSpPr txBox="1"/>
+            <p:nvPr/>
+          </p:nvSpPr>
+          <p:spPr>
+            <a:xfrm>
+              <a:off x="6889242" y="2959418"/>
+              <a:ext cx="3684803" cy="264033"/>
+            </a:xfrm>
+            <a:prstGeom prst="rect">
+              <a:avLst/>
+            </a:prstGeom>
+            <a:noFill/>
+            <a:ln>
+              <a:noFill/>
+            </a:ln>
+          </p:spPr>
+          <p:txBody>
+            <a:bodyPr wrap="none" lIns="0" tIns="0" rIns="0" bIns="0" anchor="t" anchorCtr="0">
+              <a:spAutoFit/>
+            </a:bodyPr>
+            <a:lstStyle/>
+            <a:p>
+              <a:pPr algn="l"/>
+              <a:r>
+                <a:rPr lang="en-US" sz="1350" dirty="0">
                   <a:solidFill>
                     <a:srgbClr val="FBF7EE"/>
                   </a:solidFill>
@@ -3206,14 +3270,14 @@
                   <a:ea typeface="+mn-ea"/>
                   <a:cs typeface="+mn-cs"/>
                 </a:rPr>
-                <a:t>or shows a practical resource trade-off.</a:t>
-              </a:r>
-            </a:p>
-          </p:txBody>
-        </p:sp>
-        <p:sp>
-          <p:nvSpPr>
-            <p:cNvPr id="23" name="Rectangle 23"/>
+                <a:t>≤2,000 shots / image · acceptance ≥ 0.70</a:t>
+              </a:r>
+            </a:p>
+          </p:txBody>
+        </p:sp>
+        <p:sp>
+          <p:nvSpPr>
+            <p:cNvPr id="24" name="Rectangle 24"/>
             <p:cNvSpPr/>
             <p:nvPr/>
           </p:nvSpPr>
@@ -3235,7 +3299,7 @@
         </p:sp>
         <p:sp>
           <p:nvSpPr>
-            <p:cNvPr id="24" name="TextBox 24"/>
+            <p:cNvPr id="25" name="TextBox 25"/>
             <p:cNvSpPr txBox="1"/>
             <p:nvPr/>
           </p:nvSpPr>
@@ -3275,32 +3339,32 @@
         </p:sp>
         <p:sp>
           <p:nvSpPr>
-            <p:cNvPr id="25" name="TextBox 25"/>
-            <p:cNvSpPr txBox="1"/>
-            <p:nvPr/>
-          </p:nvSpPr>
-          <p:spPr>
-            <a:xfrm>
-              <a:off x="6886194" y="4056698"/>
-              <a:ext cx="3218212" cy="381381"/>
-            </a:xfrm>
-            <a:prstGeom prst="rect">
-              <a:avLst/>
-            </a:prstGeom>
-            <a:noFill/>
-            <a:ln>
-              <a:noFill/>
-            </a:ln>
-          </p:spPr>
-          <p:txBody>
-            <a:bodyPr wrap="none" lIns="0" tIns="0" rIns="0" bIns="0" anchor="t" anchorCtr="0">
-              <a:spAutoFit/>
-            </a:bodyPr>
-            <a:lstStyle/>
-            <a:p>
-              <a:pPr algn="l"/>
-              <a:r>
-                <a:rPr lang="en-US" sz="1950" b="1" dirty="0">
+            <p:cNvPr id="26" name="TextBox 26"/>
+            <p:cNvSpPr txBox="1"/>
+            <p:nvPr/>
+          </p:nvSpPr>
+          <p:spPr>
+            <a:xfrm>
+              <a:off x="6886575" y="4055269"/>
+              <a:ext cx="2551476" cy="366712"/>
+            </a:xfrm>
+            <a:prstGeom prst="rect">
+              <a:avLst/>
+            </a:prstGeom>
+            <a:noFill/>
+            <a:ln>
+              <a:noFill/>
+            </a:ln>
+          </p:spPr>
+          <p:txBody>
+            <a:bodyPr wrap="none" lIns="0" tIns="0" rIns="0" bIns="0" anchor="t" anchorCtr="0">
+              <a:spAutoFit/>
+            </a:bodyPr>
+            <a:lstStyle/>
+            <a:p>
+              <a:pPr algn="l"/>
+              <a:r>
+                <a:rPr lang="en-US" sz="1880" b="1" dirty="0">
                   <a:solidFill>
                     <a:srgbClr val="FFFFFF"/>
                   </a:solidFill>
@@ -3308,39 +3372,39 @@
                   <a:ea typeface="+mj-ea"/>
                   <a:cs typeface="+mj-cs"/>
                 </a:rPr>
-                <a:t>If Q1 only beats RFF:</a:t>
-              </a:r>
-            </a:p>
-          </p:txBody>
-        </p:sp>
-        <p:sp>
-          <p:nvSpPr>
-            <p:cNvPr id="26" name="TextBox 26"/>
-            <p:cNvSpPr txBox="1"/>
-            <p:nvPr/>
-          </p:nvSpPr>
-          <p:spPr>
-            <a:xfrm>
-              <a:off x="6888480" y="4410075"/>
-              <a:ext cx="3556083" cy="293370"/>
-            </a:xfrm>
-            <a:prstGeom prst="rect">
-              <a:avLst/>
-            </a:prstGeom>
-            <a:noFill/>
-            <a:ln>
-              <a:noFill/>
-            </a:ln>
-          </p:spPr>
-          <p:txBody>
-            <a:bodyPr wrap="none" lIns="0" tIns="0" rIns="0" bIns="0" anchor="t" anchorCtr="0">
-              <a:spAutoFit/>
-            </a:bodyPr>
-            <a:lstStyle/>
-            <a:p>
-              <a:pPr algn="l"/>
-              <a:r>
-                <a:rPr lang="en-US" sz="1500" b="1" dirty="0">
+                <a:t>Neither pass holds</a:t>
+              </a:r>
+            </a:p>
+          </p:txBody>
+        </p:sp>
+        <p:sp>
+          <p:nvSpPr>
+            <p:cNvPr id="27" name="TextBox 27"/>
+            <p:cNvSpPr txBox="1"/>
+            <p:nvPr/>
+          </p:nvSpPr>
+          <p:spPr>
+            <a:xfrm>
+              <a:off x="6889242" y="4426268"/>
+              <a:ext cx="3763405" cy="264033"/>
+            </a:xfrm>
+            <a:prstGeom prst="rect">
+              <a:avLst/>
+            </a:prstGeom>
+            <a:noFill/>
+            <a:ln>
+              <a:noFill/>
+            </a:ln>
+          </p:spPr>
+          <p:txBody>
+            <a:bodyPr wrap="none" lIns="0" tIns="0" rIns="0" bIns="0" anchor="t" anchorCtr="0">
+              <a:spAutoFit/>
+            </a:bodyPr>
+            <a:lstStyle/>
+            <a:p>
+              <a:pPr algn="l"/>
+              <a:r>
+                <a:rPr lang="en-US" sz="1350" b="1" dirty="0">
                   <a:solidFill>
                     <a:srgbClr val="FFFFFF"/>
                   </a:solidFill>
@@ -3348,14 +3412,14 @@
                   <a:ea typeface="+mn-ea"/>
                   <a:cs typeface="+mn-cs"/>
                 </a:rPr>
-                <a:t>report feasibility without utility.</a:t>
-              </a:r>
-            </a:p>
-          </p:txBody>
-        </p:sp>
-        <p:sp>
-          <p:nvSpPr>
-            <p:cNvPr id="27" name="Rectangle 27"/>
+                <a:t>or matched controls win on ≥4 / 5 folds.</a:t>
+              </a:r>
+            </a:p>
+          </p:txBody>
+        </p:sp>
+        <p:sp>
+          <p:nvSpPr>
+            <p:cNvPr id="28" name="Rectangle 28"/>
             <p:cNvSpPr/>
             <p:nvPr/>
           </p:nvSpPr>
@@ -3377,7 +3441,7 @@
         </p:sp>
         <p:sp>
           <p:nvSpPr>
-            <p:cNvPr id="28" name="TextBox 28"/>
+            <p:cNvPr id="29" name="TextBox 29"/>
             <p:cNvSpPr txBox="1"/>
             <p:nvPr/>
           </p:nvSpPr>
@@ -3418,7 +3482,7 @@
       </p:grpSp>
       <p:grpSp>
         <p:nvGrpSpPr>
-          <p:cNvPr id="33" name="Group 33"/>
+          <p:cNvPr id="34" name="Group 34"/>
           <p:cNvGrpSpPr/>
           <p:nvPr/>
         </p:nvGrpSpPr>
@@ -3432,7 +3496,7 @@
         </p:grpSpPr>
         <p:grpSp>
           <p:nvGrpSpPr>
-            <p:cNvPr id="32" name="Group 32"/>
+            <p:cNvPr id="33" name="Group 33"/>
             <p:cNvGrpSpPr/>
             <p:nvPr/>
           </p:nvGrpSpPr>
@@ -3446,7 +3510,7 @@
           </p:grpSpPr>
           <p:sp>
             <p:nvSpPr>
-              <p:cNvPr id="30" name="Rectangle 30">
+              <p:cNvPr id="31" name="Rectangle 31">
                 <a:hlinkClick r:id="rId2"/>
               </p:cNvPr>
               <p:cNvSpPr/>
@@ -3470,7 +3534,7 @@
           </p:sp>
           <p:sp>
             <p:nvSpPr>
-              <p:cNvPr id="31" name="TextBox 31">
+              <p:cNvPr id="32" name="TextBox 32">
                 <a:hlinkClick r:id="rId2"/>
               </p:cNvPr>
               <p:cNvSpPr txBox="1"/>
@@ -3514,7 +3578,7 @@
       </p:grpSp>
       <p:grpSp>
         <p:nvGrpSpPr>
-          <p:cNvPr id="35" name="Group 35"/>
+          <p:cNvPr id="36" name="Group 36"/>
           <p:cNvGrpSpPr/>
           <p:nvPr/>
         </p:nvGrpSpPr>
@@ -3528,7 +3592,7 @@
         </p:grpSpPr>
         <p:sp>
           <p:nvSpPr>
-            <p:cNvPr id="34" name="TextBox 34"/>
+            <p:cNvPr id="35" name="TextBox 35"/>
             <p:cNvSpPr txBox="1"/>
             <p:nvPr/>
           </p:nvSpPr>
@@ -3668,7 +3732,7 @@
               <a:r>
                 <a:rPr lang="en-US" sz="1350" b="1" spc="105" dirty="0">
                   <a:solidFill>
-                    <a:schemeClr val="accent3"/>
+                    <a:schemeClr val="accent6"/>
                   </a:solidFill>
                   <a:latin typeface="+mn-lt"/>
                   <a:ea typeface="+mn-ea"/>
@@ -4184,7 +4248,7 @@
               <a:r>
                 <a:rPr lang="en-US" sz="1350" b="1" dirty="0">
                   <a:solidFill>
-                    <a:schemeClr val="accent2"/>
+                    <a:schemeClr val="accent5"/>
                   </a:solidFill>
                   <a:latin typeface="+mn-lt"/>
                   <a:ea typeface="+mn-ea"/>
@@ -4542,7 +4606,7 @@
               <a:r>
                 <a:rPr lang="en-US" sz="1350" b="1" dirty="0">
                   <a:solidFill>
-                    <a:schemeClr val="accent2"/>
+                    <a:schemeClr val="accent5"/>
                   </a:solidFill>
                   <a:latin typeface="+mn-lt"/>
                   <a:ea typeface="+mn-ea"/>
@@ -4882,7 +4946,7 @@
               <a:r>
                 <a:rPr lang="en-US" sz="1350" b="1" spc="105" dirty="0">
                   <a:solidFill>
-                    <a:schemeClr val="accent3"/>
+                    <a:schemeClr val="accent6"/>
                   </a:solidFill>
                   <a:latin typeface="+mn-lt"/>
                   <a:ea typeface="+mn-ea"/>
@@ -4999,7 +5063,7 @@
               <a:r>
                 <a:rPr lang="en-US" sz="1350" b="1" dirty="0">
                   <a:solidFill>
-                    <a:schemeClr val="accent3"/>
+                    <a:schemeClr val="accent6"/>
                   </a:solidFill>
                   <a:latin typeface="+mn-lt"/>
                   <a:ea typeface="+mn-ea"/>
@@ -5188,7 +5252,7 @@
               <a:r>
                 <a:rPr lang="en-US" sz="1350" b="1" dirty="0">
                   <a:solidFill>
-                    <a:schemeClr val="accent2"/>
+                    <a:schemeClr val="accent5"/>
                   </a:solidFill>
                   <a:latin typeface="+mn-lt"/>
                   <a:ea typeface="+mn-ea"/>
@@ -5602,7 +5666,7 @@
               <a:r>
                 <a:rPr lang="en-US" sz="1350" b="1" dirty="0">
                   <a:solidFill>
-                    <a:schemeClr val="accent3"/>
+                    <a:schemeClr val="accent6"/>
                   </a:solidFill>
                   <a:latin typeface="+mn-lt"/>
                   <a:ea typeface="+mn-ea"/>
@@ -6314,7 +6378,7 @@
       </mc:AlternateContent>
       <p:grpSp>
         <p:nvGrpSpPr>
-          <p:cNvPr id="45" name="Group 45"/>
+          <p:cNvPr id="47" name="Group 47"/>
           <p:cNvGrpSpPr/>
           <p:nvPr/>
         </p:nvGrpSpPr>
@@ -6498,26 +6562,26 @@
           </p:nvSpPr>
           <p:spPr>
             <a:xfrm>
-              <a:off x="4412742" y="4607242"/>
-              <a:ext cx="2695331" cy="264033"/>
-            </a:xfrm>
-            <a:prstGeom prst="rect">
-              <a:avLst/>
-            </a:prstGeom>
-            <a:noFill/>
-            <a:ln>
-              <a:noFill/>
-            </a:ln>
-          </p:spPr>
-          <p:txBody>
-            <a:bodyPr wrap="none" lIns="0" tIns="0" rIns="0" bIns="0" anchor="t" anchorCtr="0">
-              <a:spAutoFit/>
-            </a:bodyPr>
-            <a:lstStyle/>
-            <a:p>
-              <a:pPr algn="l"/>
-              <a:r>
-                <a:rPr lang="en-US" sz="1350" b="1" dirty="0">
+              <a:off x="4413123" y="4577239"/>
+              <a:ext cx="2555522" cy="249364"/>
+            </a:xfrm>
+            <a:prstGeom prst="rect">
+              <a:avLst/>
+            </a:prstGeom>
+            <a:noFill/>
+            <a:ln>
+              <a:noFill/>
+            </a:ln>
+          </p:spPr>
+          <p:txBody>
+            <a:bodyPr wrap="none" lIns="0" tIns="0" rIns="0" bIns="0" anchor="t" anchorCtr="0">
+              <a:spAutoFit/>
+            </a:bodyPr>
+            <a:lstStyle/>
+            <a:p>
+              <a:pPr algn="l"/>
+              <a:r>
+                <a:rPr lang="en-US" sz="1280" b="1" dirty="0">
                   <a:solidFill>
                     <a:schemeClr val="accent1"/>
                   </a:solidFill>
@@ -6538,26 +6602,26 @@
           </p:nvSpPr>
           <p:spPr>
             <a:xfrm>
-              <a:off x="4408170" y="4891088"/>
-              <a:ext cx="3335274" cy="440055"/>
-            </a:xfrm>
-            <a:prstGeom prst="rect">
-              <a:avLst/>
-            </a:prstGeom>
-            <a:noFill/>
-            <a:ln>
-              <a:noFill/>
-            </a:ln>
-          </p:spPr>
-          <p:txBody>
-            <a:bodyPr wrap="none" lIns="0" tIns="0" rIns="0" bIns="0" anchor="t" anchorCtr="0">
-              <a:spAutoFit/>
-            </a:bodyPr>
-            <a:lstStyle/>
-            <a:p>
-              <a:pPr algn="l"/>
-              <a:r>
-                <a:rPr lang="en-US" sz="2250" b="1" dirty="0">
+              <a:off x="4409313" y="4839176"/>
+              <a:ext cx="2994386" cy="396050"/>
+            </a:xfrm>
+            <a:prstGeom prst="rect">
+              <a:avLst/>
+            </a:prstGeom>
+            <a:noFill/>
+            <a:ln>
+              <a:noFill/>
+            </a:ln>
+          </p:spPr>
+          <p:txBody>
+            <a:bodyPr wrap="none" lIns="0" tIns="0" rIns="0" bIns="0" anchor="t" anchorCtr="0">
+              <a:spAutoFit/>
+            </a:bodyPr>
+            <a:lstStyle/>
+            <a:p>
+              <a:pPr algn="l"/>
+              <a:r>
+                <a:rPr lang="en-US" sz="2020" b="1" dirty="0">
                   <a:solidFill>
                     <a:schemeClr val="accent1"/>
                   </a:solidFill>
@@ -6578,26 +6642,106 @@
           </p:nvSpPr>
           <p:spPr>
             <a:xfrm>
-              <a:off x="4412742" y="5321618"/>
-              <a:ext cx="2067344" cy="264033"/>
-            </a:xfrm>
-            <a:prstGeom prst="rect">
-              <a:avLst/>
-            </a:prstGeom>
-            <a:noFill/>
-            <a:ln>
-              <a:noFill/>
-            </a:ln>
-          </p:spPr>
-          <p:txBody>
-            <a:bodyPr wrap="none" lIns="0" tIns="0" rIns="0" bIns="0" anchor="t" anchorCtr="0">
-              <a:spAutoFit/>
-            </a:bodyPr>
-            <a:lstStyle/>
-            <a:p>
-              <a:pPr algn="l"/>
-              <a:r>
-                <a:rPr lang="en-US" sz="1350" dirty="0">
+              <a:off x="4414266" y="5220652"/>
+              <a:ext cx="1516136" cy="205359"/>
+            </a:xfrm>
+            <a:prstGeom prst="rect">
+              <a:avLst/>
+            </a:prstGeom>
+            <a:noFill/>
+            <a:ln>
+              <a:noFill/>
+            </a:ln>
+          </p:spPr>
+          <p:txBody>
+            <a:bodyPr wrap="none" lIns="0" tIns="0" rIns="0" bIns="0" anchor="t" anchorCtr="0">
+              <a:spAutoFit/>
+            </a:bodyPr>
+            <a:lstStyle/>
+            <a:p>
+              <a:pPr algn="l"/>
+              <a:r>
+                <a:rPr lang="en-US" sz="1050" b="1" dirty="0">
+                  <a:solidFill>
+                    <a:schemeClr val="accent1"/>
+                  </a:solidFill>
+                  <a:latin typeface="+mn-lt"/>
+                  <a:ea typeface="+mn-ea"/>
+                  <a:cs typeface="+mn-cs"/>
+                </a:rPr>
+                <a:t>SEPARATE CODE PATH</a:t>
+              </a:r>
+            </a:p>
+          </p:txBody>
+        </p:sp>
+        <p:sp>
+          <p:nvSpPr>
+            <p:cNvPr id="41" name="TextBox 41"/>
+            <p:cNvSpPr txBox="1"/>
+            <p:nvPr/>
+          </p:nvSpPr>
+          <p:spPr>
+            <a:xfrm>
+              <a:off x="4414266" y="5401628"/>
+              <a:ext cx="1986595" cy="205359"/>
+            </a:xfrm>
+            <a:prstGeom prst="rect">
+              <a:avLst/>
+            </a:prstGeom>
+            <a:noFill/>
+            <a:ln>
+              <a:noFill/>
+            </a:ln>
+          </p:spPr>
+          <p:txBody>
+            <a:bodyPr wrap="none" lIns="0" tIns="0" rIns="0" bIns="0" anchor="t" anchorCtr="0">
+              <a:spAutoFit/>
+            </a:bodyPr>
+            <a:lstStyle/>
+            <a:p>
+              <a:pPr algn="l"/>
+              <a:r>
+                <a:rPr lang="en-US" sz="1050" b="1" dirty="0">
+                  <a:solidFill>
+                    <a:schemeClr val="accent1"/>
+                  </a:solidFill>
+                  <a:latin typeface="+mn-lt"/>
+                  <a:ea typeface="+mn-ea"/>
+                  <a:cs typeface="+mn-cs"/>
+                </a:rPr>
+                <a:t>NOT EXTERNAL REPLICATION</a:t>
+              </a:r>
+            </a:p>
+          </p:txBody>
+        </p:sp>
+        <p:sp>
+          <p:nvSpPr>
+            <p:cNvPr id="42" name="TextBox 42"/>
+            <p:cNvSpPr txBox="1"/>
+            <p:nvPr/>
+          </p:nvSpPr>
+          <p:spPr>
+            <a:xfrm>
+              <a:off x="4413885" y="5622131"/>
+              <a:ext cx="1715181" cy="220028"/>
+            </a:xfrm>
+            <a:prstGeom prst="rect">
+              <a:avLst/>
+            </a:prstGeom>
+            <a:noFill/>
+            <a:ln>
+              <a:noFill/>
+            </a:ln>
+          </p:spPr>
+          <p:txBody>
+            <a:bodyPr wrap="none" lIns="0" tIns="0" rIns="0" bIns="0" anchor="t" anchorCtr="0">
+              <a:spAutoFit/>
+            </a:bodyPr>
+            <a:lstStyle/>
+            <a:p>
+              <a:pPr algn="l"/>
+              <a:r>
+                <a:rPr lang="en-US" sz="1120" dirty="0">
                   <a:solidFill>
                     <a:schemeClr val="accent1"/>
                   </a:solidFill>
@@ -6612,7 +6756,7 @@
         </p:sp>
         <p:sp>
           <p:nvSpPr>
-            <p:cNvPr id="41" name="Rectangle 41"/>
+            <p:cNvPr id="43" name="Rectangle 43"/>
             <p:cNvSpPr/>
             <p:nvPr/>
           </p:nvSpPr>
@@ -6639,7 +6783,7 @@
         </p:sp>
         <p:sp>
           <p:nvSpPr>
-            <p:cNvPr id="42" name="TextBox 42"/>
+            <p:cNvPr id="44" name="TextBox 44"/>
             <p:cNvSpPr txBox="1"/>
             <p:nvPr/>
           </p:nvSpPr>
@@ -6666,7 +6810,7 @@
               <a:r>
                 <a:rPr lang="en-US" sz="1350" b="1" dirty="0">
                   <a:solidFill>
-                    <a:schemeClr val="accent2"/>
+                    <a:schemeClr val="accent5"/>
                   </a:solidFill>
                   <a:latin typeface="+mn-lt"/>
                   <a:ea typeface="+mn-ea"/>
@@ -6679,7 +6823,7 @@
         </p:sp>
         <p:sp>
           <p:nvSpPr>
-            <p:cNvPr id="43" name="TextBox 43"/>
+            <p:cNvPr id="45" name="TextBox 45"/>
             <p:cNvSpPr txBox="1"/>
             <p:nvPr/>
           </p:nvSpPr>
@@ -6719,7 +6863,7 @@
         </p:sp>
         <p:sp>
           <p:nvSpPr>
-            <p:cNvPr id="44" name="TextBox 44"/>
+            <p:cNvPr id="46" name="TextBox 46"/>
             <p:cNvSpPr txBox="1"/>
             <p:nvPr/>
           </p:nvSpPr>
@@ -6746,7 +6890,7 @@
               <a:r>
                 <a:rPr lang="en-US" sz="1350" b="1" dirty="0">
                   <a:solidFill>
-                    <a:schemeClr val="accent2"/>
+                    <a:schemeClr val="accent5"/>
                   </a:solidFill>
                   <a:latin typeface="+mn-lt"/>
                   <a:ea typeface="+mn-ea"/>
@@ -6760,46 +6904,46 @@
       </p:grpSp>
       <p:grpSp>
         <p:nvGrpSpPr>
-          <p:cNvPr id="47" name="Group 47"/>
+          <p:cNvPr id="49" name="Group 49"/>
           <p:cNvGrpSpPr/>
           <p:nvPr/>
         </p:nvGrpSpPr>
         <p:grpSpPr>
           <a:xfrm>
-            <a:off x="602742" y="6045518"/>
-            <a:ext cx="4681552" cy="264033"/>
-            <a:chOff x="602742" y="6045518"/>
-            <a:chExt cx="4681552" cy="264033"/>
+            <a:off x="603885" y="6069806"/>
+            <a:ext cx="7193934" cy="220028"/>
+            <a:chOff x="603885" y="6069806"/>
+            <a:chExt cx="7193934" cy="220028"/>
           </a:xfrm>
         </p:grpSpPr>
         <p:sp>
           <p:nvSpPr>
-            <p:cNvPr id="46" name="TextBox 46"/>
-            <p:cNvSpPr txBox="1"/>
-            <p:nvPr/>
-          </p:nvSpPr>
-          <p:spPr>
-            <a:xfrm>
-              <a:off x="602742" y="6045518"/>
-              <a:ext cx="4681552" cy="264033"/>
-            </a:xfrm>
-            <a:prstGeom prst="rect">
-              <a:avLst/>
-            </a:prstGeom>
-            <a:noFill/>
-            <a:ln>
-              <a:noFill/>
-            </a:ln>
-          </p:spPr>
-          <p:txBody>
-            <a:bodyPr wrap="none" lIns="0" tIns="0" rIns="0" bIns="0" anchor="t" anchorCtr="0">
-              <a:spAutoFit/>
-            </a:bodyPr>
-            <a:lstStyle/>
-            <a:p>
-              <a:pPr algn="l"/>
-              <a:r>
-                <a:rPr lang="en-US" sz="1350" dirty="0">
+            <p:cNvPr id="48" name="TextBox 48"/>
+            <p:cNvSpPr txBox="1"/>
+            <p:nvPr/>
+          </p:nvSpPr>
+          <p:spPr>
+            <a:xfrm>
+              <a:off x="603885" y="6069806"/>
+              <a:ext cx="7193934" cy="220028"/>
+            </a:xfrm>
+            <a:prstGeom prst="rect">
+              <a:avLst/>
+            </a:prstGeom>
+            <a:noFill/>
+            <a:ln>
+              <a:noFill/>
+            </a:ln>
+          </p:spPr>
+          <p:txBody>
+            <a:bodyPr wrap="none" lIns="0" tIns="0" rIns="0" bIns="0" anchor="t" anchorCtr="0">
+              <a:spAutoFit/>
+            </a:bodyPr>
+            <a:lstStyle/>
+            <a:p>
+              <a:pPr algn="l"/>
+              <a:r>
+                <a:rPr lang="en-US" sz="1120" dirty="0">
                   <a:solidFill>
                     <a:srgbClr val="766E62"/>
                   </a:solidFill>
@@ -6807,7 +6951,7 @@
                   <a:ea typeface="+mn-ea"/>
                   <a:cs typeface="+mn-cs"/>
                 </a:rPr>
-                <a:t>Source: experiment_protocol.md · verification.json</a:t>
+                <a:t>Official docs: perceval.quandela.net/docs/v1.2 · merlinquantum.ai/0.4 · local verification.json</a:t>
               </a:r>
             </a:p>
           </p:txBody>
@@ -6815,7 +6959,7 @@
       </p:grpSp>
       <p:grpSp>
         <p:nvGrpSpPr>
-          <p:cNvPr id="49" name="Group 49"/>
+          <p:cNvPr id="51" name="Group 51"/>
           <p:cNvGrpSpPr/>
           <p:nvPr/>
         </p:nvGrpSpPr>
@@ -6829,7 +6973,7 @@
         </p:grpSpPr>
         <p:sp>
           <p:nvSpPr>
-            <p:cNvPr id="48" name="TextBox 48"/>
+            <p:cNvPr id="50" name="TextBox 50"/>
             <p:cNvSpPr txBox="1"/>
             <p:nvPr/>
           </p:nvSpPr>
@@ -6969,7 +7113,7 @@
               <a:r>
                 <a:rPr lang="en-US" sz="1350" b="1" spc="105" dirty="0">
                   <a:solidFill>
-                    <a:schemeClr val="accent3"/>
+                    <a:schemeClr val="accent6"/>
                   </a:solidFill>
                   <a:latin typeface="+mn-lt"/>
                   <a:ea typeface="+mn-ea"/>
@@ -7030,9 +7174,9 @@
         <p:grpSpPr>
           <a:xfrm>
             <a:off x="609600" y="1466850"/>
-            <a:ext cx="10972800" cy="1117473"/>
+            <a:ext cx="10972800" cy="1101376"/>
             <a:chOff x="609600" y="1466850"/>
-            <a:chExt cx="10972800" cy="1117473"/>
+            <a:chExt cx="10972800" cy="1101376"/>
           </a:xfrm>
         </p:grpSpPr>
         <p:sp>
@@ -7065,26 +7209,26 @@
           </p:nvSpPr>
           <p:spPr>
             <a:xfrm>
-              <a:off x="831342" y="1625918"/>
-              <a:ext cx="4651096" cy="264033"/>
-            </a:xfrm>
-            <a:prstGeom prst="rect">
-              <a:avLst/>
-            </a:prstGeom>
-            <a:noFill/>
-            <a:ln>
-              <a:noFill/>
-            </a:ln>
-          </p:spPr>
-          <p:txBody>
-            <a:bodyPr wrap="none" lIns="0" tIns="0" rIns="0" bIns="0" anchor="t" anchorCtr="0">
-              <a:spAutoFit/>
-            </a:bodyPr>
-            <a:lstStyle/>
-            <a:p>
-              <a:pPr algn="l"/>
-              <a:r>
-                <a:rPr lang="en-US" sz="1350" b="1" dirty="0">
+              <a:off x="831723" y="1624489"/>
+              <a:ext cx="2230532" cy="249364"/>
+            </a:xfrm>
+            <a:prstGeom prst="rect">
+              <a:avLst/>
+            </a:prstGeom>
+            <a:noFill/>
+            <a:ln>
+              <a:noFill/>
+            </a:ln>
+          </p:spPr>
+          <p:txBody>
+            <a:bodyPr wrap="none" lIns="0" tIns="0" rIns="0" bIns="0" anchor="t" anchorCtr="0">
+              <a:spAutoFit/>
+            </a:bodyPr>
+            <a:lstStyle/>
+            <a:p>
+              <a:pPr algn="l"/>
+              <a:r>
+                <a:rPr lang="en-US" sz="1280" b="1" dirty="0">
                   <a:solidFill>
                     <a:srgbClr val="B9D0C7"/>
                   </a:solidFill>
@@ -7092,7 +7236,7 @@
                   <a:ea typeface="+mn-ea"/>
                   <a:cs typeface="+mn-cs"/>
                 </a:rPr>
-                <a:t>AT THE SAME COMPRESSED INPUT AND 15-D OUTPUT</a:t>
+                <a:t>AT THE SAME PCA-5 INPUT</a:t>
               </a:r>
             </a:p>
           </p:txBody>
@@ -7105,8 +7249,8 @@
           </p:nvSpPr>
           <p:spPr>
             <a:xfrm>
-              <a:off x="827532" y="1868805"/>
-              <a:ext cx="6966204" cy="715518"/>
+              <a:off x="827913" y="1867376"/>
+              <a:ext cx="8047711" cy="700850"/>
             </a:xfrm>
             <a:prstGeom prst="rect">
               <a:avLst/>
@@ -7128,7 +7272,7 @@
                 </a:lnSpc>
               </a:pPr>
               <a:r>
-                <a:rPr lang="en-US" sz="2100" b="1" dirty="0">
+                <a:rPr lang="en-US" sz="2020" b="1" dirty="0">
                   <a:solidFill>
                     <a:srgbClr val="FFFFFF"/>
                   </a:solidFill>
@@ -7136,11 +7280,11 @@
                   <a:ea typeface="+mj-ea"/>
                   <a:cs typeface="+mj-cs"/>
                 </a:rPr>
-                <a:t>Can Q1 beat matched RFF, close the ELM / RBF gap,</a:t>
+                <a:t>Can Q1’s 15-D photonic features beat matched 15-D controls</a:t>
               </a:r>
               <a:br/>
               <a:r>
-                <a:rPr lang="en-US" sz="2100" b="1" dirty="0">
+                <a:rPr lang="en-US" sz="2020" b="1" dirty="0">
                   <a:solidFill>
                     <a:srgbClr val="FFFFFF"/>
                   </a:solidFill>
@@ -7148,7 +7292,7 @@
                   <a:ea typeface="+mj-ea"/>
                   <a:cs typeface="+mj-cs"/>
                 </a:rPr>
-                <a:t>or show practical resource value?</a:t>
+                <a:t>and approach PCA-5 RBF-SVM?</a:t>
               </a:r>
             </a:p>
           </p:txBody>
@@ -7163,9 +7307,9 @@
         <p:grpSpPr>
           <a:xfrm>
             <a:off x="609600" y="2647950"/>
-            <a:ext cx="3352800" cy="2981706"/>
+            <a:ext cx="3052886" cy="2971800"/>
             <a:chOff x="609600" y="2647950"/>
-            <a:chExt cx="3352800" cy="2981706"/>
+            <a:chExt cx="3052886" cy="2971800"/>
           </a:xfrm>
         </p:grpSpPr>
         <p:sp>
@@ -7177,7 +7321,7 @@
           <p:spPr>
             <a:xfrm>
               <a:off x="609600" y="2647950"/>
-              <a:ext cx="3352800" cy="2971800"/>
+              <a:ext cx="3048000" cy="2971800"/>
             </a:xfrm>
             <a:prstGeom prst="rect">
               <a:avLst/>
@@ -7219,7 +7363,7 @@
               <a:r>
                 <a:rPr lang="en-US" sz="1350" b="1" dirty="0">
                   <a:solidFill>
-                    <a:schemeClr val="accent2"/>
+                    <a:schemeClr val="accent5"/>
                   </a:solidFill>
                   <a:latin typeface="+mn-lt"/>
                   <a:ea typeface="+mn-ea"/>
@@ -7279,7 +7423,7 @@
           <p:spPr>
             <a:xfrm>
               <a:off x="831342" y="3521392"/>
-              <a:ext cx="1894694" cy="264033"/>
+              <a:ext cx="1385830" cy="264033"/>
             </a:xfrm>
             <a:prstGeom prst="rect">
               <a:avLst/>
@@ -7305,7 +7449,7 @@
                   <a:ea typeface="+mn-ea"/>
                   <a:cs typeface="+mn-cs"/>
                 </a:rPr>
-                <a:t>total labels per class</a:t>
+                <a:t>labels per class</a:t>
               </a:r>
             </a:p>
           </p:txBody>
@@ -7319,7 +7463,7 @@
           <p:spPr>
             <a:xfrm>
               <a:off x="838200" y="3886200"/>
-              <a:ext cx="2895600" cy="9525"/>
+              <a:ext cx="2590800" cy="9525"/>
             </a:xfrm>
             <a:custGeom>
               <a:avLst/>
@@ -7328,12 +7472,12 @@
               <a:cxnLst/>
               <a:rect l="l" t="t" r="r" b="b"/>
               <a:pathLst>
-                <a:path w="2895600" h="9525">
+                <a:path w="2590800" h="9525">
                   <a:moveTo>
                     <a:pt x="0" y="0"/>
                   </a:moveTo>
                   <a:lnTo>
-                    <a:pt x="2895600" y="0"/>
+                    <a:pt x="2590800" y="0"/>
                   </a:lnTo>
                 </a:path>
               </a:pathLst>
@@ -7354,8 +7498,8 @@
           </p:nvSpPr>
           <p:spPr>
             <a:xfrm>
-              <a:off x="831342" y="4026218"/>
-              <a:ext cx="2148268" cy="1368933"/>
+              <a:off x="831723" y="4034314"/>
+              <a:ext cx="2036826" cy="1316164"/>
             </a:xfrm>
             <a:prstGeom prst="rect">
               <a:avLst/>
@@ -7373,11 +7517,11 @@
             <a:p>
               <a:pPr algn="l">
                 <a:lnSpc>
-                  <a:spcPts val="2175"/>
+                  <a:spcPts val="2100"/>
                 </a:lnSpc>
               </a:pPr>
               <a:r>
-                <a:rPr lang="en-US" sz="1350" dirty="0">
+                <a:rPr lang="en-US" sz="1280" dirty="0">
                   <a:solidFill>
                     <a:schemeClr val="dk1"/>
                   </a:solidFill>
@@ -7389,7 +7533,7 @@
               </a:r>
               <a:br/>
               <a:r>
-                <a:rPr lang="en-US" sz="1350" dirty="0">
+                <a:rPr lang="en-US" sz="1280" dirty="0">
                   <a:solidFill>
                     <a:schemeClr val="dk1"/>
                   </a:solidFill>
@@ -7401,7 +7545,7 @@
               </a:r>
               <a:br/>
               <a:r>
-                <a:rPr lang="en-US" sz="1350" dirty="0">
+                <a:rPr lang="en-US" sz="1280" dirty="0">
                   <a:solidFill>
                     <a:schemeClr val="dk1"/>
                   </a:solidFill>
@@ -7413,7 +7557,7 @@
               </a:r>
               <a:br/>
               <a:r>
-                <a:rPr lang="en-US" sz="1350" dirty="0">
+                <a:rPr lang="en-US" sz="1280" dirty="0">
                   <a:solidFill>
                     <a:schemeClr val="dk1"/>
                   </a:solidFill>
@@ -7421,11 +7565,11 @@
                   <a:ea typeface="+mn-ea"/>
                   <a:cs typeface="+mn-cs"/>
                 </a:rPr>
-                <a:t>One test evaluation</a:t>
+                <a:t>One test evaluation per</a:t>
               </a:r>
               <a:br/>
               <a:r>
-                <a:rPr lang="en-US" sz="1350" dirty="0">
+                <a:rPr lang="en-US" sz="1280" dirty="0">
                   <a:solidFill>
                     <a:schemeClr val="dk1"/>
                   </a:solidFill>
@@ -7433,7 +7577,7 @@
                   <a:ea typeface="+mn-ea"/>
                   <a:cs typeface="+mn-cs"/>
                 </a:rPr>
-                <a:t>per selected pipeline</a:t>
+                <a:t>selected fitted pipeline</a:t>
               </a:r>
             </a:p>
           </p:txBody>
@@ -7446,34 +7590,34 @@
           </p:nvSpPr>
           <p:spPr>
             <a:xfrm>
-              <a:off x="832104" y="5394960"/>
-              <a:ext cx="2924556" cy="234696"/>
-            </a:xfrm>
-            <a:prstGeom prst="rect">
-              <a:avLst/>
-            </a:prstGeom>
-            <a:noFill/>
-            <a:ln>
-              <a:noFill/>
-            </a:ln>
-          </p:spPr>
-          <p:txBody>
-            <a:bodyPr wrap="none" lIns="0" tIns="0" rIns="0" bIns="0" anchor="t" anchorCtr="0">
-              <a:spAutoFit/>
-            </a:bodyPr>
-            <a:lstStyle/>
-            <a:p>
-              <a:pPr algn="l"/>
-              <a:r>
-                <a:rPr lang="en-US" sz="1200" b="1" dirty="0">
-                  <a:solidFill>
-                    <a:schemeClr val="accent3"/>
-                  </a:solidFill>
-                  <a:latin typeface="+mn-lt"/>
-                  <a:ea typeface="+mn-ea"/>
-                  <a:cs typeface="+mn-cs"/>
-                </a:rPr>
-                <a:t>MAP SEEDS AVERAGED—NEVER PICKED</a:t>
+              <a:off x="832485" y="5384006"/>
+              <a:ext cx="2830001" cy="220028"/>
+            </a:xfrm>
+            <a:prstGeom prst="rect">
+              <a:avLst/>
+            </a:prstGeom>
+            <a:noFill/>
+            <a:ln>
+              <a:noFill/>
+            </a:ln>
+          </p:spPr>
+          <p:txBody>
+            <a:bodyPr wrap="none" lIns="0" tIns="0" rIns="0" bIns="0" anchor="t" anchorCtr="0">
+              <a:spAutoFit/>
+            </a:bodyPr>
+            <a:lstStyle/>
+            <a:p>
+              <a:pPr algn="l"/>
+              <a:r>
+                <a:rPr lang="en-US" sz="1120" b="1" dirty="0">
+                  <a:solidFill>
+                    <a:schemeClr val="accent6"/>
+                  </a:solidFill>
+                  <a:latin typeface="+mn-lt"/>
+                  <a:ea typeface="+mn-ea"/>
+                  <a:cs typeface="+mn-cs"/>
+                </a:rPr>
+                <a:t>MAP SEEDS AVERAGED · NEVER PICKED</a:t>
               </a:r>
             </a:p>
           </p:txBody>
@@ -7487,10 +7631,10 @@
         </p:nvGrpSpPr>
         <p:grpSpPr>
           <a:xfrm>
-            <a:off x="4184142" y="2845118"/>
-            <a:ext cx="3740658" cy="2588133"/>
-            <a:chOff x="4184142" y="2845118"/>
-            <a:chExt cx="3740658" cy="2588133"/>
+            <a:off x="3880485" y="2802731"/>
+            <a:ext cx="3358515" cy="2817019"/>
+            <a:chOff x="3880485" y="2802731"/>
+            <a:chExt cx="3358515" cy="2817019"/>
           </a:xfrm>
         </p:grpSpPr>
         <p:sp>
@@ -7501,34 +7645,34 @@
           </p:nvSpPr>
           <p:spPr>
             <a:xfrm>
-              <a:off x="4184142" y="2845118"/>
-              <a:ext cx="3179232" cy="264033"/>
-            </a:xfrm>
-            <a:prstGeom prst="rect">
-              <a:avLst/>
-            </a:prstGeom>
-            <a:noFill/>
-            <a:ln>
-              <a:noFill/>
-            </a:ln>
-          </p:spPr>
-          <p:txBody>
-            <a:bodyPr wrap="none" lIns="0" tIns="0" rIns="0" bIns="0" anchor="t" anchorCtr="0">
-              <a:spAutoFit/>
-            </a:bodyPr>
-            <a:lstStyle/>
-            <a:p>
-              <a:pPr algn="l"/>
-              <a:r>
-                <a:rPr lang="en-US" sz="1350" b="1" dirty="0">
-                  <a:solidFill>
-                    <a:schemeClr val="accent3"/>
-                  </a:solidFill>
-                  <a:latin typeface="+mn-lt"/>
-                  <a:ea typeface="+mn-ea"/>
-                  <a:cs typeface="+mn-cs"/>
-                </a:rPr>
-                <a:t>SEVEN FAMILIES · SAME TEST GATE</a:t>
+              <a:off x="3880485" y="2802731"/>
+              <a:ext cx="2938729" cy="220028"/>
+            </a:xfrm>
+            <a:prstGeom prst="rect">
+              <a:avLst/>
+            </a:prstGeom>
+            <a:noFill/>
+            <a:ln>
+              <a:noFill/>
+            </a:ln>
+          </p:spPr>
+          <p:txBody>
+            <a:bodyPr wrap="none" lIns="0" tIns="0" rIns="0" bIns="0" anchor="t" anchorCtr="0">
+              <a:spAutoFit/>
+            </a:bodyPr>
+            <a:lstStyle/>
+            <a:p>
+              <a:pPr algn="l"/>
+              <a:r>
+                <a:rPr lang="en-US" sz="1120" b="1" dirty="0">
+                  <a:solidFill>
+                    <a:schemeClr val="accent6"/>
+                  </a:solidFill>
+                  <a:latin typeface="+mn-lt"/>
+                  <a:ea typeface="+mn-ea"/>
+                  <a:cs typeface="+mn-cs"/>
+                </a:rPr>
+                <a:t>7 FAMILIES · EQUAL-WIDTH SCHEMATIC</a:t>
               </a:r>
             </a:p>
           </p:txBody>
@@ -7541,8 +7685,8 @@
           </p:nvSpPr>
           <p:spPr>
             <a:xfrm>
-              <a:off x="4191000" y="3181350"/>
-              <a:ext cx="3733800" cy="323850"/>
+              <a:off x="3886200" y="3086100"/>
+              <a:ext cx="3352800" cy="323850"/>
             </a:xfrm>
             <a:prstGeom prst="rect">
               <a:avLst/>
@@ -7563,26 +7707,26 @@
           </p:nvSpPr>
           <p:spPr>
             <a:xfrm>
-              <a:off x="4336542" y="3264218"/>
-              <a:ext cx="1828559" cy="264033"/>
-            </a:xfrm>
-            <a:prstGeom prst="rect">
-              <a:avLst/>
-            </a:prstGeom>
-            <a:noFill/>
-            <a:ln>
-              <a:noFill/>
-            </a:ln>
-          </p:spPr>
-          <p:txBody>
-            <a:bodyPr wrap="none" lIns="0" tIns="0" rIns="0" bIns="0" anchor="t" anchorCtr="0">
-              <a:spAutoFit/>
-            </a:bodyPr>
-            <a:lstStyle/>
-            <a:p>
-              <a:pPr algn="l"/>
-              <a:r>
-                <a:rPr lang="en-US" sz="1350" b="1" dirty="0">
+              <a:off x="4032123" y="3177064"/>
+              <a:ext cx="1733694" cy="249364"/>
+            </a:xfrm>
+            <a:prstGeom prst="rect">
+              <a:avLst/>
+            </a:prstGeom>
+            <a:noFill/>
+            <a:ln>
+              <a:noFill/>
+            </a:ln>
+          </p:spPr>
+          <p:txBody>
+            <a:bodyPr wrap="none" lIns="0" tIns="0" rIns="0" bIns="0" anchor="t" anchorCtr="0">
+              <a:spAutoFit/>
+            </a:bodyPr>
+            <a:lstStyle/>
+            <a:p>
+              <a:pPr algn="l"/>
+              <a:r>
+                <a:rPr lang="en-US" sz="1280" b="1" dirty="0">
                   <a:solidFill>
                     <a:srgbClr val="FFFFFF"/>
                   </a:solidFill>
@@ -7603,8 +7747,8 @@
           </p:nvSpPr>
           <p:spPr>
             <a:xfrm>
-              <a:off x="4191000" y="3562350"/>
-              <a:ext cx="3524250" cy="323850"/>
+              <a:off x="3886200" y="3448050"/>
+              <a:ext cx="3352800" cy="323850"/>
             </a:xfrm>
             <a:prstGeom prst="rect">
               <a:avLst/>
@@ -7625,26 +7769,26 @@
           </p:nvSpPr>
           <p:spPr>
             <a:xfrm>
-              <a:off x="4336542" y="3645218"/>
-              <a:ext cx="1557752" cy="264033"/>
-            </a:xfrm>
-            <a:prstGeom prst="rect">
-              <a:avLst/>
-            </a:prstGeom>
-            <a:noFill/>
-            <a:ln>
-              <a:noFill/>
-            </a:ln>
-          </p:spPr>
-          <p:txBody>
-            <a:bodyPr wrap="none" lIns="0" tIns="0" rIns="0" bIns="0" anchor="t" anchorCtr="0">
-              <a:spAutoFit/>
-            </a:bodyPr>
-            <a:lstStyle/>
-            <a:p>
-              <a:pPr algn="l"/>
-              <a:r>
-                <a:rPr lang="en-US" sz="1350" dirty="0">
+              <a:off x="4032123" y="3539014"/>
+              <a:ext cx="1913183" cy="249364"/>
+            </a:xfrm>
+            <a:prstGeom prst="rect">
+              <a:avLst/>
+            </a:prstGeom>
+            <a:noFill/>
+            <a:ln>
+              <a:noFill/>
+            </a:ln>
+          </p:spPr>
+          <p:txBody>
+            <a:bodyPr wrap="none" lIns="0" tIns="0" rIns="0" bIns="0" anchor="t" anchorCtr="0">
+              <a:spAutoFit/>
+            </a:bodyPr>
+            <a:lstStyle/>
+            <a:p>
+              <a:pPr algn="l"/>
+              <a:r>
+                <a:rPr lang="en-US" sz="1280" dirty="0">
                   <a:solidFill>
                     <a:srgbClr val="FFFFFF"/>
                   </a:solidFill>
@@ -7652,7 +7796,7 @@
                   <a:ea typeface="+mn-ea"/>
                   <a:cs typeface="+mn-cs"/>
                 </a:rPr>
-                <a:t>B2 Full CLIP + RBF</a:t>
+                <a:t>B2 Full CLIP + RBF-SVM</a:t>
               </a:r>
             </a:p>
           </p:txBody>
@@ -7665,8 +7809,8 @@
           </p:nvSpPr>
           <p:spPr>
             <a:xfrm>
-              <a:off x="4191000" y="3943350"/>
-              <a:ext cx="3276600" cy="323850"/>
+              <a:off x="3886200" y="3810000"/>
+              <a:ext cx="3352800" cy="323850"/>
             </a:xfrm>
             <a:prstGeom prst="rect">
               <a:avLst/>
@@ -7674,8 +7818,10 @@
             <a:solidFill>
               <a:schemeClr val="lt2"/>
             </a:solidFill>
-            <a:ln>
-              <a:noFill/>
+            <a:ln w="9525">
+              <a:solidFill>
+                <a:srgbClr val="C9BDA8"/>
+              </a:solidFill>
             </a:ln>
           </p:spPr>
         </p:sp>
@@ -7687,26 +7833,26 @@
           </p:nvSpPr>
           <p:spPr>
             <a:xfrm>
-              <a:off x="4336542" y="4026218"/>
-              <a:ext cx="1519116" cy="264033"/>
-            </a:xfrm>
-            <a:prstGeom prst="rect">
-              <a:avLst/>
-            </a:prstGeom>
-            <a:noFill/>
-            <a:ln>
-              <a:noFill/>
-            </a:ln>
-          </p:spPr>
-          <p:txBody>
-            <a:bodyPr wrap="none" lIns="0" tIns="0" rIns="0" bIns="0" anchor="t" anchorCtr="0">
-              <a:spAutoFit/>
-            </a:bodyPr>
-            <a:lstStyle/>
-            <a:p>
-              <a:pPr algn="l"/>
-              <a:r>
-                <a:rPr lang="en-US" sz="1350" dirty="0">
+              <a:off x="4032123" y="3900964"/>
+              <a:ext cx="1440296" cy="249364"/>
+            </a:xfrm>
+            <a:prstGeom prst="rect">
+              <a:avLst/>
+            </a:prstGeom>
+            <a:noFill/>
+            <a:ln>
+              <a:noFill/>
+            </a:ln>
+          </p:spPr>
+          <p:txBody>
+            <a:bodyPr wrap="none" lIns="0" tIns="0" rIns="0" bIns="0" anchor="t" anchorCtr="0">
+              <a:spAutoFit/>
+            </a:bodyPr>
+            <a:lstStyle/>
+            <a:p>
+              <a:pPr algn="l"/>
+              <a:r>
+                <a:rPr lang="en-US" sz="1280" dirty="0">
                   <a:solidFill>
                     <a:schemeClr val="dk1"/>
                   </a:solidFill>
@@ -7727,8 +7873,8 @@
           </p:nvSpPr>
           <p:spPr>
             <a:xfrm>
-              <a:off x="4191000" y="4324350"/>
-              <a:ext cx="3067050" cy="323850"/>
+              <a:off x="3886200" y="4171950"/>
+              <a:ext cx="3352800" cy="323850"/>
             </a:xfrm>
             <a:prstGeom prst="rect">
               <a:avLst/>
@@ -7749,26 +7895,26 @@
           </p:nvSpPr>
           <p:spPr>
             <a:xfrm>
-              <a:off x="4336542" y="4407218"/>
-              <a:ext cx="1348283" cy="264033"/>
-            </a:xfrm>
-            <a:prstGeom prst="rect">
-              <a:avLst/>
-            </a:prstGeom>
-            <a:noFill/>
-            <a:ln>
-              <a:noFill/>
-            </a:ln>
-          </p:spPr>
-          <p:txBody>
-            <a:bodyPr wrap="none" lIns="0" tIns="0" rIns="0" bIns="0" anchor="t" anchorCtr="0">
-              <a:spAutoFit/>
-            </a:bodyPr>
-            <a:lstStyle/>
-            <a:p>
-              <a:pPr algn="l"/>
-              <a:r>
-                <a:rPr lang="en-US" sz="1350" dirty="0">
+              <a:off x="4032123" y="4262914"/>
+              <a:ext cx="1715282" cy="249364"/>
+            </a:xfrm>
+            <a:prstGeom prst="rect">
+              <a:avLst/>
+            </a:prstGeom>
+            <a:noFill/>
+            <a:ln>
+              <a:noFill/>
+            </a:ln>
+          </p:spPr>
+          <p:txBody>
+            <a:bodyPr wrap="none" lIns="0" tIns="0" rIns="0" bIns="0" anchor="t" anchorCtr="0">
+              <a:spAutoFit/>
+            </a:bodyPr>
+            <a:lstStyle/>
+            <a:p>
+              <a:pPr algn="l"/>
+              <a:r>
+                <a:rPr lang="en-US" sz="1280" dirty="0">
                   <a:solidFill>
                     <a:schemeClr val="dk1"/>
                   </a:solidFill>
@@ -7776,7 +7922,7 @@
                   <a:ea typeface="+mn-ea"/>
                   <a:cs typeface="+mn-cs"/>
                 </a:rPr>
-                <a:t>B4 PCA-5 + RBF</a:t>
+                <a:t>B4 PCA-5 + RBF-SVM</a:t>
               </a:r>
             </a:p>
           </p:txBody>
@@ -7789,8 +7935,8 @@
           </p:nvSpPr>
           <p:spPr>
             <a:xfrm>
-              <a:off x="4191000" y="4705350"/>
-              <a:ext cx="2819400" cy="323850"/>
+              <a:off x="3886200" y="4533900"/>
+              <a:ext cx="3352800" cy="323850"/>
             </a:xfrm>
             <a:prstGeom prst="rect">
               <a:avLst/>
@@ -7811,26 +7957,26 @@
           </p:nvSpPr>
           <p:spPr>
             <a:xfrm>
-              <a:off x="4336542" y="4788218"/>
-              <a:ext cx="916229" cy="264033"/>
-            </a:xfrm>
-            <a:prstGeom prst="rect">
-              <a:avLst/>
-            </a:prstGeom>
-            <a:noFill/>
-            <a:ln>
-              <a:noFill/>
-            </a:ln>
-          </p:spPr>
-          <p:txBody>
-            <a:bodyPr wrap="none" lIns="0" tIns="0" rIns="0" bIns="0" anchor="t" anchorCtr="0">
-              <a:spAutoFit/>
-            </a:bodyPr>
-            <a:lstStyle/>
-            <a:p>
-              <a:pPr algn="l"/>
-              <a:r>
-                <a:rPr lang="en-US" sz="1350" dirty="0">
+              <a:off x="4032123" y="4624864"/>
+              <a:ext cx="868670" cy="249364"/>
+            </a:xfrm>
+            <a:prstGeom prst="rect">
+              <a:avLst/>
+            </a:prstGeom>
+            <a:noFill/>
+            <a:ln>
+              <a:noFill/>
+            </a:ln>
+          </p:spPr>
+          <p:txBody>
+            <a:bodyPr wrap="none" lIns="0" tIns="0" rIns="0" bIns="0" anchor="t" anchorCtr="0">
+              <a:spAutoFit/>
+            </a:bodyPr>
+            <a:lstStyle/>
+            <a:p>
+              <a:pPr algn="l"/>
+              <a:r>
+                <a:rPr lang="en-US" sz="1280" dirty="0">
                   <a:solidFill>
                     <a:schemeClr val="dk1"/>
                   </a:solidFill>
@@ -7851,8 +7997,8 @@
           </p:nvSpPr>
           <p:spPr>
             <a:xfrm>
-              <a:off x="4191000" y="5086350"/>
-              <a:ext cx="2571750" cy="323850"/>
+              <a:off x="3886200" y="4895850"/>
+              <a:ext cx="3352800" cy="323850"/>
             </a:xfrm>
             <a:prstGeom prst="rect">
               <a:avLst/>
@@ -7873,26 +8019,26 @@
           </p:nvSpPr>
           <p:spPr>
             <a:xfrm>
-              <a:off x="4336542" y="5169218"/>
-              <a:ext cx="954634" cy="264033"/>
-            </a:xfrm>
-            <a:prstGeom prst="rect">
-              <a:avLst/>
-            </a:prstGeom>
-            <a:noFill/>
-            <a:ln>
-              <a:noFill/>
-            </a:ln>
-          </p:spPr>
-          <p:txBody>
-            <a:bodyPr wrap="none" lIns="0" tIns="0" rIns="0" bIns="0" anchor="t" anchorCtr="0">
-              <a:spAutoFit/>
-            </a:bodyPr>
-            <a:lstStyle/>
-            <a:p>
-              <a:pPr algn="l"/>
-              <a:r>
-                <a:rPr lang="en-US" sz="1350" dirty="0">
+              <a:off x="4032123" y="4986814"/>
+              <a:ext cx="905083" cy="249364"/>
+            </a:xfrm>
+            <a:prstGeom prst="rect">
+              <a:avLst/>
+            </a:prstGeom>
+            <a:noFill/>
+            <a:ln>
+              <a:noFill/>
+            </a:ln>
+          </p:spPr>
+          <p:txBody>
+            <a:bodyPr wrap="none" lIns="0" tIns="0" rIns="0" bIns="0" anchor="t" anchorCtr="0">
+              <a:spAutoFit/>
+            </a:bodyPr>
+            <a:lstStyle/>
+            <a:p>
+              <a:pPr algn="l"/>
+              <a:r>
+                <a:rPr lang="en-US" sz="1280" dirty="0">
                   <a:solidFill>
                     <a:schemeClr val="accent1"/>
                   </a:solidFill>
@@ -7913,8 +8059,8 @@
           </p:nvSpPr>
           <p:spPr>
             <a:xfrm>
-              <a:off x="6819900" y="5086350"/>
-              <a:ext cx="1104900" cy="323850"/>
+              <a:off x="3886200" y="5257800"/>
+              <a:ext cx="3352800" cy="361950"/>
             </a:xfrm>
             <a:prstGeom prst="rect">
               <a:avLst/>
@@ -7935,26 +8081,26 @@
           </p:nvSpPr>
           <p:spPr>
             <a:xfrm>
-              <a:off x="7068095" y="5169218"/>
-              <a:ext cx="608510" cy="264033"/>
-            </a:xfrm>
-            <a:prstGeom prst="rect">
-              <a:avLst/>
-            </a:prstGeom>
-            <a:noFill/>
-            <a:ln>
-              <a:noFill/>
-            </a:ln>
-          </p:spPr>
-          <p:txBody>
-            <a:bodyPr wrap="none" lIns="0" tIns="0" rIns="0" bIns="0" anchor="t" anchorCtr="0">
-              <a:spAutoFit/>
-            </a:bodyPr>
-            <a:lstStyle/>
-            <a:p>
-              <a:pPr algn="ctr"/>
-              <a:r>
-                <a:rPr lang="en-US" sz="1350" b="1" dirty="0">
+              <a:off x="4032123" y="5367814"/>
+              <a:ext cx="1368672" cy="249364"/>
+            </a:xfrm>
+            <a:prstGeom prst="rect">
+              <a:avLst/>
+            </a:prstGeom>
+            <a:noFill/>
+            <a:ln>
+              <a:noFill/>
+            </a:ln>
+          </p:spPr>
+          <p:txBody>
+            <a:bodyPr wrap="none" lIns="0" tIns="0" rIns="0" bIns="0" anchor="t" anchorCtr="0">
+              <a:spAutoFit/>
+            </a:bodyPr>
+            <a:lstStyle/>
+            <a:p>
+              <a:pPr algn="l"/>
+              <a:r>
+                <a:rPr lang="en-US" sz="1280" b="1" dirty="0">
                   <a:solidFill>
                     <a:srgbClr val="FFFFFF"/>
                   </a:solidFill>
@@ -7962,7 +8108,7 @@
                   <a:ea typeface="+mn-ea"/>
                   <a:cs typeface="+mn-cs"/>
                 </a:rPr>
-                <a:t>Q1-15</a:t>
+                <a:t>Q1 Photonic-15</a:t>
               </a:r>
             </a:p>
           </p:txBody>
@@ -7970,16 +8116,16 @@
       </p:grpSp>
       <p:grpSp>
         <p:nvGrpSpPr>
-          <p:cNvPr id="42" name="Group 42"/>
+          <p:cNvPr id="46" name="Group 46"/>
           <p:cNvGrpSpPr/>
           <p:nvPr/>
         </p:nvGrpSpPr>
         <p:grpSpPr>
           <a:xfrm>
-            <a:off x="8153400" y="2647950"/>
-            <a:ext cx="3429000" cy="2971800"/>
-            <a:chOff x="8153400" y="2647950"/>
-            <a:chExt cx="3429000" cy="2971800"/>
+            <a:off x="7467600" y="2647950"/>
+            <a:ext cx="4171954" cy="2975134"/>
+            <a:chOff x="7467600" y="2647950"/>
+            <a:chExt cx="4171954" cy="2975134"/>
           </a:xfrm>
         </p:grpSpPr>
         <p:sp>
@@ -7990,8 +8136,8 @@
           </p:nvSpPr>
           <p:spPr>
             <a:xfrm>
-              <a:off x="8153400" y="2647950"/>
-              <a:ext cx="3429000" cy="1352550"/>
+              <a:off x="7467600" y="2647950"/>
+              <a:ext cx="4114800" cy="990600"/>
             </a:xfrm>
             <a:prstGeom prst="rect">
               <a:avLst/>
@@ -8012,26 +8158,26 @@
           </p:nvSpPr>
           <p:spPr>
             <a:xfrm>
-              <a:off x="8375142" y="2826068"/>
-              <a:ext cx="1394849" cy="264033"/>
-            </a:xfrm>
-            <a:prstGeom prst="rect">
-              <a:avLst/>
-            </a:prstGeom>
-            <a:noFill/>
-            <a:ln>
-              <a:noFill/>
-            </a:ln>
-          </p:spPr>
-          <p:txBody>
-            <a:bodyPr wrap="none" lIns="0" tIns="0" rIns="0" bIns="0" anchor="t" anchorCtr="0">
-              <a:spAutoFit/>
-            </a:bodyPr>
-            <a:lstStyle/>
-            <a:p>
-              <a:pPr algn="l"/>
-              <a:r>
-                <a:rPr lang="en-US" sz="1350" b="1" dirty="0">
+              <a:off x="7689723" y="2805589"/>
+              <a:ext cx="2297442" cy="249364"/>
+            </a:xfrm>
+            <a:prstGeom prst="rect">
+              <a:avLst/>
+            </a:prstGeom>
+            <a:noFill/>
+            <a:ln>
+              <a:noFill/>
+            </a:ln>
+          </p:spPr>
+          <p:txBody>
+            <a:bodyPr wrap="none" lIns="0" tIns="0" rIns="0" bIns="0" anchor="t" anchorCtr="0">
+              <a:spAutoFit/>
+            </a:bodyPr>
+            <a:lstStyle/>
+            <a:p>
+              <a:pPr algn="l"/>
+              <a:r>
+                <a:rPr lang="en-US" sz="1280" b="1" dirty="0">
                   <a:solidFill>
                     <a:srgbClr val="FBF7EE"/>
                   </a:solidFill>
@@ -8039,7 +8185,7 @@
                   <a:ea typeface="+mn-ea"/>
                   <a:cs typeface="+mn-cs"/>
                 </a:rPr>
-                <a:t>CONTINUE GATE</a:t>
+                <a:t>PASS A · ACCURACY PARITY</a:t>
               </a:r>
             </a:p>
           </p:txBody>
@@ -8052,30 +8198,26 @@
           </p:nvSpPr>
           <p:spPr>
             <a:xfrm>
-              <a:off x="8372856" y="3139440"/>
-              <a:ext cx="2274570" cy="656844"/>
-            </a:xfrm>
-            <a:prstGeom prst="rect">
-              <a:avLst/>
-            </a:prstGeom>
-            <a:noFill/>
-            <a:ln>
-              <a:noFill/>
-            </a:ln>
-          </p:spPr>
-          <p:txBody>
-            <a:bodyPr wrap="none" lIns="0" tIns="0" rIns="0" bIns="0" anchor="t" anchorCtr="0">
-              <a:spAutoFit/>
-            </a:bodyPr>
-            <a:lstStyle/>
-            <a:p>
-              <a:pPr algn="l">
-                <a:lnSpc>
-                  <a:spcPts val="2400"/>
-                </a:lnSpc>
-              </a:pPr>
-              <a:r>
-                <a:rPr lang="en-US" sz="1800" b="1" dirty="0">
+              <a:off x="7687437" y="3080861"/>
+              <a:ext cx="3090059" cy="337376"/>
+            </a:xfrm>
+            <a:prstGeom prst="rect">
+              <a:avLst/>
+            </a:prstGeom>
+            <a:noFill/>
+            <a:ln>
+              <a:noFill/>
+            </a:ln>
+          </p:spPr>
+          <p:txBody>
+            <a:bodyPr wrap="none" lIns="0" tIns="0" rIns="0" bIns="0" anchor="t" anchorCtr="0">
+              <a:spAutoFit/>
+            </a:bodyPr>
+            <a:lstStyle/>
+            <a:p>
+              <a:pPr algn="l"/>
+              <a:r>
+                <a:rPr lang="en-US" sz="1720" b="1" dirty="0">
                   <a:solidFill>
                     <a:srgbClr val="FFFFFF"/>
                   </a:solidFill>
@@ -8083,11 +8225,141 @@
                   <a:ea typeface="+mj-ea"/>
                   <a:cs typeface="+mj-cs"/>
                 </a:rPr>
-                <a:t>Close ELM / RBF gap</a:t>
-              </a:r>
-              <a:br/>
-              <a:r>
-                <a:rPr lang="en-US" sz="1800" b="1" dirty="0">
+                <a:t>Q1 ≥ RBF-SVM − 0.02</a:t>
+              </a:r>
+            </a:p>
+          </p:txBody>
+        </p:sp>
+        <p:sp>
+          <p:nvSpPr>
+            <p:cNvPr id="37" name="TextBox 37"/>
+            <p:cNvSpPr txBox="1"/>
+            <p:nvPr/>
+          </p:nvSpPr>
+          <p:spPr>
+            <a:xfrm>
+              <a:off x="7689723" y="3377089"/>
+              <a:ext cx="2373650" cy="249364"/>
+            </a:xfrm>
+            <a:prstGeom prst="rect">
+              <a:avLst/>
+            </a:prstGeom>
+            <a:noFill/>
+            <a:ln>
+              <a:noFill/>
+            </a:ln>
+          </p:spPr>
+          <p:txBody>
+            <a:bodyPr wrap="none" lIns="0" tIns="0" rIns="0" bIns="0" anchor="t" anchorCtr="0">
+              <a:spAutoFit/>
+            </a:bodyPr>
+            <a:lstStyle/>
+            <a:p>
+              <a:pPr algn="l"/>
+              <a:r>
+                <a:rPr lang="en-US" sz="1280" dirty="0">
+                  <a:solidFill>
+                    <a:srgbClr val="FBF7EE"/>
+                  </a:solidFill>
+                  <a:latin typeface="+mn-lt"/>
+                  <a:ea typeface="+mn-ea"/>
+                  <a:cs typeface="+mn-cs"/>
+                </a:rPr>
+                <a:t>on at least 4 / 5 outer folds</a:t>
+              </a:r>
+            </a:p>
+          </p:txBody>
+        </p:sp>
+        <p:sp>
+          <p:nvSpPr>
+            <p:cNvPr id="38" name="Rectangle 38"/>
+            <p:cNvSpPr/>
+            <p:nvPr/>
+          </p:nvSpPr>
+          <p:spPr>
+            <a:xfrm>
+              <a:off x="7467600" y="3752850"/>
+              <a:ext cx="4114800" cy="1200150"/>
+            </a:xfrm>
+            <a:prstGeom prst="rect">
+              <a:avLst/>
+            </a:prstGeom>
+            <a:solidFill>
+              <a:schemeClr val="accent1"/>
+            </a:solidFill>
+            <a:ln>
+              <a:noFill/>
+            </a:ln>
+          </p:spPr>
+        </p:sp>
+        <p:sp>
+          <p:nvSpPr>
+            <p:cNvPr id="39" name="TextBox 39"/>
+            <p:cNvSpPr txBox="1"/>
+            <p:nvPr/>
+          </p:nvSpPr>
+          <p:spPr>
+            <a:xfrm>
+              <a:off x="7689723" y="3910489"/>
+              <a:ext cx="2622432" cy="249364"/>
+            </a:xfrm>
+            <a:prstGeom prst="rect">
+              <a:avLst/>
+            </a:prstGeom>
+            <a:noFill/>
+            <a:ln>
+              <a:noFill/>
+            </a:ln>
+          </p:spPr>
+          <p:txBody>
+            <a:bodyPr wrap="none" lIns="0" tIns="0" rIns="0" bIns="0" anchor="t" anchorCtr="0">
+              <a:spAutoFit/>
+            </a:bodyPr>
+            <a:lstStyle/>
+            <a:p>
+              <a:pPr algn="l"/>
+              <a:r>
+                <a:rPr lang="en-US" sz="1280" b="1" dirty="0">
+                  <a:solidFill>
+                    <a:srgbClr val="B9D0C7"/>
+                  </a:solidFill>
+                  <a:latin typeface="+mn-lt"/>
+                  <a:ea typeface="+mn-ea"/>
+                  <a:cs typeface="+mn-cs"/>
+                </a:rPr>
+                <a:t>PASS B · 2× LABEL EFFICIENCY</a:t>
+              </a:r>
+            </a:p>
+          </p:txBody>
+        </p:sp>
+        <p:sp>
+          <p:nvSpPr>
+            <p:cNvPr id="40" name="TextBox 40"/>
+            <p:cNvSpPr txBox="1"/>
+            <p:nvPr/>
+          </p:nvSpPr>
+          <p:spPr>
+            <a:xfrm>
+              <a:off x="7687818" y="4193858"/>
+              <a:ext cx="3951736" cy="322707"/>
+            </a:xfrm>
+            <a:prstGeom prst="rect">
+              <a:avLst/>
+            </a:prstGeom>
+            <a:noFill/>
+            <a:ln>
+              <a:noFill/>
+            </a:ln>
+          </p:spPr>
+          <p:txBody>
+            <a:bodyPr wrap="none" lIns="0" tIns="0" rIns="0" bIns="0" anchor="t" anchorCtr="0">
+              <a:spAutoFit/>
+            </a:bodyPr>
+            <a:lstStyle/>
+            <a:p>
+              <a:pPr algn="l"/>
+              <a:r>
+                <a:rPr lang="en-US" sz="1650" b="1" dirty="0">
                   <a:solidFill>
                     <a:srgbClr val="FFFFFF"/>
                   </a:solidFill>
@@ -8095,39 +8367,39 @@
                   <a:ea typeface="+mj-ea"/>
                   <a:cs typeface="+mj-cs"/>
                 </a:rPr>
-                <a:t>across outer folds</a:t>
-              </a:r>
-            </a:p>
-          </p:txBody>
-        </p:sp>
-        <p:sp>
-          <p:nvSpPr>
-            <p:cNvPr id="37" name="TextBox 37"/>
-            <p:cNvSpPr txBox="1"/>
-            <p:nvPr/>
-          </p:nvSpPr>
-          <p:spPr>
-            <a:xfrm>
-              <a:off x="8375142" y="3711892"/>
-              <a:ext cx="2930595" cy="264033"/>
-            </a:xfrm>
-            <a:prstGeom prst="rect">
-              <a:avLst/>
-            </a:prstGeom>
-            <a:noFill/>
-            <a:ln>
-              <a:noFill/>
-            </a:ln>
-          </p:spPr>
-          <p:txBody>
-            <a:bodyPr wrap="none" lIns="0" tIns="0" rIns="0" bIns="0" anchor="t" anchorCtr="0">
-              <a:spAutoFit/>
-            </a:bodyPr>
-            <a:lstStyle/>
-            <a:p>
-              <a:pPr algn="l"/>
-              <a:r>
-                <a:rPr lang="en-US" sz="1350" dirty="0">
+                <a:t>Q1@24 ≥ RBF-SVM@48 − 0.02</a:t>
+              </a:r>
+            </a:p>
+          </p:txBody>
+        </p:sp>
+        <p:sp>
+          <p:nvSpPr>
+            <p:cNvPr id="41" name="TextBox 41"/>
+            <p:cNvSpPr txBox="1"/>
+            <p:nvPr/>
+          </p:nvSpPr>
+          <p:spPr>
+            <a:xfrm>
+              <a:off x="7690104" y="4509135"/>
+              <a:ext cx="2750363" cy="234696"/>
+            </a:xfrm>
+            <a:prstGeom prst="rect">
+              <a:avLst/>
+            </a:prstGeom>
+            <a:noFill/>
+            <a:ln>
+              <a:noFill/>
+            </a:ln>
+          </p:spPr>
+          <p:txBody>
+            <a:bodyPr wrap="none" lIns="0" tIns="0" rIns="0" bIns="0" anchor="t" anchorCtr="0">
+              <a:spAutoFit/>
+            </a:bodyPr>
+            <a:lstStyle/>
+            <a:p>
+              <a:pPr algn="l"/>
+              <a:r>
+                <a:rPr lang="en-US" sz="1200" dirty="0">
                   <a:solidFill>
                     <a:srgbClr val="FBF7EE"/>
                   </a:solidFill>
@@ -8135,21 +8407,61 @@
                   <a:ea typeface="+mn-ea"/>
                   <a:cs typeface="+mn-cs"/>
                 </a:rPr>
-                <a:t>or show practical resource value</a:t>
-              </a:r>
-            </a:p>
-          </p:txBody>
-        </p:sp>
-        <p:sp>
-          <p:nvSpPr>
-            <p:cNvPr id="38" name="Rectangle 38"/>
+                <a:t>≥4 / 5 folds · ≤2,000 shots / image</a:t>
+              </a:r>
+            </a:p>
+          </p:txBody>
+        </p:sp>
+        <p:sp>
+          <p:nvSpPr>
+            <p:cNvPr id="42" name="TextBox 42"/>
+            <p:cNvSpPr txBox="1"/>
+            <p:nvPr/>
+          </p:nvSpPr>
+          <p:spPr>
+            <a:xfrm>
+              <a:off x="7690104" y="4728210"/>
+              <a:ext cx="1845716" cy="234696"/>
+            </a:xfrm>
+            <a:prstGeom prst="rect">
+              <a:avLst/>
+            </a:prstGeom>
+            <a:noFill/>
+            <a:ln>
+              <a:noFill/>
+            </a:ln>
+          </p:spPr>
+          <p:txBody>
+            <a:bodyPr wrap="none" lIns="0" tIns="0" rIns="0" bIns="0" anchor="t" anchorCtr="0">
+              <a:spAutoFit/>
+            </a:bodyPr>
+            <a:lstStyle/>
+            <a:p>
+              <a:pPr algn="l"/>
+              <a:r>
+                <a:rPr lang="en-US" sz="1200" dirty="0">
+                  <a:solidFill>
+                    <a:srgbClr val="FBF7EE"/>
+                  </a:solidFill>
+                  <a:latin typeface="+mn-lt"/>
+                  <a:ea typeface="+mn-ea"/>
+                  <a:cs typeface="+mn-cs"/>
+                </a:rPr>
+                <a:t>acceptance rate ≥ 0.70</a:t>
+              </a:r>
+            </a:p>
+          </p:txBody>
+        </p:sp>
+        <p:sp>
+          <p:nvSpPr>
+            <p:cNvPr id="43" name="Rectangle 43"/>
             <p:cNvSpPr/>
             <p:nvPr/>
           </p:nvSpPr>
           <p:spPr>
             <a:xfrm>
-              <a:off x="8153400" y="4171950"/>
-              <a:ext cx="3429000" cy="1447800"/>
+              <a:off x="7467600" y="5067300"/>
+              <a:ext cx="4114800" cy="552450"/>
             </a:xfrm>
             <a:prstGeom prst="rect">
               <a:avLst/>
@@ -8164,32 +8476,32 @@
         </p:sp>
         <p:sp>
           <p:nvSpPr>
-            <p:cNvPr id="39" name="TextBox 39"/>
-            <p:cNvSpPr txBox="1"/>
-            <p:nvPr/>
-          </p:nvSpPr>
-          <p:spPr>
-            <a:xfrm>
-              <a:off x="8375142" y="4350068"/>
-              <a:ext cx="1001679" cy="264033"/>
-            </a:xfrm>
-            <a:prstGeom prst="rect">
-              <a:avLst/>
-            </a:prstGeom>
-            <a:noFill/>
-            <a:ln>
-              <a:noFill/>
-            </a:ln>
-          </p:spPr>
-          <p:txBody>
-            <a:bodyPr wrap="none" lIns="0" tIns="0" rIns="0" bIns="0" anchor="t" anchorCtr="0">
-              <a:spAutoFit/>
-            </a:bodyPr>
-            <a:lstStyle/>
-            <a:p>
-              <a:pPr algn="l"/>
-              <a:r>
-                <a:rPr lang="en-US" sz="1350" b="1" dirty="0">
+            <p:cNvPr id="44" name="TextBox 44"/>
+            <p:cNvSpPr txBox="1"/>
+            <p:nvPr/>
+          </p:nvSpPr>
+          <p:spPr>
+            <a:xfrm>
+              <a:off x="7690104" y="5185410"/>
+              <a:ext cx="2377928" cy="234696"/>
+            </a:xfrm>
+            <a:prstGeom prst="rect">
+              <a:avLst/>
+            </a:prstGeom>
+            <a:noFill/>
+            <a:ln>
+              <a:noFill/>
+            </a:ln>
+          </p:spPr>
+          <p:txBody>
+            <a:bodyPr wrap="none" lIns="0" tIns="0" rIns="0" bIns="0" anchor="t" anchorCtr="0">
+              <a:spAutoFit/>
+            </a:bodyPr>
+            <a:lstStyle/>
+            <a:p>
+              <a:pPr algn="l"/>
+              <a:r>
+                <a:rPr lang="en-US" sz="1200" b="1" dirty="0">
                   <a:solidFill>
                     <a:srgbClr val="FFFFFF"/>
                   </a:solidFill>
@@ -8197,103 +8509,47 @@
                   <a:ea typeface="+mn-ea"/>
                   <a:cs typeface="+mn-cs"/>
                 </a:rPr>
-                <a:t>STOP GATE</a:t>
-              </a:r>
-            </a:p>
-          </p:txBody>
-        </p:sp>
-        <p:sp>
-          <p:nvSpPr>
-            <p:cNvPr id="40" name="TextBox 40"/>
-            <p:cNvSpPr txBox="1"/>
-            <p:nvPr/>
-          </p:nvSpPr>
-          <p:spPr>
-            <a:xfrm>
-              <a:off x="8372856" y="4663440"/>
-              <a:ext cx="2994660" cy="656844"/>
-            </a:xfrm>
-            <a:prstGeom prst="rect">
-              <a:avLst/>
-            </a:prstGeom>
-            <a:noFill/>
-            <a:ln>
-              <a:noFill/>
-            </a:ln>
-          </p:spPr>
-          <p:txBody>
-            <a:bodyPr wrap="none" lIns="0" tIns="0" rIns="0" bIns="0" anchor="t" anchorCtr="0">
-              <a:spAutoFit/>
-            </a:bodyPr>
-            <a:lstStyle/>
-            <a:p>
-              <a:pPr algn="l">
-                <a:lnSpc>
-                  <a:spcPts val="2400"/>
-                </a:lnSpc>
-              </a:pPr>
-              <a:r>
-                <a:rPr lang="en-US" sz="1800" b="1" dirty="0">
+                <a:t>STOP IF NEITHER PASS HOLDS</a:t>
+              </a:r>
+            </a:p>
+          </p:txBody>
+        </p:sp>
+        <p:sp>
+          <p:nvSpPr>
+            <p:cNvPr id="45" name="TextBox 45"/>
+            <p:cNvSpPr txBox="1"/>
+            <p:nvPr/>
+          </p:nvSpPr>
+          <p:spPr>
+            <a:xfrm>
+              <a:off x="7690485" y="5403056"/>
+              <a:ext cx="3613386" cy="220028"/>
+            </a:xfrm>
+            <a:prstGeom prst="rect">
+              <a:avLst/>
+            </a:prstGeom>
+            <a:noFill/>
+            <a:ln>
+              <a:noFill/>
+            </a:ln>
+          </p:spPr>
+          <p:txBody>
+            <a:bodyPr wrap="none" lIns="0" tIns="0" rIns="0" bIns="0" anchor="t" anchorCtr="0">
+              <a:spAutoFit/>
+            </a:bodyPr>
+            <a:lstStyle/>
+            <a:p>
+              <a:pPr algn="l"/>
+              <a:r>
+                <a:rPr lang="en-US" sz="1120" dirty="0">
                   <a:solidFill>
                     <a:srgbClr val="FFFFFF"/>
                   </a:solidFill>
-                  <a:latin typeface="+mj-lt"/>
-                  <a:ea typeface="+mj-ea"/>
-                  <a:cs typeface="+mj-cs"/>
-                </a:rPr>
-                <a:t>If Q1 only beats RFF</a:t>
-              </a:r>
-              <a:br/>
-              <a:r>
-                <a:rPr lang="en-US" sz="1800" b="1" dirty="0">
-                  <a:solidFill>
-                    <a:srgbClr val="FFFFFF"/>
-                  </a:solidFill>
-                  <a:latin typeface="+mj-lt"/>
-                  <a:ea typeface="+mj-ea"/>
-                  <a:cs typeface="+mj-cs"/>
-                </a:rPr>
-                <a:t>while strong controls win</a:t>
-              </a:r>
-            </a:p>
-          </p:txBody>
-        </p:sp>
-        <p:sp>
-          <p:nvSpPr>
-            <p:cNvPr id="41" name="TextBox 41"/>
-            <p:cNvSpPr txBox="1"/>
-            <p:nvPr/>
-          </p:nvSpPr>
-          <p:spPr>
-            <a:xfrm>
-              <a:off x="8375142" y="5245418"/>
-              <a:ext cx="2685250" cy="264033"/>
-            </a:xfrm>
-            <a:prstGeom prst="rect">
-              <a:avLst/>
-            </a:prstGeom>
-            <a:noFill/>
-            <a:ln>
-              <a:noFill/>
-            </a:ln>
-          </p:spPr>
-          <p:txBody>
-            <a:bodyPr wrap="none" lIns="0" tIns="0" rIns="0" bIns="0" anchor="t" anchorCtr="0">
-              <a:spAutoFit/>
-            </a:bodyPr>
-            <a:lstStyle/>
-            <a:p>
-              <a:pPr algn="l"/>
-              <a:r>
-                <a:rPr lang="en-US" sz="1350" b="1" dirty="0">
-                  <a:solidFill>
-                    <a:srgbClr val="FFFFFF"/>
-                  </a:solidFill>
-                  <a:latin typeface="+mn-lt"/>
-                  <a:ea typeface="+mn-ea"/>
-                  <a:cs typeface="+mn-cs"/>
-                </a:rPr>
-                <a:t>FEASIBILITY WITHOUT UTILITY</a:t>
+                  <a:latin typeface="+mn-lt"/>
+                  <a:ea typeface="+mn-ea"/>
+                  <a:cs typeface="+mn-cs"/>
+                </a:rPr>
+                <a:t>or Q1 fails both matched controls on ≥4 / 5 folds</a:t>
               </a:r>
             </a:p>
           </p:txBody>
@@ -8301,46 +8557,46 @@
       </p:grpSp>
       <p:grpSp>
         <p:nvGrpSpPr>
-          <p:cNvPr id="44" name="Group 44"/>
+          <p:cNvPr id="49" name="Group 49"/>
           <p:cNvGrpSpPr/>
           <p:nvPr/>
         </p:nvGrpSpPr>
         <p:grpSpPr>
           <a:xfrm>
-            <a:off x="602742" y="6045518"/>
-            <a:ext cx="7625560" cy="264033"/>
-            <a:chOff x="602742" y="6045518"/>
-            <a:chExt cx="7625560" cy="264033"/>
+            <a:off x="603885" y="5926931"/>
+            <a:ext cx="11046145" cy="420053"/>
+            <a:chOff x="603885" y="5926931"/>
+            <a:chExt cx="11046145" cy="420053"/>
           </a:xfrm>
         </p:grpSpPr>
         <p:sp>
           <p:nvSpPr>
-            <p:cNvPr id="43" name="TextBox 43"/>
-            <p:cNvSpPr txBox="1"/>
-            <p:nvPr/>
-          </p:nvSpPr>
-          <p:spPr>
-            <a:xfrm>
-              <a:off x="602742" y="6045518"/>
-              <a:ext cx="7625560" cy="264033"/>
-            </a:xfrm>
-            <a:prstGeom prst="rect">
-              <a:avLst/>
-            </a:prstGeom>
-            <a:noFill/>
-            <a:ln>
-              <a:noFill/>
-            </a:ln>
-          </p:spPr>
-          <p:txBody>
-            <a:bodyPr wrap="none" lIns="0" tIns="0" rIns="0" bIns="0" anchor="t" anchorCtr="0">
-              <a:spAutoFit/>
-            </a:bodyPr>
-            <a:lstStyle/>
-            <a:p>
-              <a:pPr algn="l"/>
-              <a:r>
-                <a:rPr lang="en-US" sz="1350" dirty="0">
+            <p:cNvPr id="47" name="TextBox 47"/>
+            <p:cNvSpPr txBox="1"/>
+            <p:nvPr/>
+          </p:nvSpPr>
+          <p:spPr>
+            <a:xfrm>
+              <a:off x="603885" y="5926931"/>
+              <a:ext cx="6974492" cy="220028"/>
+            </a:xfrm>
+            <a:prstGeom prst="rect">
+              <a:avLst/>
+            </a:prstGeom>
+            <a:noFill/>
+            <a:ln>
+              <a:noFill/>
+            </a:ln>
+          </p:spPr>
+          <p:txBody>
+            <a:bodyPr wrap="none" lIns="0" tIns="0" rIns="0" bIns="0" anchor="t" anchorCtr="0">
+              <a:spAutoFit/>
+            </a:bodyPr>
+            <a:lstStyle/>
+            <a:p>
+              <a:pPr algn="l"/>
+              <a:r>
+                <a:rPr lang="en-US" sz="1120" dirty="0">
                   <a:solidFill>
                     <a:srgbClr val="766E62"/>
                   </a:solidFill>
@@ -8348,7 +8604,47 @@
                   <a:ea typeface="+mn-ea"/>
                   <a:cs typeface="+mn-cs"/>
                 </a:rPr>
-                <a:t>Source: frozen experiment protocol · repeated evaluations share one outer test fold</a:t>
+                <a:t>Matched 15-D controls: Random Fourier Features (RFF) and Extreme Learning Machine (ELM).</a:t>
+              </a:r>
+            </a:p>
+          </p:txBody>
+        </p:sp>
+        <p:sp>
+          <p:nvSpPr>
+            <p:cNvPr id="48" name="TextBox 48"/>
+            <p:cNvSpPr txBox="1"/>
+            <p:nvPr/>
+          </p:nvSpPr>
+          <p:spPr>
+            <a:xfrm>
+              <a:off x="603885" y="6126956"/>
+              <a:ext cx="11046145" cy="220028"/>
+            </a:xfrm>
+            <a:prstGeom prst="rect">
+              <a:avLst/>
+            </a:prstGeom>
+            <a:noFill/>
+            <a:ln>
+              <a:noFill/>
+            </a:ln>
+          </p:spPr>
+          <p:txBody>
+            <a:bodyPr wrap="none" lIns="0" tIns="0" rIns="0" bIns="0" anchor="t" anchorCtr="0">
+              <a:spAutoFit/>
+            </a:bodyPr>
+            <a:lstStyle/>
+            <a:p>
+              <a:pPr algn="l"/>
+              <a:r>
+                <a:rPr lang="en-US" sz="1120" dirty="0">
+                  <a:solidFill>
+                    <a:srgbClr val="766E62"/>
+                  </a:solidFill>
+                  <a:latin typeface="+mn-lt"/>
+                  <a:ea typeface="+mn-ea"/>
+                  <a:cs typeface="+mn-cs"/>
+                </a:rPr>
+                <a:t>RBF-SVM = radial-basis-function support vector machine. Resource value is pre-specified as label efficiency under shot and acceptance constraints.</a:t>
               </a:r>
             </a:p>
           </p:txBody>
@@ -8356,7 +8652,7 @@
       </p:grpSp>
       <p:grpSp>
         <p:nvGrpSpPr>
-          <p:cNvPr id="46" name="Group 46"/>
+          <p:cNvPr id="51" name="Group 51"/>
           <p:cNvGrpSpPr/>
           <p:nvPr/>
         </p:nvGrpSpPr>
@@ -8370,7 +8666,7 @@
         </p:grpSpPr>
         <p:sp>
           <p:nvSpPr>
-            <p:cNvPr id="45" name="TextBox 45"/>
+            <p:cNvPr id="50" name="TextBox 50"/>
             <p:cNvSpPr txBox="1"/>
             <p:nvPr/>
           </p:nvSpPr>
@@ -8510,7 +8806,7 @@
               <a:r>
                 <a:rPr lang="en-US" sz="1350" b="1" spc="105" dirty="0">
                   <a:solidFill>
-                    <a:schemeClr val="accent3"/>
+                    <a:schemeClr val="accent6"/>
                   </a:solidFill>
                   <a:latin typeface="+mn-lt"/>
                   <a:ea typeface="+mn-ea"/>
@@ -9152,7 +9448,7 @@
               <a:r>
                 <a:rPr lang="en-US" sz="1350" b="1" dirty="0">
                   <a:solidFill>
-                    <a:schemeClr val="accent2"/>
+                    <a:schemeClr val="accent5"/>
                   </a:solidFill>
                   <a:latin typeface="+mn-lt"/>
                   <a:ea typeface="+mn-ea"/>
@@ -9248,7 +9544,7 @@
               <a:r>
                 <a:rPr lang="en-US" sz="1200" b="1" dirty="0">
                   <a:solidFill>
-                    <a:schemeClr val="accent3"/>
+                    <a:schemeClr val="accent6"/>
                   </a:solidFill>
                   <a:latin typeface="+mn-lt"/>
                   <a:ea typeface="+mn-ea"/>
@@ -9328,7 +9624,7 @@
               <a:r>
                 <a:rPr lang="en-US" sz="1200" b="1" dirty="0">
                   <a:solidFill>
-                    <a:schemeClr val="accent2"/>
+                    <a:schemeClr val="accent5"/>
                   </a:solidFill>
                   <a:latin typeface="+mn-lt"/>
                   <a:ea typeface="+mn-ea"/>
@@ -9764,7 +10060,7 @@
               <a:r>
                 <a:rPr lang="en-US" sz="1350" b="1" dirty="0">
                   <a:solidFill>
-                    <a:schemeClr val="accent2"/>
+                    <a:schemeClr val="accent5"/>
                   </a:solidFill>
                   <a:latin typeface="+mn-lt"/>
                   <a:ea typeface="+mn-ea"/>
@@ -9860,7 +10156,7 @@
               <a:r>
                 <a:rPr lang="en-US" sz="1200" b="1" dirty="0">
                   <a:solidFill>
-                    <a:schemeClr val="accent3"/>
+                    <a:schemeClr val="accent6"/>
                   </a:solidFill>
                   <a:latin typeface="+mn-lt"/>
                   <a:ea typeface="+mn-ea"/>
@@ -9940,7 +10236,7 @@
               <a:r>
                 <a:rPr lang="en-US" sz="1200" b="1" dirty="0">
                   <a:solidFill>
-                    <a:schemeClr val="accent2"/>
+                    <a:schemeClr val="accent5"/>
                   </a:solidFill>
                   <a:latin typeface="+mn-lt"/>
                   <a:ea typeface="+mn-ea"/>
@@ -10357,7 +10653,7 @@
               <a:r>
                 <a:rPr lang="en-US" sz="1350" b="1" dirty="0">
                   <a:solidFill>
-                    <a:schemeClr val="accent2"/>
+                    <a:schemeClr val="accent5"/>
                   </a:solidFill>
                   <a:latin typeface="+mn-lt"/>
                   <a:ea typeface="+mn-ea"/>
@@ -10453,7 +10749,7 @@
               <a:r>
                 <a:rPr lang="en-US" sz="1200" b="1" dirty="0">
                   <a:solidFill>
-                    <a:schemeClr val="accent3"/>
+                    <a:schemeClr val="accent6"/>
                   </a:solidFill>
                   <a:latin typeface="+mn-lt"/>
                   <a:ea typeface="+mn-ea"/>
@@ -10533,7 +10829,7 @@
               <a:r>
                 <a:rPr lang="en-US" sz="1200" b="1" dirty="0">
                   <a:solidFill>
-                    <a:schemeClr val="accent2"/>
+                    <a:schemeClr val="accent5"/>
                   </a:solidFill>
                   <a:latin typeface="+mn-lt"/>
                   <a:ea typeface="+mn-ea"/>
@@ -11128,7 +11424,7 @@
               <a:r>
                 <a:rPr lang="en-US" sz="1350" b="1" spc="105" dirty="0">
                   <a:solidFill>
-                    <a:schemeClr val="accent3"/>
+                    <a:schemeClr val="accent6"/>
                   </a:solidFill>
                   <a:latin typeface="+mn-lt"/>
                   <a:ea typeface="+mn-ea"/>
@@ -11284,7 +11580,7 @@
               <a:r>
                 <a:rPr lang="en-US" sz="1350" b="1" dirty="0">
                   <a:solidFill>
-                    <a:schemeClr val="accent2"/>
+                    <a:schemeClr val="accent5"/>
                   </a:solidFill>
                   <a:latin typeface="+mn-lt"/>
                   <a:ea typeface="+mn-ea"/>
@@ -11364,7 +11660,7 @@
               <a:r>
                 <a:rPr lang="en-US" sz="2250" b="1" dirty="0">
                   <a:solidFill>
-                    <a:schemeClr val="accent2"/>
+                    <a:schemeClr val="accent5"/>
                   </a:solidFill>
                   <a:latin typeface="Consolas"/>
                   <a:ea typeface="Consolas"/>
@@ -11480,7 +11776,7 @@
               <a:r>
                 <a:rPr lang="en-US" sz="1350" b="1" dirty="0">
                   <a:solidFill>
-                    <a:schemeClr val="accent3"/>
+                    <a:schemeClr val="accent6"/>
                   </a:solidFill>
                   <a:latin typeface="+mn-lt"/>
                   <a:ea typeface="+mn-ea"/>
@@ -11560,7 +11856,7 @@
               <a:r>
                 <a:rPr lang="en-US" sz="2250" b="1" dirty="0">
                   <a:solidFill>
-                    <a:schemeClr val="accent3"/>
+                    <a:schemeClr val="accent6"/>
                   </a:solidFill>
                   <a:latin typeface="Consolas"/>
                   <a:ea typeface="Consolas"/>
@@ -11937,7 +12233,7 @@
               <a:r>
                 <a:rPr lang="en-US" sz="1350" b="1" spc="105" dirty="0">
                   <a:solidFill>
-                    <a:schemeClr val="accent3"/>
+                    <a:schemeClr val="accent6"/>
                   </a:solidFill>
                   <a:latin typeface="+mn-lt"/>
                   <a:ea typeface="+mn-ea"/>
@@ -12059,9 +12355,9 @@
         <p:grpSpPr>
           <a:xfrm>
             <a:off x="7761732" y="1664018"/>
-            <a:ext cx="3820668" cy="3679888"/>
+            <a:ext cx="3820668" cy="3673316"/>
             <a:chOff x="7761732" y="1664018"/>
-            <a:chExt cx="3820668" cy="3679888"/>
+            <a:chExt cx="3820668" cy="3673316"/>
           </a:xfrm>
         </p:grpSpPr>
         <p:sp>
@@ -12093,7 +12389,7 @@
               <a:r>
                 <a:rPr lang="en-US" sz="1350" b="1" dirty="0">
                   <a:solidFill>
-                    <a:schemeClr val="accent2"/>
+                    <a:schemeClr val="accent5"/>
                   </a:solidFill>
                   <a:latin typeface="+mn-lt"/>
                   <a:ea typeface="+mn-ea"/>
@@ -12419,7 +12715,7 @@
           <p:spPr>
             <a:xfrm>
               <a:off x="7994142" y="4540568"/>
-              <a:ext cx="1455336" cy="264033"/>
+              <a:ext cx="1939237" cy="264033"/>
             </a:xfrm>
             <a:prstGeom prst="rect">
               <a:avLst/>
@@ -12445,7 +12741,7 @@
                   <a:ea typeface="+mn-ea"/>
                   <a:cs typeface="+mn-cs"/>
                 </a:rPr>
-                <a:t>Q1 − PCA-5 RBF</a:t>
+                <a:t>Q1 − PCA-5 RBF-SVM</a:t>
               </a:r>
             </a:p>
           </p:txBody>
@@ -12498,26 +12794,26 @@
           </p:nvSpPr>
           <p:spPr>
             <a:xfrm>
-              <a:off x="7994904" y="5109210"/>
-              <a:ext cx="3507528" cy="234696"/>
-            </a:xfrm>
-            <a:prstGeom prst="rect">
-              <a:avLst/>
-            </a:prstGeom>
-            <a:noFill/>
-            <a:ln>
-              <a:noFill/>
-            </a:ln>
-          </p:spPr>
-          <p:txBody>
-            <a:bodyPr wrap="none" lIns="0" tIns="0" rIns="0" bIns="0" anchor="t" anchorCtr="0">
-              <a:spAutoFit/>
-            </a:bodyPr>
-            <a:lstStyle/>
-            <a:p>
-              <a:pPr algn="l"/>
-              <a:r>
-                <a:rPr lang="en-US" sz="1200" dirty="0">
+              <a:off x="7995285" y="5117306"/>
+              <a:ext cx="3419539" cy="220028"/>
+            </a:xfrm>
+            <a:prstGeom prst="rect">
+              <a:avLst/>
+            </a:prstGeom>
+            <a:noFill/>
+            <a:ln>
+              <a:noFill/>
+            </a:ln>
+          </p:spPr>
+          <p:txBody>
+            <a:bodyPr wrap="none" lIns="0" tIns="0" rIns="0" bIns="0" anchor="t" anchorCtr="0">
+              <a:spAutoFit/>
+            </a:bodyPr>
+            <a:lstStyle/>
+            <a:p>
+              <a:pPr algn="l"/>
+              <a:r>
+                <a:rPr lang="en-US" sz="1120" dirty="0">
                   <a:solidFill>
                     <a:srgbClr val="B9D0C7"/>
                   </a:solidFill>
@@ -12525,7 +12821,7 @@
                   <a:ea typeface="+mn-ea"/>
                   <a:cs typeface="+mn-cs"/>
                 </a:rPr>
-                <a:t>Q1 only wins against the weak matched map.</a:t>
+                <a:t>Only win: locked matched RFF-15 comparator.</a:t>
               </a:r>
             </a:p>
           </p:txBody>
@@ -12819,7 +13115,7 @@
               <a:r>
                 <a:rPr lang="en-US" sz="1350" b="1" spc="105" dirty="0">
                   <a:solidFill>
-                    <a:schemeClr val="accent3"/>
+                    <a:schemeClr val="accent6"/>
                   </a:solidFill>
                   <a:latin typeface="+mn-lt"/>
                   <a:ea typeface="+mn-ea"/>
@@ -12873,7 +13169,7 @@
       </p:grpSp>
       <p:grpSp>
         <p:nvGrpSpPr>
-          <p:cNvPr id="8" name="Group 8"/>
+          <p:cNvPr id="12" name="Group 12"/>
           <p:cNvGrpSpPr/>
           <p:nvPr/>
         </p:nvGrpSpPr>
@@ -12931,10 +13227,138 @@
             </a:prstGeom>
           </p:spPr>
         </p:pic>
+        <p:sp>
+          <p:nvSpPr>
+            <p:cNvPr id="8" name="Rectangle 8"/>
+            <p:cNvSpPr/>
+            <p:nvPr/>
+          </p:nvSpPr>
+          <p:spPr>
+            <a:xfrm>
+              <a:off x="4762500" y="2228850"/>
+              <a:ext cx="1200150" cy="238125"/>
+            </a:xfrm>
+            <a:prstGeom prst="rect">
+              <a:avLst/>
+            </a:prstGeom>
+            <a:solidFill>
+              <a:srgbClr val="FFFFFF">
+                <a:alpha val="92000"/>
+              </a:srgbClr>
+            </a:solidFill>
+            <a:ln>
+              <a:noFill/>
+            </a:ln>
+          </p:spPr>
+        </p:sp>
+        <p:sp>
+          <p:nvSpPr>
+            <p:cNvPr id="9" name="TextBox 9"/>
+            <p:cNvSpPr txBox="1"/>
+            <p:nvPr/>
+          </p:nvSpPr>
+          <p:spPr>
+            <a:xfrm>
+              <a:off x="4832604" y="2280285"/>
+              <a:ext cx="872460" cy="234696"/>
+            </a:xfrm>
+            <a:prstGeom prst="rect">
+              <a:avLst/>
+            </a:prstGeom>
+            <a:noFill/>
+            <a:ln>
+              <a:noFill/>
+            </a:ln>
+          </p:spPr>
+          <p:txBody>
+            <a:bodyPr wrap="none" lIns="0" tIns="0" rIns="0" bIns="0" anchor="t" anchorCtr="0">
+              <a:spAutoFit/>
+            </a:bodyPr>
+            <a:lstStyle/>
+            <a:p>
+              <a:pPr algn="l"/>
+              <a:r>
+                <a:rPr lang="en-US" sz="1200" b="1" dirty="0">
+                  <a:solidFill>
+                    <a:schemeClr val="accent6"/>
+                  </a:solidFill>
+                  <a:latin typeface="+mn-lt"/>
+                  <a:ea typeface="+mn-ea"/>
+                  <a:cs typeface="+mn-cs"/>
+                </a:rPr>
+                <a:t>MACRO-F1</a:t>
+              </a:r>
+            </a:p>
+          </p:txBody>
+        </p:sp>
+        <p:sp>
+          <p:nvSpPr>
+            <p:cNvPr id="10" name="Rectangle 10"/>
+            <p:cNvSpPr/>
+            <p:nvPr/>
+          </p:nvSpPr>
+          <p:spPr>
+            <a:xfrm>
+              <a:off x="4762500" y="2533650"/>
+              <a:ext cx="1600200" cy="238125"/>
+            </a:xfrm>
+            <a:prstGeom prst="rect">
+              <a:avLst/>
+            </a:prstGeom>
+            <a:solidFill>
+              <a:srgbClr val="FFFFFF">
+                <a:alpha val="92000"/>
+              </a:srgbClr>
+            </a:solidFill>
+            <a:ln>
+              <a:noFill/>
+            </a:ln>
+          </p:spPr>
+        </p:sp>
+        <p:sp>
+          <p:nvSpPr>
+            <p:cNvPr id="11" name="TextBox 11"/>
+            <p:cNvSpPr txBox="1"/>
+            <p:nvPr/>
+          </p:nvSpPr>
+          <p:spPr>
+            <a:xfrm>
+              <a:off x="4832604" y="2585085"/>
+              <a:ext cx="1445971" cy="234696"/>
+            </a:xfrm>
+            <a:prstGeom prst="rect">
+              <a:avLst/>
+            </a:prstGeom>
+            <a:noFill/>
+            <a:ln>
+              <a:noFill/>
+            </a:ln>
+          </p:spPr>
+          <p:txBody>
+            <a:bodyPr wrap="none" lIns="0" tIns="0" rIns="0" bIns="0" anchor="t" anchorCtr="0">
+              <a:spAutoFit/>
+            </a:bodyPr>
+            <a:lstStyle/>
+            <a:p>
+              <a:pPr algn="l"/>
+              <a:r>
+                <a:rPr lang="en-US" sz="1200" b="1" dirty="0">
+                  <a:solidFill>
+                    <a:schemeClr val="accent5"/>
+                  </a:solidFill>
+                  <a:latin typeface="+mn-lt"/>
+                  <a:ea typeface="+mn-ea"/>
+                  <a:cs typeface="+mn-cs"/>
+                </a:rPr>
+                <a:t>ACCEPTANCE RATE</a:t>
+              </a:r>
+            </a:p>
+          </p:txBody>
+        </p:sp>
       </p:grpSp>
       <p:grpSp>
         <p:nvGrpSpPr>
-          <p:cNvPr id="25" name="Group 25"/>
+          <p:cNvPr id="29" name="Group 29"/>
           <p:cNvGrpSpPr/>
           <p:nvPr/>
         </p:nvGrpSpPr>
@@ -12948,7 +13372,7 @@
         </p:grpSpPr>
         <p:sp>
           <p:nvSpPr>
-            <p:cNvPr id="9" name="TextBox 9"/>
+            <p:cNvPr id="13" name="TextBox 13"/>
             <p:cNvSpPr txBox="1"/>
             <p:nvPr/>
           </p:nvSpPr>
@@ -12975,7 +13399,7 @@
               <a:r>
                 <a:rPr lang="en-US" sz="1350" b="1" dirty="0">
                   <a:solidFill>
-                    <a:schemeClr val="accent2"/>
+                    <a:schemeClr val="accent5"/>
                   </a:solidFill>
                   <a:latin typeface="+mn-lt"/>
                   <a:ea typeface="+mn-ea"/>
@@ -12988,7 +13412,7 @@
         </p:sp>
         <p:sp>
           <p:nvSpPr>
-            <p:cNvPr id="10" name="TextBox 10"/>
+            <p:cNvPr id="14" name="TextBox 14"/>
             <p:cNvSpPr txBox="1"/>
             <p:nvPr/>
           </p:nvSpPr>
@@ -13028,7 +13452,7 @@
         </p:sp>
         <p:sp>
           <p:nvSpPr>
-            <p:cNvPr id="11" name="TextBox 11"/>
+            <p:cNvPr id="15" name="TextBox 15"/>
             <p:cNvSpPr txBox="1"/>
             <p:nvPr/>
           </p:nvSpPr>
@@ -13068,7 +13492,7 @@
         </p:sp>
         <p:sp>
           <p:nvSpPr>
-            <p:cNvPr id="12" name="TextBox 12"/>
+            <p:cNvPr id="16" name="TextBox 16"/>
             <p:cNvSpPr txBox="1"/>
             <p:nvPr/>
           </p:nvSpPr>
@@ -13108,7 +13532,7 @@
         </p:sp>
         <p:sp>
           <p:nvSpPr>
-            <p:cNvPr id="13" name="TextBox 13"/>
+            <p:cNvPr id="17" name="TextBox 17"/>
             <p:cNvSpPr txBox="1"/>
             <p:nvPr/>
           </p:nvSpPr>
@@ -13148,7 +13572,7 @@
         </p:sp>
         <p:sp>
           <p:nvSpPr>
-            <p:cNvPr id="14" name="TextBox 14"/>
+            <p:cNvPr id="18" name="TextBox 18"/>
             <p:cNvSpPr txBox="1"/>
             <p:nvPr/>
           </p:nvSpPr>
@@ -13188,7 +13612,7 @@
         </p:sp>
         <p:sp>
           <p:nvSpPr>
-            <p:cNvPr id="15" name="TextBox 15"/>
+            <p:cNvPr id="19" name="TextBox 19"/>
             <p:cNvSpPr txBox="1"/>
             <p:nvPr/>
           </p:nvSpPr>
@@ -13228,7 +13652,7 @@
         </p:sp>
         <p:sp>
           <p:nvSpPr>
-            <p:cNvPr id="16" name="Rectangle 16"/>
+            <p:cNvPr id="20" name="Rectangle 20"/>
             <p:cNvSpPr/>
             <p:nvPr/>
           </p:nvSpPr>
@@ -13250,7 +13674,7 @@
         </p:sp>
         <p:sp>
           <p:nvSpPr>
-            <p:cNvPr id="17" name="TextBox 17"/>
+            <p:cNvPr id="21" name="TextBox 21"/>
             <p:cNvSpPr txBox="1"/>
             <p:nvPr/>
           </p:nvSpPr>
@@ -13290,7 +13714,7 @@
         </p:sp>
         <p:sp>
           <p:nvSpPr>
-            <p:cNvPr id="18" name="TextBox 18"/>
+            <p:cNvPr id="22" name="TextBox 22"/>
             <p:cNvSpPr txBox="1"/>
             <p:nvPr/>
           </p:nvSpPr>
@@ -13330,7 +13754,7 @@
         </p:sp>
         <p:sp>
           <p:nvSpPr>
-            <p:cNvPr id="19" name="Rectangle 19"/>
+            <p:cNvPr id="23" name="Rectangle 23"/>
             <p:cNvSpPr/>
             <p:nvPr/>
           </p:nvSpPr>
@@ -13352,7 +13776,7 @@
         </p:sp>
         <p:sp>
           <p:nvSpPr>
-            <p:cNvPr id="20" name="TextBox 20"/>
+            <p:cNvPr id="24" name="TextBox 24"/>
             <p:cNvSpPr txBox="1"/>
             <p:nvPr/>
           </p:nvSpPr>
@@ -13379,7 +13803,7 @@
               <a:r>
                 <a:rPr lang="en-US" sz="1350" b="1" dirty="0">
                   <a:solidFill>
-                    <a:schemeClr val="accent3"/>
+                    <a:schemeClr val="accent6"/>
                   </a:solidFill>
                   <a:latin typeface="+mn-lt"/>
                   <a:ea typeface="+mn-ea"/>
@@ -13392,7 +13816,7 @@
         </p:sp>
         <p:sp>
           <p:nvSpPr>
-            <p:cNvPr id="21" name="TextBox 21"/>
+            <p:cNvPr id="25" name="TextBox 25"/>
             <p:cNvSpPr txBox="1"/>
             <p:nvPr/>
           </p:nvSpPr>
@@ -13460,7 +13884,7 @@
         </p:sp>
         <p:sp>
           <p:nvSpPr>
-            <p:cNvPr id="22" name="Rectangle 22"/>
+            <p:cNvPr id="26" name="Rectangle 26"/>
             <p:cNvSpPr/>
             <p:nvPr/>
           </p:nvSpPr>
@@ -13482,7 +13906,7 @@
         </p:sp>
         <p:sp>
           <p:nvSpPr>
-            <p:cNvPr id="23" name="TextBox 23"/>
+            <p:cNvPr id="27" name="TextBox 27"/>
             <p:cNvSpPr txBox="1"/>
             <p:nvPr/>
           </p:nvSpPr>
@@ -13509,7 +13933,7 @@
               <a:r>
                 <a:rPr lang="en-US" sz="1350" b="1" dirty="0">
                   <a:solidFill>
-                    <a:schemeClr val="accent2"/>
+                    <a:schemeClr val="accent5"/>
                   </a:solidFill>
                   <a:latin typeface="+mn-lt"/>
                   <a:ea typeface="+mn-ea"/>
@@ -13522,7 +13946,7 @@
         </p:sp>
         <p:sp>
           <p:nvSpPr>
-            <p:cNvPr id="24" name="TextBox 24"/>
+            <p:cNvPr id="28" name="TextBox 28"/>
             <p:cNvSpPr txBox="1"/>
             <p:nvPr/>
           </p:nvSpPr>
@@ -13591,46 +14015,46 @@
       </p:grpSp>
       <p:grpSp>
         <p:nvGrpSpPr>
-          <p:cNvPr id="27" name="Group 27"/>
+          <p:cNvPr id="31" name="Group 31"/>
           <p:cNvGrpSpPr/>
           <p:nvPr/>
         </p:nvGrpSpPr>
         <p:grpSpPr>
           <a:xfrm>
-            <a:off x="602742" y="6045518"/>
-            <a:ext cx="5347697" cy="264033"/>
-            <a:chOff x="602742" y="6045518"/>
-            <a:chExt cx="5347697" cy="264033"/>
+            <a:off x="603504" y="6061710"/>
+            <a:ext cx="8848649" cy="234696"/>
+            <a:chOff x="603504" y="6061710"/>
+            <a:chExt cx="8848649" cy="234696"/>
           </a:xfrm>
         </p:grpSpPr>
         <p:sp>
           <p:nvSpPr>
-            <p:cNvPr id="26" name="TextBox 26"/>
-            <p:cNvSpPr txBox="1"/>
-            <p:nvPr/>
-          </p:nvSpPr>
-          <p:spPr>
-            <a:xfrm>
-              <a:off x="602742" y="6045518"/>
-              <a:ext cx="5347697" cy="264033"/>
-            </a:xfrm>
-            <a:prstGeom prst="rect">
-              <a:avLst/>
-            </a:prstGeom>
-            <a:noFill/>
-            <a:ln>
-              <a:noFill/>
-            </a:ln>
-          </p:spPr>
-          <p:txBody>
-            <a:bodyPr wrap="none" lIns="0" tIns="0" rIns="0" bIns="0" anchor="t" anchorCtr="0">
-              <a:spAutoFit/>
-            </a:bodyPr>
-            <a:lstStyle/>
-            <a:p>
-              <a:pPr algn="l"/>
-              <a:r>
-                <a:rPr lang="en-US" sz="1350" dirty="0">
+            <p:cNvPr id="30" name="TextBox 30"/>
+            <p:cNvSpPr txBox="1"/>
+            <p:nvPr/>
+          </p:nvSpPr>
+          <p:spPr>
+            <a:xfrm>
+              <a:off x="603504" y="6061710"/>
+              <a:ext cx="8848649" cy="234696"/>
+            </a:xfrm>
+            <a:prstGeom prst="rect">
+              <a:avLst/>
+            </a:prstGeom>
+            <a:noFill/>
+            <a:ln>
+              <a:noFill/>
+            </a:ln>
+          </p:spPr>
+          <p:txBody>
+            <a:bodyPr wrap="none" lIns="0" tIns="0" rIns="0" bIns="0" anchor="t" anchorCtr="0">
+              <a:spAutoFit/>
+            </a:bodyPr>
+            <a:lstStyle/>
+            <a:p>
+              <a:pPr algn="l"/>
+              <a:r>
+                <a:rPr lang="en-US" sz="1200" dirty="0">
                   <a:solidFill>
                     <a:srgbClr val="766E62"/>
                   </a:solidFill>
@@ -13638,7 +14062,7 @@
                   <a:ea typeface="+mn-ea"/>
                   <a:cs typeface="+mn-cs"/>
                 </a:rPr>
-                <a:t>45 sampled-inference evaluations · source: finite_shot.csv</a:t>
+                <a:t>45 evaluations = 3 map seeds × 5 sampling seeds × 3 shot levels · same outer test fold · source: finite_shot.csv</a:t>
               </a:r>
             </a:p>
           </p:txBody>
@@ -13646,7 +14070,7 @@
       </p:grpSp>
       <p:grpSp>
         <p:nvGrpSpPr>
-          <p:cNvPr id="29" name="Group 29"/>
+          <p:cNvPr id="33" name="Group 33"/>
           <p:cNvGrpSpPr/>
           <p:nvPr/>
         </p:nvGrpSpPr>
@@ -13660,7 +14084,7 @@
         </p:grpSpPr>
         <p:sp>
           <p:nvSpPr>
-            <p:cNvPr id="28" name="TextBox 28"/>
+            <p:cNvPr id="32" name="TextBox 32"/>
             <p:cNvSpPr txBox="1"/>
             <p:nvPr/>
           </p:nvSpPr>
@@ -13800,7 +14224,7 @@
               <a:r>
                 <a:rPr lang="en-US" sz="1350" b="1" spc="105" dirty="0">
                   <a:solidFill>
-                    <a:schemeClr val="accent3"/>
+                    <a:schemeClr val="accent6"/>
                   </a:solidFill>
                   <a:latin typeface="+mn-lt"/>
                   <a:ea typeface="+mn-ea"/>
@@ -14257,7 +14681,7 @@
               <a:r>
                 <a:rPr lang="en-US" sz="1350" b="1" dirty="0">
                   <a:solidFill>
-                    <a:schemeClr val="accent2"/>
+                    <a:schemeClr val="accent5"/>
                   </a:solidFill>
                   <a:latin typeface="+mn-lt"/>
                   <a:ea typeface="+mn-ea"/>
@@ -14379,7 +14803,7 @@
       </p:grpSp>
       <p:grpSp>
         <p:nvGrpSpPr>
-          <p:cNvPr id="33" name="Group 33"/>
+          <p:cNvPr id="34" name="Group 34"/>
           <p:cNvGrpSpPr/>
           <p:nvPr/>
         </p:nvGrpSpPr>
@@ -14400,53 +14824,7 @@
           <p:spPr>
             <a:xfrm>
               <a:off x="609600" y="4057650"/>
-              <a:ext cx="3657600" cy="1733550"/>
-            </a:xfrm>
-            <a:prstGeom prst="rect">
-              <a:avLst/>
-            </a:prstGeom>
-            <a:solidFill>
-              <a:srgbClr val="FFFFFF"/>
-            </a:solidFill>
-            <a:ln>
-              <a:noFill/>
-            </a:ln>
-          </p:spPr>
-        </p:sp>
-        <p:pic>
-          <p:nvPicPr>
-            <p:cNvPr id="20" name="Image 20"/>
-            <p:cNvPicPr>
-              <a:picLocks noChangeAspect="1"/>
-            </p:cNvPicPr>
-            <p:nvPr/>
-          </p:nvPicPr>
-          <p:blipFill>
-            <a:blip r:embed="rId2"/>
-            <a:stretch>
-              <a:fillRect/>
-            </a:stretch>
-          </p:blipFill>
-          <p:spPr>
-            <a:xfrm>
-              <a:off x="1041471" y="4171950"/>
-              <a:ext cx="2793857" cy="1504950"/>
-            </a:xfrm>
-            <a:prstGeom prst="rect">
-              <a:avLst/>
-            </a:prstGeom>
-          </p:spPr>
-        </p:pic>
-        <p:sp>
-          <p:nvSpPr>
-            <p:cNvPr id="21" name="Rectangle 21"/>
-            <p:cNvSpPr/>
-            <p:nvPr/>
-          </p:nvSpPr>
-          <p:spPr>
-            <a:xfrm>
-              <a:off x="4495800" y="4057650"/>
-              <a:ext cx="2895600" cy="1733550"/>
+              <a:ext cx="3352800" cy="1733550"/>
             </a:xfrm>
             <a:prstGeom prst="rect">
               <a:avLst/>
@@ -14461,112 +14839,72 @@
         </p:sp>
         <p:sp>
           <p:nvSpPr>
-            <p:cNvPr id="22" name="TextBox 22"/>
-            <p:cNvSpPr txBox="1"/>
-            <p:nvPr/>
-          </p:nvSpPr>
-          <p:spPr>
-            <a:xfrm>
-              <a:off x="4717542" y="4245292"/>
-              <a:ext cx="1656961" cy="264033"/>
-            </a:xfrm>
-            <a:prstGeom prst="rect">
-              <a:avLst/>
-            </a:prstGeom>
-            <a:noFill/>
-            <a:ln>
-              <a:noFill/>
-            </a:ln>
-          </p:spPr>
-          <p:txBody>
-            <a:bodyPr wrap="none" lIns="0" tIns="0" rIns="0" bIns="0" anchor="t" anchorCtr="0">
-              <a:spAutoFit/>
-            </a:bodyPr>
-            <a:lstStyle/>
-            <a:p>
-              <a:pPr algn="l"/>
-              <a:r>
-                <a:rPr lang="en-US" sz="1350" b="1" dirty="0">
-                  <a:solidFill>
-                    <a:schemeClr val="accent3"/>
-                  </a:solidFill>
-                  <a:latin typeface="+mn-lt"/>
-                  <a:ea typeface="+mn-ea"/>
-                  <a:cs typeface="+mn-cs"/>
-                </a:rPr>
-                <a:t>MEASURED ON CPU</a:t>
-              </a:r>
-            </a:p>
-          </p:txBody>
-        </p:sp>
-        <p:sp>
-          <p:nvSpPr>
-            <p:cNvPr id="23" name="TextBox 23"/>
-            <p:cNvSpPr txBox="1"/>
-            <p:nvPr/>
-          </p:nvSpPr>
-          <p:spPr>
-            <a:xfrm>
-              <a:off x="4716780" y="4695825"/>
-              <a:ext cx="1696798" cy="293370"/>
-            </a:xfrm>
-            <a:prstGeom prst="rect">
-              <a:avLst/>
-            </a:prstGeom>
-            <a:noFill/>
-            <a:ln>
-              <a:noFill/>
-            </a:ln>
-          </p:spPr>
-          <p:txBody>
-            <a:bodyPr wrap="none" lIns="0" tIns="0" rIns="0" bIns="0" anchor="t" anchorCtr="0">
-              <a:spAutoFit/>
-            </a:bodyPr>
-            <a:lstStyle/>
-            <a:p>
-              <a:pPr algn="l"/>
-              <a:r>
-                <a:rPr lang="en-US" sz="1500" dirty="0">
-                  <a:solidFill>
-                    <a:schemeClr val="dk1"/>
-                  </a:solidFill>
-                  <a:latin typeface="+mn-lt"/>
-                  <a:ea typeface="+mn-ea"/>
-                  <a:cs typeface="+mn-cs"/>
-                </a:rPr>
-                <a:t>OpenCLIP embed.</a:t>
-              </a:r>
-            </a:p>
-          </p:txBody>
-        </p:sp>
-        <p:sp>
-          <p:nvSpPr>
-            <p:cNvPr id="24" name="TextBox 24"/>
-            <p:cNvSpPr txBox="1"/>
-            <p:nvPr/>
-          </p:nvSpPr>
-          <p:spPr>
-            <a:xfrm>
-              <a:off x="6278792" y="4671536"/>
-              <a:ext cx="892771" cy="337376"/>
-            </a:xfrm>
-            <a:prstGeom prst="rect">
-              <a:avLst/>
-            </a:prstGeom>
-            <a:noFill/>
-            <a:ln>
-              <a:noFill/>
-            </a:ln>
-          </p:spPr>
-          <p:txBody>
-            <a:bodyPr wrap="none" lIns="0" tIns="0" rIns="0" bIns="0" anchor="t" anchorCtr="0">
-              <a:spAutoFit/>
-            </a:bodyPr>
-            <a:lstStyle/>
-            <a:p>
-              <a:pPr algn="r"/>
-              <a:r>
-                <a:rPr lang="en-US" sz="1720" b="1" dirty="0">
+            <p:cNvPr id="20" name="TextBox 20"/>
+            <p:cNvSpPr txBox="1"/>
+            <p:nvPr/>
+          </p:nvSpPr>
+          <p:spPr>
+            <a:xfrm>
+              <a:off x="831723" y="4253389"/>
+              <a:ext cx="2479054" cy="249364"/>
+            </a:xfrm>
+            <a:prstGeom prst="rect">
+              <a:avLst/>
+            </a:prstGeom>
+            <a:noFill/>
+            <a:ln>
+              <a:noFill/>
+            </a:ln>
+          </p:spPr>
+          <p:txBody>
+            <a:bodyPr wrap="none" lIns="0" tIns="0" rIns="0" bIns="0" anchor="t" anchorCtr="0">
+              <a:spAutoFit/>
+            </a:bodyPr>
+            <a:lstStyle/>
+            <a:p>
+              <a:pPr algn="l"/>
+              <a:r>
+                <a:rPr lang="en-US" sz="1280" b="1" dirty="0">
+                  <a:solidFill>
+                    <a:schemeClr val="accent6"/>
+                  </a:solidFill>
+                  <a:latin typeface="+mn-lt"/>
+                  <a:ea typeface="+mn-ea"/>
+                  <a:cs typeface="+mn-cs"/>
+                </a:rPr>
+                <a:t>OPENCLIP EMBEDDINGS · CPU</a:t>
+              </a:r>
+            </a:p>
+          </p:txBody>
+        </p:sp>
+        <p:sp>
+          <p:nvSpPr>
+            <p:cNvPr id="21" name="TextBox 21"/>
+            <p:cNvSpPr txBox="1"/>
+            <p:nvPr/>
+          </p:nvSpPr>
+          <p:spPr>
+            <a:xfrm>
+              <a:off x="820674" y="4637722"/>
+              <a:ext cx="1790631" cy="674751"/>
+            </a:xfrm>
+            <a:prstGeom prst="rect">
+              <a:avLst/>
+            </a:prstGeom>
+            <a:noFill/>
+            <a:ln>
+              <a:noFill/>
+            </a:ln>
+          </p:spPr>
+          <p:txBody>
+            <a:bodyPr wrap="none" lIns="0" tIns="0" rIns="0" bIns="0" anchor="t" anchorCtr="0">
+              <a:spAutoFit/>
+            </a:bodyPr>
+            <a:lstStyle/>
+            <a:p>
+              <a:pPr algn="l"/>
+              <a:r>
+                <a:rPr lang="en-US" sz="3450" b="1" dirty="0">
                   <a:solidFill>
                     <a:schemeClr val="accent1"/>
                   </a:solidFill>
@@ -14581,40 +14919,142 @@
         </p:sp>
         <p:sp>
           <p:nvSpPr>
+            <p:cNvPr id="22" name="TextBox 22"/>
+            <p:cNvSpPr txBox="1"/>
+            <p:nvPr/>
+          </p:nvSpPr>
+          <p:spPr>
+            <a:xfrm>
+              <a:off x="831342" y="5245418"/>
+              <a:ext cx="2218957" cy="264033"/>
+            </a:xfrm>
+            <a:prstGeom prst="rect">
+              <a:avLst/>
+            </a:prstGeom>
+            <a:noFill/>
+            <a:ln>
+              <a:noFill/>
+            </a:ln>
+          </p:spPr>
+          <p:txBody>
+            <a:bodyPr wrap="none" lIns="0" tIns="0" rIns="0" bIns="0" anchor="t" anchorCtr="0">
+              <a:spAutoFit/>
+            </a:bodyPr>
+            <a:lstStyle/>
+            <a:p>
+              <a:pPr algn="l"/>
+              <a:r>
+                <a:rPr lang="en-US" sz="1350" dirty="0">
+                  <a:solidFill>
+                    <a:schemeClr val="dk1"/>
+                  </a:solidFill>
+                  <a:latin typeface="+mn-lt"/>
+                  <a:ea typeface="+mn-ea"/>
+                  <a:cs typeface="+mn-cs"/>
+                </a:rPr>
+                <a:t>One cached feature pass</a:t>
+              </a:r>
+            </a:p>
+          </p:txBody>
+        </p:sp>
+        <p:sp>
+          <p:nvSpPr>
+            <p:cNvPr id="23" name="TextBox 23"/>
+            <p:cNvSpPr txBox="1"/>
+            <p:nvPr/>
+          </p:nvSpPr>
+          <p:spPr>
+            <a:xfrm>
+              <a:off x="832104" y="5509260"/>
+              <a:ext cx="2731618" cy="234696"/>
+            </a:xfrm>
+            <a:prstGeom prst="rect">
+              <a:avLst/>
+            </a:prstGeom>
+            <a:noFill/>
+            <a:ln>
+              <a:noFill/>
+            </a:ln>
+          </p:spPr>
+          <p:txBody>
+            <a:bodyPr wrap="none" lIns="0" tIns="0" rIns="0" bIns="0" anchor="t" anchorCtr="0">
+              <a:spAutoFit/>
+            </a:bodyPr>
+            <a:lstStyle/>
+            <a:p>
+              <a:pPr algn="l"/>
+              <a:r>
+                <a:rPr lang="en-US" sz="1200" dirty="0">
+                  <a:solidFill>
+                    <a:srgbClr val="766E62"/>
+                  </a:solidFill>
+                  <a:latin typeface="+mn-lt"/>
+                  <a:ea typeface="+mn-ea"/>
+                  <a:cs typeface="+mn-cs"/>
+                </a:rPr>
+                <a:t>Reused across every model family.</a:t>
+              </a:r>
+            </a:p>
+          </p:txBody>
+        </p:sp>
+        <p:sp>
+          <p:nvSpPr>
+            <p:cNvPr id="24" name="Rectangle 24"/>
+            <p:cNvSpPr/>
+            <p:nvPr/>
+          </p:nvSpPr>
+          <p:spPr>
+            <a:xfrm>
+              <a:off x="4191000" y="4057650"/>
+              <a:ext cx="3352800" cy="1733550"/>
+            </a:xfrm>
+            <a:prstGeom prst="rect">
+              <a:avLst/>
+            </a:prstGeom>
+            <a:solidFill>
+              <a:srgbClr val="B9D0C7"/>
+            </a:solidFill>
+            <a:ln>
+              <a:noFill/>
+            </a:ln>
+          </p:spPr>
+        </p:sp>
+        <p:sp>
+          <p:nvSpPr>
             <p:cNvPr id="25" name="TextBox 25"/>
             <p:cNvSpPr txBox="1"/>
             <p:nvPr/>
           </p:nvSpPr>
           <p:spPr>
             <a:xfrm>
-              <a:off x="4716780" y="5086350"/>
-              <a:ext cx="961807" cy="293370"/>
-            </a:xfrm>
-            <a:prstGeom prst="rect">
-              <a:avLst/>
-            </a:prstGeom>
-            <a:noFill/>
-            <a:ln>
-              <a:noFill/>
-            </a:ln>
-          </p:spPr>
-          <p:txBody>
-            <a:bodyPr wrap="none" lIns="0" tIns="0" rIns="0" bIns="0" anchor="t" anchorCtr="0">
-              <a:spAutoFit/>
-            </a:bodyPr>
-            <a:lstStyle/>
-            <a:p>
-              <a:pPr algn="l"/>
-              <a:r>
-                <a:rPr lang="en-US" sz="1500" dirty="0">
-                  <a:solidFill>
-                    <a:schemeClr val="dk1"/>
-                  </a:solidFill>
-                  <a:latin typeface="+mn-lt"/>
-                  <a:ea typeface="+mn-ea"/>
-                  <a:cs typeface="+mn-cs"/>
-                </a:rPr>
-                <a:t>R1 models</a:t>
+              <a:off x="4413123" y="4253389"/>
+              <a:ext cx="2154064" cy="249364"/>
+            </a:xfrm>
+            <a:prstGeom prst="rect">
+              <a:avLst/>
+            </a:prstGeom>
+            <a:noFill/>
+            <a:ln>
+              <a:noFill/>
+            </a:ln>
+          </p:spPr>
+          <p:txBody>
+            <a:bodyPr wrap="none" lIns="0" tIns="0" rIns="0" bIns="0" anchor="t" anchorCtr="0">
+              <a:spAutoFit/>
+            </a:bodyPr>
+            <a:lstStyle/>
+            <a:p>
+              <a:pPr algn="l"/>
+              <a:r>
+                <a:rPr lang="en-US" sz="1280" b="1" dirty="0">
+                  <a:solidFill>
+                    <a:schemeClr val="accent1"/>
+                  </a:solidFill>
+                  <a:latin typeface="+mn-lt"/>
+                  <a:ea typeface="+mn-ea"/>
+                  <a:cs typeface="+mn-cs"/>
+                </a:rPr>
+                <a:t>PILOT MODEL GRID · CPU</a:t>
               </a:r>
             </a:p>
           </p:txBody>
@@ -14627,26 +15067,26 @@
           </p:nvSpPr>
           <p:spPr>
             <a:xfrm>
-              <a:off x="6278792" y="5062061"/>
-              <a:ext cx="892771" cy="337376"/>
-            </a:xfrm>
-            <a:prstGeom prst="rect">
-              <a:avLst/>
-            </a:prstGeom>
-            <a:noFill/>
-            <a:ln>
-              <a:noFill/>
-            </a:ln>
-          </p:spPr>
-          <p:txBody>
-            <a:bodyPr wrap="none" lIns="0" tIns="0" rIns="0" bIns="0" anchor="t" anchorCtr="0">
-              <a:spAutoFit/>
-            </a:bodyPr>
-            <a:lstStyle/>
-            <a:p>
-              <a:pPr algn="r"/>
-              <a:r>
-                <a:rPr lang="en-US" sz="1720" b="1" dirty="0">
+              <a:off x="4402074" y="4637722"/>
+              <a:ext cx="1790631" cy="674751"/>
+            </a:xfrm>
+            <a:prstGeom prst="rect">
+              <a:avLst/>
+            </a:prstGeom>
+            <a:noFill/>
+            <a:ln>
+              <a:noFill/>
+            </a:ln>
+          </p:spPr>
+          <p:txBody>
+            <a:bodyPr wrap="none" lIns="0" tIns="0" rIns="0" bIns="0" anchor="t" anchorCtr="0">
+              <a:spAutoFit/>
+            </a:bodyPr>
+            <a:lstStyle/>
+            <a:p>
+              <a:pPr algn="l"/>
+              <a:r>
+                <a:rPr lang="en-US" sz="3450" b="1" dirty="0">
                   <a:solidFill>
                     <a:schemeClr val="accent1"/>
                   </a:solidFill>
@@ -14667,8 +15107,48 @@
           </p:nvSpPr>
           <p:spPr>
             <a:xfrm>
-              <a:off x="4718304" y="5433060"/>
-              <a:ext cx="2868650" cy="234696"/>
+              <a:off x="4412742" y="5245418"/>
+              <a:ext cx="2754387" cy="264033"/>
+            </a:xfrm>
+            <a:prstGeom prst="rect">
+              <a:avLst/>
+            </a:prstGeom>
+            <a:noFill/>
+            <a:ln>
+              <a:noFill/>
+            </a:ln>
+          </p:spPr>
+          <p:txBody>
+            <a:bodyPr wrap="none" lIns="0" tIns="0" rIns="0" bIns="0" anchor="t" anchorCtr="0">
+              <a:spAutoFit/>
+            </a:bodyPr>
+            <a:lstStyle/>
+            <a:p>
+              <a:pPr algn="l"/>
+              <a:r>
+                <a:rPr lang="en-US" sz="1350" dirty="0">
+                  <a:solidFill>
+                    <a:schemeClr val="accent1"/>
+                  </a:solidFill>
+                  <a:latin typeface="+mn-lt"/>
+                  <a:ea typeface="+mn-ea"/>
+                  <a:cs typeface="+mn-cs"/>
+                </a:rPr>
+                <a:t>Broader validation is tractable</a:t>
+              </a:r>
+            </a:p>
+          </p:txBody>
+        </p:sp>
+        <p:sp>
+          <p:nvSpPr>
+            <p:cNvPr id="28" name="TextBox 28"/>
+            <p:cNvSpPr txBox="1"/>
+            <p:nvPr/>
+          </p:nvSpPr>
+          <p:spPr>
+            <a:xfrm>
+              <a:off x="4413504" y="5509260"/>
+              <a:ext cx="2699243" cy="234696"/>
             </a:xfrm>
             <a:prstGeom prst="rect">
               <a:avLst/>
@@ -14688,27 +15168,27 @@
               <a:r>
                 <a:rPr lang="en-US" sz="1200" dirty="0">
                   <a:solidFill>
-                    <a:srgbClr val="766E62"/>
-                  </a:solidFill>
-                  <a:latin typeface="+mn-lt"/>
-                  <a:ea typeface="+mn-ea"/>
-                  <a:cs typeface="+mn-cs"/>
-                </a:rPr>
-                <a:t>Runtime permits broader validation.</a:t>
-              </a:r>
-            </a:p>
-          </p:txBody>
-        </p:sp>
-        <p:sp>
-          <p:nvSpPr>
-            <p:cNvPr id="28" name="Rectangle 28"/>
+                    <a:schemeClr val="accent1"/>
+                  </a:solidFill>
+                  <a:latin typeface="+mn-lt"/>
+                  <a:ea typeface="+mn-ea"/>
+                  <a:cs typeface="+mn-cs"/>
+                </a:rPr>
+                <a:t>Five folds fit the project window.</a:t>
+              </a:r>
+            </a:p>
+          </p:txBody>
+        </p:sp>
+        <p:sp>
+          <p:nvSpPr>
+            <p:cNvPr id="29" name="Rectangle 29"/>
             <p:cNvSpPr/>
             <p:nvPr/>
           </p:nvSpPr>
           <p:spPr>
             <a:xfrm>
-              <a:off x="7620000" y="4057650"/>
-              <a:ext cx="3962400" cy="1733550"/>
+              <a:off x="7772400" y="4057650"/>
+              <a:ext cx="3810000" cy="1733550"/>
             </a:xfrm>
             <a:prstGeom prst="rect">
               <a:avLst/>
@@ -14723,32 +15203,32 @@
         </p:sp>
         <p:sp>
           <p:nvSpPr>
-            <p:cNvPr id="29" name="TextBox 29"/>
-            <p:cNvSpPr txBox="1"/>
-            <p:nvPr/>
-          </p:nvSpPr>
-          <p:spPr>
-            <a:xfrm>
-              <a:off x="7841742" y="4245292"/>
-              <a:ext cx="1999724" cy="264033"/>
-            </a:xfrm>
-            <a:prstGeom prst="rect">
-              <a:avLst/>
-            </a:prstGeom>
-            <a:noFill/>
-            <a:ln>
-              <a:noFill/>
-            </a:ln>
-          </p:spPr>
-          <p:txBody>
-            <a:bodyPr wrap="none" lIns="0" tIns="0" rIns="0" bIns="0" anchor="t" anchorCtr="0">
-              <a:spAutoFit/>
-            </a:bodyPr>
-            <a:lstStyle/>
-            <a:p>
-              <a:pPr algn="l"/>
-              <a:r>
-                <a:rPr lang="en-US" sz="1350" b="1" dirty="0">
+            <p:cNvPr id="30" name="TextBox 30"/>
+            <p:cNvSpPr txBox="1"/>
+            <p:nvPr/>
+          </p:nvSpPr>
+          <p:spPr>
+            <a:xfrm>
+              <a:off x="7994523" y="4253389"/>
+              <a:ext cx="1895984" cy="249364"/>
+            </a:xfrm>
+            <a:prstGeom prst="rect">
+              <a:avLst/>
+            </a:prstGeom>
+            <a:noFill/>
+            <a:ln>
+              <a:noFill/>
+            </a:ln>
+          </p:spPr>
+          <p:txBody>
+            <a:bodyPr wrap="none" lIns="0" tIns="0" rIns="0" bIns="0" anchor="t" anchorCtr="0">
+              <a:spAutoFit/>
+            </a:bodyPr>
+            <a:lstStyle/>
+            <a:p>
+              <a:pPr algn="l"/>
+              <a:r>
+                <a:rPr lang="en-US" sz="1280" b="1" dirty="0">
                   <a:solidFill>
                     <a:srgbClr val="B9D0C7"/>
                   </a:solidFill>
@@ -14763,13 +15243,13 @@
         </p:sp>
         <p:sp>
           <p:nvSpPr>
-            <p:cNvPr id="30" name="TextBox 30"/>
-            <p:cNvSpPr txBox="1"/>
-            <p:nvPr/>
-          </p:nvSpPr>
-          <p:spPr>
-            <a:xfrm>
-              <a:off x="7837932" y="4583430"/>
+            <p:cNvPr id="31" name="TextBox 31"/>
+            <p:cNvSpPr txBox="1"/>
+            <p:nvPr/>
+          </p:nvSpPr>
+          <p:spPr>
+            <a:xfrm>
+              <a:off x="7990332" y="4583430"/>
               <a:ext cx="2782481" cy="410718"/>
             </a:xfrm>
             <a:prstGeom prst="rect">
@@ -14803,14 +15283,14 @@
         </p:sp>
         <p:sp>
           <p:nvSpPr>
-            <p:cNvPr id="31" name="TextBox 31"/>
-            <p:cNvSpPr txBox="1"/>
-            <p:nvPr/>
-          </p:nvSpPr>
-          <p:spPr>
-            <a:xfrm>
-              <a:off x="7840980" y="4991100"/>
-              <a:ext cx="3510915" cy="569595"/>
+            <p:cNvPr id="32" name="TextBox 32"/>
+            <p:cNvSpPr txBox="1"/>
+            <p:nvPr/>
+          </p:nvSpPr>
+          <p:spPr>
+            <a:xfrm>
+              <a:off x="7993761" y="4999196"/>
+              <a:ext cx="3323717" cy="545402"/>
             </a:xfrm>
             <a:prstGeom prst="rect">
               <a:avLst/>
@@ -14828,11 +15308,11 @@
             <a:p>
               <a:pPr algn="l">
                 <a:lnSpc>
-                  <a:spcPts val="2175"/>
+                  <a:spcPts val="2100"/>
                 </a:lnSpc>
               </a:pPr>
               <a:r>
-                <a:rPr lang="en-US" sz="1500" dirty="0">
+                <a:rPr lang="en-US" sz="1420" dirty="0">
                   <a:solidFill>
                     <a:srgbClr val="FBF7EE"/>
                   </a:solidFill>
@@ -14844,7 +15324,7 @@
               </a:r>
               <a:br/>
               <a:r>
-                <a:rPr lang="en-US" sz="1500" dirty="0">
+                <a:rPr lang="en-US" sz="1420" dirty="0">
                   <a:solidFill>
                     <a:srgbClr val="FBF7EE"/>
                   </a:solidFill>
@@ -14859,34 +15339,34 @@
         </p:sp>
         <p:sp>
           <p:nvSpPr>
-            <p:cNvPr id="32" name="TextBox 32"/>
-            <p:cNvSpPr txBox="1"/>
-            <p:nvPr/>
-          </p:nvSpPr>
-          <p:spPr>
-            <a:xfrm>
-              <a:off x="7841742" y="5493068"/>
-              <a:ext cx="3048175" cy="264033"/>
-            </a:xfrm>
-            <a:prstGeom prst="rect">
-              <a:avLst/>
-            </a:prstGeom>
-            <a:noFill/>
-            <a:ln>
-              <a:noFill/>
-            </a:ln>
-          </p:spPr>
-          <p:txBody>
-            <a:bodyPr wrap="none" lIns="0" tIns="0" rIns="0" bIns="0" anchor="t" anchorCtr="0">
-              <a:spAutoFit/>
-            </a:bodyPr>
-            <a:lstStyle/>
-            <a:p>
-              <a:pPr algn="l"/>
-              <a:r>
-                <a:rPr lang="en-US" sz="1350" b="1" dirty="0">
-                  <a:solidFill>
-                    <a:schemeClr val="accent2"/>
+            <p:cNvPr id="33" name="TextBox 33"/>
+            <p:cNvSpPr txBox="1"/>
+            <p:nvPr/>
+          </p:nvSpPr>
+          <p:spPr>
+            <a:xfrm>
+              <a:off x="7994523" y="5501164"/>
+              <a:ext cx="2890071" cy="249364"/>
+            </a:xfrm>
+            <a:prstGeom prst="rect">
+              <a:avLst/>
+            </a:prstGeom>
+            <a:noFill/>
+            <a:ln>
+              <a:noFill/>
+            </a:ln>
+          </p:spPr>
+          <p:txBody>
+            <a:bodyPr wrap="none" lIns="0" tIns="0" rIns="0" bIns="0" anchor="t" anchorCtr="0">
+              <a:spAutoFit/>
+            </a:bodyPr>
+            <a:lstStyle/>
+            <a:p>
+              <a:pPr algn="l"/>
+              <a:r>
+                <a:rPr lang="en-US" sz="1280" b="1" dirty="0">
+                  <a:solidFill>
+                    <a:srgbClr val="F18B6C"/>
                   </a:solidFill>
                   <a:latin typeface="+mn-lt"/>
                   <a:ea typeface="+mn-ea"/>
@@ -14900,7 +15380,7 @@
       </p:grpSp>
       <p:grpSp>
         <p:nvGrpSpPr>
-          <p:cNvPr id="35" name="Group 35"/>
+          <p:cNvPr id="36" name="Group 36"/>
           <p:cNvGrpSpPr/>
           <p:nvPr/>
         </p:nvGrpSpPr>
@@ -14914,7 +15394,7 @@
         </p:grpSpPr>
         <p:sp>
           <p:nvSpPr>
-            <p:cNvPr id="34" name="TextBox 34"/>
+            <p:cNvPr id="35" name="TextBox 35"/>
             <p:cNvSpPr txBox="1"/>
             <p:nvPr/>
           </p:nvSpPr>
@@ -14955,7 +15435,7 @@
       </p:grpSp>
       <p:grpSp>
         <p:nvGrpSpPr>
-          <p:cNvPr id="37" name="Group 37"/>
+          <p:cNvPr id="38" name="Group 38"/>
           <p:cNvGrpSpPr/>
           <p:nvPr/>
         </p:nvGrpSpPr>
@@ -14969,7 +15449,7 @@
         </p:grpSpPr>
         <p:sp>
           <p:nvSpPr>
-            <p:cNvPr id="36" name="TextBox 36"/>
+            <p:cNvPr id="37" name="TextBox 37"/>
             <p:cNvSpPr txBox="1"/>
             <p:nvPr/>
           </p:nvSpPr>
@@ -15048,10 +15528,10 @@
         <a:srgbClr val="1C2D38"/>
       </a:accent4>
       <a:accent5>
-        <a:srgbClr val="4BACC6"/>
+        <a:srgbClr val="9B2D17"/>
       </a:accent5>
       <a:accent6>
-        <a:srgbClr val="F79646"/>
+        <a:srgbClr val="1B5756"/>
       </a:accent6>
       <a:hlink>
         <a:srgbClr val="D84924"/>
@@ -15368,10 +15848,10 @@
         <a:srgbClr val="1C2D38"/>
       </a:accent4>
       <a:accent5>
-        <a:srgbClr val="4BACC6"/>
+        <a:srgbClr val="9B2D17"/>
       </a:accent5>
       <a:accent6>
-        <a:srgbClr val="F79646"/>
+        <a:srgbClr val="1B5756"/>
       </a:accent6>
       <a:hlink>
         <a:srgbClr val="D84924"/>

</xml_diff>